<commit_message>
Update configuration and documentation for face recognition and YOLO training
- Reduced face match threshold in app/config.py from 0.2 to 0.1 for improved accuracy in face recognition.
- Adjusted formatting in train_yolo11n.yaml to ensure consistency.
- Updated table of contents in Thesis_YOLO11_TOC.docx for better organization and clarity.
</commit_message>
<xml_diff>
--- a/docs/thesis/Defense_Presentation_YOLO11.pptx
+++ b/docs/thesis/Defense_Presentation_YOLO11.pptx
@@ -4570,15 +4570,52 @@
           <a:p>
             <a:pPr algn="ctr" rtl="1"/>
             <a:r>
-              <a:rPr sz="1100" b="0">
+              <a:rPr sz="1100" dirty="0" err="1">
                 <a:solidFill>
                   <a:srgbClr val="5A6A7A"/>
                 </a:solidFill>
                 <a:latin typeface="Vazir" panose="020B0603030804020204" pitchFamily="34" charset="-78"/>
                 <a:cs typeface="Vazir" panose="020B0603030804020204" pitchFamily="34" charset="-78"/>
               </a:rPr>
-              <a:t>شروع ← پایان</a:t>
-            </a:r>
+              <a:t>شروع</a:t>
+            </a:r>
+            <a:r>
+              <a:rPr sz="1100" dirty="0">
+                <a:solidFill>
+                  <a:srgbClr val="5A6A7A"/>
+                </a:solidFill>
+                <a:latin typeface="Vazir" panose="020B0603030804020204" pitchFamily="34" charset="-78"/>
+                <a:cs typeface="Vazir" panose="020B0603030804020204" pitchFamily="34" charset="-78"/>
+              </a:rPr>
+              <a:t> ← </a:t>
+            </a:r>
+            <a:r>
+              <a:rPr lang="fa-IR" sz="1100" dirty="0">
+                <a:solidFill>
+                  <a:srgbClr val="5A6A7A"/>
+                </a:solidFill>
+                <a:latin typeface="Vazir" panose="020B0603030804020204" pitchFamily="34" charset="-78"/>
+                <a:cs typeface="Vazir" panose="020B0603030804020204" pitchFamily="34" charset="-78"/>
+              </a:rPr>
+              <a:t> </a:t>
+            </a:r>
+            <a:r>
+              <a:rPr sz="1100" dirty="0" err="1">
+                <a:solidFill>
+                  <a:srgbClr val="5A6A7A"/>
+                </a:solidFill>
+                <a:latin typeface="Vazir" panose="020B0603030804020204" pitchFamily="34" charset="-78"/>
+                <a:cs typeface="Vazir" panose="020B0603030804020204" pitchFamily="34" charset="-78"/>
+              </a:rPr>
+              <a:t>پایان</a:t>
+            </a:r>
+            <a:endParaRPr sz="1100" dirty="0">
+              <a:solidFill>
+                <a:srgbClr val="5A6A7A"/>
+              </a:solidFill>
+              <a:latin typeface="Vazir" panose="020B0603030804020204" pitchFamily="34" charset="-78"/>
+              <a:cs typeface="Vazir" panose="020B0603030804020204" pitchFamily="34" charset="-78"/>
+            </a:endParaRPr>
           </a:p>
         </p:txBody>
       </p:sp>
@@ -4774,7 +4811,7 @@
           <a:bodyPr wrap="square" anchor="t"/>
           <a:lstStyle/>
           <a:p>
-            <a:pPr algn="ctr"/>
+            <a:pPr algn="ctr" rtl="1"/>
             <a:r>
               <a:rPr sz="1400" b="1" dirty="0">
                 <a:solidFill>
@@ -4783,8 +4820,65 @@
                 <a:latin typeface="Vazir" panose="020B0603030804020204" pitchFamily="34" charset="-78"/>
                 <a:cs typeface="Vazir" panose="020B0603030804020204" pitchFamily="34" charset="-78"/>
               </a:rPr>
-              <a:t>mAP50: ۰٫۴۵۶ ← ۰٫۵۸۵</a:t>
-            </a:r>
+              <a:t>mAP50</a:t>
+            </a:r>
+            <a:r>
+              <a:rPr lang="fa-IR" sz="1400" b="1" dirty="0">
+                <a:solidFill>
+                  <a:srgbClr val="0B1F3A"/>
+                </a:solidFill>
+                <a:latin typeface="Vazir" panose="020B0603030804020204" pitchFamily="34" charset="-78"/>
+                <a:cs typeface="Vazir" panose="020B0603030804020204" pitchFamily="34" charset="-78"/>
+              </a:rPr>
+              <a:t> :	</a:t>
+            </a:r>
+            <a:r>
+              <a:rPr sz="1400" b="1" dirty="0">
+                <a:solidFill>
+                  <a:srgbClr val="0B1F3A"/>
+                </a:solidFill>
+                <a:latin typeface="Vazir" panose="020B0603030804020204" pitchFamily="34" charset="-78"/>
+                <a:cs typeface="Vazir" panose="020B0603030804020204" pitchFamily="34" charset="-78"/>
+              </a:rPr>
+              <a:t> </a:t>
+            </a:r>
+            <a:r>
+              <a:rPr lang="fa-IR" sz="1400" b="1" dirty="0">
+                <a:solidFill>
+                  <a:srgbClr val="0B1F3A"/>
+                </a:solidFill>
+                <a:latin typeface="Vazir" panose="020B0603030804020204" pitchFamily="34" charset="-78"/>
+                <a:cs typeface="Vazir" panose="020B0603030804020204" pitchFamily="34" charset="-78"/>
+              </a:rPr>
+              <a:t>0.456</a:t>
+            </a:r>
+            <a:r>
+              <a:rPr sz="1400" b="1" dirty="0">
+                <a:solidFill>
+                  <a:srgbClr val="0B1F3A"/>
+                </a:solidFill>
+                <a:latin typeface="Vazir" panose="020B0603030804020204" pitchFamily="34" charset="-78"/>
+                <a:cs typeface="Vazir" panose="020B0603030804020204" pitchFamily="34" charset="-78"/>
+              </a:rPr>
+              <a:t> ← </a:t>
+            </a:r>
+            <a:r>
+              <a:rPr lang="fa-IR" sz="1400" b="1" dirty="0">
+                <a:solidFill>
+                  <a:srgbClr val="0B1F3A"/>
+                </a:solidFill>
+                <a:latin typeface="Vazir" panose="020B0603030804020204" pitchFamily="34" charset="-78"/>
+                <a:cs typeface="Vazir" panose="020B0603030804020204" pitchFamily="34" charset="-78"/>
+              </a:rPr>
+              <a:t>0.585</a:t>
+            </a:r>
+            <a:endParaRPr sz="1400" b="1" dirty="0">
+              <a:solidFill>
+                <a:srgbClr val="0B1F3A"/>
+              </a:solidFill>
+              <a:latin typeface="Vazir" panose="020B0603030804020204" pitchFamily="34" charset="-78"/>
+              <a:cs typeface="Vazir" panose="020B0603030804020204" pitchFamily="34" charset="-78"/>
+            </a:endParaRPr>
           </a:p>
         </p:txBody>
       </p:sp>
@@ -4854,7 +4948,7 @@
           <a:bodyPr wrap="square" anchor="t"/>
           <a:lstStyle/>
           <a:p>
-            <a:pPr algn="ctr"/>
+            <a:pPr algn="ctr" rtl="1"/>
             <a:r>
               <a:rPr sz="1400" b="1" dirty="0">
                 <a:solidFill>
@@ -4863,8 +4957,65 @@
                 <a:latin typeface="Vazir" panose="020B0603030804020204" pitchFamily="34" charset="-78"/>
                 <a:cs typeface="Vazir" panose="020B0603030804020204" pitchFamily="34" charset="-78"/>
               </a:rPr>
-              <a:t>mAP50-95: ۰٫۲۲۵ ← ۰٫۳۳۴</a:t>
-            </a:r>
+              <a:t>mAP50-95</a:t>
+            </a:r>
+            <a:r>
+              <a:rPr lang="fa-IR" sz="1400" b="1" dirty="0">
+                <a:solidFill>
+                  <a:srgbClr val="0B1F3A"/>
+                </a:solidFill>
+                <a:latin typeface="Vazir" panose="020B0603030804020204" pitchFamily="34" charset="-78"/>
+                <a:cs typeface="Vazir" panose="020B0603030804020204" pitchFamily="34" charset="-78"/>
+              </a:rPr>
+              <a:t> :	</a:t>
+            </a:r>
+            <a:r>
+              <a:rPr sz="1400" b="1" dirty="0">
+                <a:solidFill>
+                  <a:srgbClr val="0B1F3A"/>
+                </a:solidFill>
+                <a:latin typeface="Vazir" panose="020B0603030804020204" pitchFamily="34" charset="-78"/>
+                <a:cs typeface="Vazir" panose="020B0603030804020204" pitchFamily="34" charset="-78"/>
+              </a:rPr>
+              <a:t> </a:t>
+            </a:r>
+            <a:r>
+              <a:rPr lang="fa-IR" sz="1400" b="1" dirty="0">
+                <a:solidFill>
+                  <a:srgbClr val="0B1F3A"/>
+                </a:solidFill>
+                <a:latin typeface="Vazir" panose="020B0603030804020204" pitchFamily="34" charset="-78"/>
+                <a:cs typeface="Vazir" panose="020B0603030804020204" pitchFamily="34" charset="-78"/>
+              </a:rPr>
+              <a:t>0.225</a:t>
+            </a:r>
+            <a:r>
+              <a:rPr sz="1400" b="1" dirty="0">
+                <a:solidFill>
+                  <a:srgbClr val="0B1F3A"/>
+                </a:solidFill>
+                <a:latin typeface="Vazir" panose="020B0603030804020204" pitchFamily="34" charset="-78"/>
+                <a:cs typeface="Vazir" panose="020B0603030804020204" pitchFamily="34" charset="-78"/>
+              </a:rPr>
+              <a:t> ← </a:t>
+            </a:r>
+            <a:r>
+              <a:rPr lang="fa-IR" sz="1400" b="1" dirty="0">
+                <a:solidFill>
+                  <a:srgbClr val="0B1F3A"/>
+                </a:solidFill>
+                <a:latin typeface="Vazir" panose="020B0603030804020204" pitchFamily="34" charset="-78"/>
+                <a:cs typeface="Vazir" panose="020B0603030804020204" pitchFamily="34" charset="-78"/>
+              </a:rPr>
+              <a:t>0.334</a:t>
+            </a:r>
+            <a:endParaRPr sz="1400" b="1" dirty="0">
+              <a:solidFill>
+                <a:srgbClr val="0B1F3A"/>
+              </a:solidFill>
+              <a:latin typeface="Vazir" panose="020B0603030804020204" pitchFamily="34" charset="-78"/>
+              <a:cs typeface="Vazir" panose="020B0603030804020204" pitchFamily="34" charset="-78"/>
+            </a:endParaRPr>
           </a:p>
         </p:txBody>
       </p:sp>
@@ -4936,15 +5087,45 @@
           <a:p>
             <a:pPr algn="ctr"/>
             <a:r>
-              <a:rPr sz="1400" b="1">
+              <a:rPr sz="1400" b="1" dirty="0">
                 <a:solidFill>
                   <a:srgbClr val="0B1F3A"/>
                 </a:solidFill>
                 <a:latin typeface="Vazir" panose="020B0603030804020204" pitchFamily="34" charset="-78"/>
                 <a:cs typeface="Vazir" panose="020B0603030804020204" pitchFamily="34" charset="-78"/>
               </a:rPr>
-              <a:t>Precision ≈ ۰٫۷۳۹</a:t>
-            </a:r>
+              <a:t>Precision </a:t>
+            </a:r>
+            <a:r>
+              <a:rPr lang="en-US" sz="1400" b="1" dirty="0">
+                <a:solidFill>
+                  <a:srgbClr val="0B1F3A"/>
+                </a:solidFill>
+                <a:latin typeface="Vazir" panose="020B0603030804020204" pitchFamily="34" charset="-78"/>
+                <a:cs typeface="Vazir" panose="020B0603030804020204" pitchFamily="34" charset="-78"/>
+              </a:rPr>
+              <a:t>≈</a:t>
+            </a:r>
+            <a:r>
+              <a:rPr lang="fa-IR" sz="1400" b="1" dirty="0">
+                <a:solidFill>
+                  <a:srgbClr val="0B1F3A"/>
+                </a:solidFill>
+                <a:latin typeface="Vazir" panose="020B0603030804020204" pitchFamily="34" charset="-78"/>
+                <a:cs typeface="Vazir" panose="020B0603030804020204" pitchFamily="34" charset="-78"/>
+              </a:rPr>
+              <a:t>  0.739 </a:t>
+            </a:r>
+          </a:p>
+          <a:p>
+            <a:pPr algn="ctr"/>
+            <a:endParaRPr sz="1400" b="1" dirty="0">
+              <a:solidFill>
+                <a:srgbClr val="0B1F3A"/>
+              </a:solidFill>
+              <a:latin typeface="Vazir" panose="020B0603030804020204" pitchFamily="34" charset="-78"/>
+              <a:cs typeface="Vazir" panose="020B0603030804020204" pitchFamily="34" charset="-78"/>
+            </a:endParaRPr>
           </a:p>
         </p:txBody>
       </p:sp>
@@ -5016,15 +5197,32 @@
           <a:p>
             <a:pPr algn="ctr"/>
             <a:r>
-              <a:rPr sz="1400" b="1">
+              <a:rPr sz="1400" b="1" dirty="0">
                 <a:solidFill>
                   <a:srgbClr val="0B1F3A"/>
                 </a:solidFill>
                 <a:latin typeface="Vazir" panose="020B0603030804020204" pitchFamily="34" charset="-78"/>
                 <a:cs typeface="Vazir" panose="020B0603030804020204" pitchFamily="34" charset="-78"/>
               </a:rPr>
-              <a:t>Recall ≈ ۰٫۵۰۴</a:t>
-            </a:r>
+              <a:t>Recall ≈ </a:t>
+            </a:r>
+            <a:r>
+              <a:rPr lang="fa-IR" sz="1400" b="1" dirty="0">
+                <a:solidFill>
+                  <a:srgbClr val="0B1F3A"/>
+                </a:solidFill>
+                <a:latin typeface="Vazir" panose="020B0603030804020204" pitchFamily="34" charset="-78"/>
+                <a:cs typeface="Vazir" panose="020B0603030804020204" pitchFamily="34" charset="-78"/>
+              </a:rPr>
+              <a:t>0.504</a:t>
+            </a:r>
+            <a:endParaRPr sz="1400" b="1" dirty="0">
+              <a:solidFill>
+                <a:srgbClr val="0B1F3A"/>
+              </a:solidFill>
+              <a:latin typeface="Vazir" panose="020B0603030804020204" pitchFamily="34" charset="-78"/>
+              <a:cs typeface="Vazir" panose="020B0603030804020204" pitchFamily="34" charset="-78"/>
+            </a:endParaRPr>
           </a:p>
         </p:txBody>
       </p:sp>
@@ -5094,17 +5292,64 @@
           <a:bodyPr wrap="square" anchor="t"/>
           <a:lstStyle/>
           <a:p>
-            <a:pPr algn="ctr"/>
-            <a:r>
-              <a:rPr sz="1400" b="1">
+            <a:pPr algn="ctr" rtl="1"/>
+            <a:r>
+              <a:rPr sz="1400" b="1" dirty="0" err="1">
                 <a:solidFill>
                   <a:srgbClr val="0B1F3A"/>
                 </a:solidFill>
                 <a:latin typeface="Vazir" panose="020B0603030804020204" pitchFamily="34" charset="-78"/>
                 <a:cs typeface="Vazir" panose="020B0603030804020204" pitchFamily="34" charset="-78"/>
               </a:rPr>
-              <a:t>زمان آموزش ≈ ۱۷٫۳ دقیقه</a:t>
-            </a:r>
+              <a:t>زمان</a:t>
+            </a:r>
+            <a:r>
+              <a:rPr sz="1400" b="1" dirty="0">
+                <a:solidFill>
+                  <a:srgbClr val="0B1F3A"/>
+                </a:solidFill>
+                <a:latin typeface="Vazir" panose="020B0603030804020204" pitchFamily="34" charset="-78"/>
+                <a:cs typeface="Vazir" panose="020B0603030804020204" pitchFamily="34" charset="-78"/>
+              </a:rPr>
+              <a:t> </a:t>
+            </a:r>
+            <a:r>
+              <a:rPr sz="1400" b="1" dirty="0" err="1">
+                <a:solidFill>
+                  <a:srgbClr val="0B1F3A"/>
+                </a:solidFill>
+                <a:latin typeface="Vazir" panose="020B0603030804020204" pitchFamily="34" charset="-78"/>
+                <a:cs typeface="Vazir" panose="020B0603030804020204" pitchFamily="34" charset="-78"/>
+              </a:rPr>
+              <a:t>آموزش</a:t>
+            </a:r>
+            <a:r>
+              <a:rPr sz="1400" b="1" dirty="0">
+                <a:solidFill>
+                  <a:srgbClr val="0B1F3A"/>
+                </a:solidFill>
+                <a:latin typeface="Vazir" panose="020B0603030804020204" pitchFamily="34" charset="-78"/>
+                <a:cs typeface="Vazir" panose="020B0603030804020204" pitchFamily="34" charset="-78"/>
+              </a:rPr>
+              <a:t> ≈ ۱۷٫۳ </a:t>
+            </a:r>
+            <a:r>
+              <a:rPr sz="1400" b="1" dirty="0" err="1">
+                <a:solidFill>
+                  <a:srgbClr val="0B1F3A"/>
+                </a:solidFill>
+                <a:latin typeface="Vazir" panose="020B0603030804020204" pitchFamily="34" charset="-78"/>
+                <a:cs typeface="Vazir" panose="020B0603030804020204" pitchFamily="34" charset="-78"/>
+              </a:rPr>
+              <a:t>دقیقه</a:t>
+            </a:r>
+            <a:endParaRPr sz="1400" b="1" dirty="0">
+              <a:solidFill>
+                <a:srgbClr val="0B1F3A"/>
+              </a:solidFill>
+              <a:latin typeface="Vazir" panose="020B0603030804020204" pitchFamily="34" charset="-78"/>
+              <a:cs typeface="Vazir" panose="020B0603030804020204" pitchFamily="34" charset="-78"/>
+            </a:endParaRPr>
           </a:p>
         </p:txBody>
       </p:sp>
@@ -6092,7 +6337,7 @@
               <a:t> Precision </a:t>
             </a:r>
             <a:r>
-              <a:rPr lang="fa-IR" sz="1100" b="0">
+              <a:rPr lang="fa-IR" sz="1100" b="0" dirty="0">
                 <a:solidFill>
                   <a:srgbClr val="5A6A7A"/>
                 </a:solidFill>
@@ -6102,7 +6347,7 @@
               <a:t> </a:t>
             </a:r>
             <a:r>
-              <a:rPr sz="1100" b="0">
+              <a:rPr sz="1100" b="0" dirty="0">
                 <a:solidFill>
                   <a:srgbClr val="5A6A7A"/>
                 </a:solidFill>
@@ -8764,72 +9009,521 @@
           </a:bodyPr>
           <a:lstStyle/>
           <a:p>
-            <a:pPr algn="r" rtl="1">
+            <a:pPr marL="285750" indent="-285750" algn="r" rtl="1">
               <a:spcAft>
                 <a:spcPts val="1200"/>
               </a:spcAft>
+              <a:buFont typeface="Arial" panose="020B0604020202020204" pitchFamily="34" charset="0"/>
+              <a:buChar char="•"/>
             </a:pPr>
             <a:r>
-              <a:rPr sz="1300" b="0">
-                <a:solidFill>
-                  <a:srgbClr val="1C2430"/>
-                </a:solidFill>
-                <a:latin typeface="Vazir" panose="020B0603030804020204" pitchFamily="34" charset="-78"/>
-                <a:cs typeface="Vazir" panose="020B0603030804020204" pitchFamily="34" charset="-78"/>
-              </a:rPr>
-              <a:t>• تشخیص کلاس person روی تصویر نمونه</a:t>
-            </a:r>
-          </a:p>
-          <a:p>
-            <a:pPr algn="r" rtl="1">
+              <a:rPr sz="1300" b="0" dirty="0" err="1">
+                <a:solidFill>
+                  <a:srgbClr val="1C2430"/>
+                </a:solidFill>
+                <a:latin typeface="Vazir" panose="020B0603030804020204" pitchFamily="34" charset="-78"/>
+                <a:cs typeface="Vazir" panose="020B0603030804020204" pitchFamily="34" charset="-78"/>
+              </a:rPr>
+              <a:t>تشخیص</a:t>
+            </a:r>
+            <a:r>
+              <a:rPr sz="1300" b="0" dirty="0">
+                <a:solidFill>
+                  <a:srgbClr val="1C2430"/>
+                </a:solidFill>
+                <a:latin typeface="Vazir" panose="020B0603030804020204" pitchFamily="34" charset="-78"/>
+                <a:cs typeface="Vazir" panose="020B0603030804020204" pitchFamily="34" charset="-78"/>
+              </a:rPr>
+              <a:t> </a:t>
+            </a:r>
+            <a:r>
+              <a:rPr sz="1300" b="0" dirty="0" err="1">
+                <a:solidFill>
+                  <a:srgbClr val="1C2430"/>
+                </a:solidFill>
+                <a:latin typeface="Vazir" panose="020B0603030804020204" pitchFamily="34" charset="-78"/>
+                <a:cs typeface="Vazir" panose="020B0603030804020204" pitchFamily="34" charset="-78"/>
+              </a:rPr>
+              <a:t>کلاس</a:t>
+            </a:r>
+            <a:r>
+              <a:rPr sz="1300" b="0" dirty="0">
+                <a:solidFill>
+                  <a:srgbClr val="1C2430"/>
+                </a:solidFill>
+                <a:latin typeface="Vazir" panose="020B0603030804020204" pitchFamily="34" charset="-78"/>
+                <a:cs typeface="Vazir" panose="020B0603030804020204" pitchFamily="34" charset="-78"/>
+              </a:rPr>
+              <a:t> person </a:t>
+            </a:r>
+            <a:r>
+              <a:rPr lang="fa-IR" sz="1300" b="0" dirty="0">
+                <a:solidFill>
+                  <a:srgbClr val="1C2430"/>
+                </a:solidFill>
+                <a:latin typeface="Vazir" panose="020B0603030804020204" pitchFamily="34" charset="-78"/>
+                <a:cs typeface="Vazir" panose="020B0603030804020204" pitchFamily="34" charset="-78"/>
+              </a:rPr>
+              <a:t> </a:t>
+            </a:r>
+            <a:r>
+              <a:rPr sz="1300" b="0" dirty="0" err="1">
+                <a:solidFill>
+                  <a:srgbClr val="1C2430"/>
+                </a:solidFill>
+                <a:latin typeface="Vazir" panose="020B0603030804020204" pitchFamily="34" charset="-78"/>
+                <a:cs typeface="Vazir" panose="020B0603030804020204" pitchFamily="34" charset="-78"/>
+              </a:rPr>
+              <a:t>روی</a:t>
+            </a:r>
+            <a:r>
+              <a:rPr sz="1300" b="0" dirty="0">
+                <a:solidFill>
+                  <a:srgbClr val="1C2430"/>
+                </a:solidFill>
+                <a:latin typeface="Vazir" panose="020B0603030804020204" pitchFamily="34" charset="-78"/>
+                <a:cs typeface="Vazir" panose="020B0603030804020204" pitchFamily="34" charset="-78"/>
+              </a:rPr>
+              <a:t> </a:t>
+            </a:r>
+            <a:r>
+              <a:rPr sz="1300" b="0" dirty="0" err="1">
+                <a:solidFill>
+                  <a:srgbClr val="1C2430"/>
+                </a:solidFill>
+                <a:latin typeface="Vazir" panose="020B0603030804020204" pitchFamily="34" charset="-78"/>
+                <a:cs typeface="Vazir" panose="020B0603030804020204" pitchFamily="34" charset="-78"/>
+              </a:rPr>
+              <a:t>تصویر</a:t>
+            </a:r>
+            <a:r>
+              <a:rPr sz="1300" b="0" dirty="0">
+                <a:solidFill>
+                  <a:srgbClr val="1C2430"/>
+                </a:solidFill>
+                <a:latin typeface="Vazir" panose="020B0603030804020204" pitchFamily="34" charset="-78"/>
+                <a:cs typeface="Vazir" panose="020B0603030804020204" pitchFamily="34" charset="-78"/>
+              </a:rPr>
+              <a:t> </a:t>
+            </a:r>
+            <a:r>
+              <a:rPr sz="1300" b="0" dirty="0" err="1">
+                <a:solidFill>
+                  <a:srgbClr val="1C2430"/>
+                </a:solidFill>
+                <a:latin typeface="Vazir" panose="020B0603030804020204" pitchFamily="34" charset="-78"/>
+                <a:cs typeface="Vazir" panose="020B0603030804020204" pitchFamily="34" charset="-78"/>
+              </a:rPr>
+              <a:t>نمونه</a:t>
+            </a:r>
+            <a:endParaRPr sz="1300" b="0" dirty="0">
+              <a:solidFill>
+                <a:srgbClr val="1C2430"/>
+              </a:solidFill>
+              <a:latin typeface="Vazir" panose="020B0603030804020204" pitchFamily="34" charset="-78"/>
+              <a:cs typeface="Vazir" panose="020B0603030804020204" pitchFamily="34" charset="-78"/>
+            </a:endParaRPr>
+          </a:p>
+          <a:p>
+            <a:pPr marL="285750" indent="-285750" algn="r" rtl="1">
               <a:spcAft>
                 <a:spcPts val="1200"/>
               </a:spcAft>
+              <a:buFont typeface="Arial" panose="020B0604020202020204" pitchFamily="34" charset="0"/>
+              <a:buChar char="•"/>
             </a:pPr>
             <a:r>
-              <a:rPr sz="1300" b="0">
-                <a:solidFill>
-                  <a:srgbClr val="1C2430"/>
-                </a:solidFill>
-                <a:latin typeface="Vazir" panose="020B0603030804020204" pitchFamily="34" charset="-78"/>
-                <a:cs typeface="Vazir" panose="020B0603030804020204" pitchFamily="34" charset="-78"/>
-              </a:rPr>
-              <a:t>• خروجی با وزن best.pt پس از fine-tune</a:t>
-            </a:r>
-          </a:p>
-          <a:p>
-            <a:pPr algn="r" rtl="1">
+              <a:rPr sz="1300" b="0" dirty="0" err="1">
+                <a:solidFill>
+                  <a:srgbClr val="1C2430"/>
+                </a:solidFill>
+                <a:latin typeface="Vazir" panose="020B0603030804020204" pitchFamily="34" charset="-78"/>
+                <a:cs typeface="Vazir" panose="020B0603030804020204" pitchFamily="34" charset="-78"/>
+              </a:rPr>
+              <a:t>خروجی</a:t>
+            </a:r>
+            <a:r>
+              <a:rPr sz="1300" b="0" dirty="0">
+                <a:solidFill>
+                  <a:srgbClr val="1C2430"/>
+                </a:solidFill>
+                <a:latin typeface="Vazir" panose="020B0603030804020204" pitchFamily="34" charset="-78"/>
+                <a:cs typeface="Vazir" panose="020B0603030804020204" pitchFamily="34" charset="-78"/>
+              </a:rPr>
+              <a:t> </a:t>
+            </a:r>
+            <a:r>
+              <a:rPr sz="1300" b="0" dirty="0" err="1">
+                <a:solidFill>
+                  <a:srgbClr val="1C2430"/>
+                </a:solidFill>
+                <a:latin typeface="Vazir" panose="020B0603030804020204" pitchFamily="34" charset="-78"/>
+                <a:cs typeface="Vazir" panose="020B0603030804020204" pitchFamily="34" charset="-78"/>
+              </a:rPr>
+              <a:t>با</a:t>
+            </a:r>
+            <a:r>
+              <a:rPr sz="1300" b="0" dirty="0">
+                <a:solidFill>
+                  <a:srgbClr val="1C2430"/>
+                </a:solidFill>
+                <a:latin typeface="Vazir" panose="020B0603030804020204" pitchFamily="34" charset="-78"/>
+                <a:cs typeface="Vazir" panose="020B0603030804020204" pitchFamily="34" charset="-78"/>
+              </a:rPr>
+              <a:t> </a:t>
+            </a:r>
+            <a:r>
+              <a:rPr sz="1300" b="0" dirty="0" err="1">
+                <a:solidFill>
+                  <a:srgbClr val="1C2430"/>
+                </a:solidFill>
+                <a:latin typeface="Vazir" panose="020B0603030804020204" pitchFamily="34" charset="-78"/>
+                <a:cs typeface="Vazir" panose="020B0603030804020204" pitchFamily="34" charset="-78"/>
+              </a:rPr>
+              <a:t>وزن</a:t>
+            </a:r>
+            <a:r>
+              <a:rPr sz="1300" b="0" dirty="0">
+                <a:solidFill>
+                  <a:srgbClr val="1C2430"/>
+                </a:solidFill>
+                <a:latin typeface="Vazir" panose="020B0603030804020204" pitchFamily="34" charset="-78"/>
+                <a:cs typeface="Vazir" panose="020B0603030804020204" pitchFamily="34" charset="-78"/>
+              </a:rPr>
+              <a:t> best.pt </a:t>
+            </a:r>
+            <a:r>
+              <a:rPr lang="fa-IR" sz="1300" b="0" dirty="0">
+                <a:solidFill>
+                  <a:srgbClr val="1C2430"/>
+                </a:solidFill>
+                <a:latin typeface="Vazir" panose="020B0603030804020204" pitchFamily="34" charset="-78"/>
+                <a:cs typeface="Vazir" panose="020B0603030804020204" pitchFamily="34" charset="-78"/>
+              </a:rPr>
+              <a:t> </a:t>
+            </a:r>
+            <a:r>
+              <a:rPr sz="1300" b="0" dirty="0" err="1">
+                <a:solidFill>
+                  <a:srgbClr val="1C2430"/>
+                </a:solidFill>
+                <a:latin typeface="Vazir" panose="020B0603030804020204" pitchFamily="34" charset="-78"/>
+                <a:cs typeface="Vazir" panose="020B0603030804020204" pitchFamily="34" charset="-78"/>
+              </a:rPr>
+              <a:t>پس</a:t>
+            </a:r>
+            <a:r>
+              <a:rPr sz="1300" b="0" dirty="0">
+                <a:solidFill>
+                  <a:srgbClr val="1C2430"/>
+                </a:solidFill>
+                <a:latin typeface="Vazir" panose="020B0603030804020204" pitchFamily="34" charset="-78"/>
+                <a:cs typeface="Vazir" panose="020B0603030804020204" pitchFamily="34" charset="-78"/>
+              </a:rPr>
+              <a:t> </a:t>
+            </a:r>
+            <a:r>
+              <a:rPr sz="1300" b="0" dirty="0" err="1">
+                <a:solidFill>
+                  <a:srgbClr val="1C2430"/>
+                </a:solidFill>
+                <a:latin typeface="Vazir" panose="020B0603030804020204" pitchFamily="34" charset="-78"/>
+                <a:cs typeface="Vazir" panose="020B0603030804020204" pitchFamily="34" charset="-78"/>
+              </a:rPr>
+              <a:t>از</a:t>
+            </a:r>
+            <a:r>
+              <a:rPr sz="1300" b="0" dirty="0">
+                <a:solidFill>
+                  <a:srgbClr val="1C2430"/>
+                </a:solidFill>
+                <a:latin typeface="Vazir" panose="020B0603030804020204" pitchFamily="34" charset="-78"/>
+                <a:cs typeface="Vazir" panose="020B0603030804020204" pitchFamily="34" charset="-78"/>
+              </a:rPr>
+              <a:t> fine-tune</a:t>
+            </a:r>
+          </a:p>
+          <a:p>
+            <a:pPr marL="285750" indent="-285750" algn="r" rtl="1">
               <a:spcAft>
                 <a:spcPts val="1200"/>
               </a:spcAft>
+              <a:buFont typeface="Arial" panose="020B0604020202020204" pitchFamily="34" charset="0"/>
+              <a:buChar char="•"/>
             </a:pPr>
             <a:r>
-              <a:rPr sz="1300" b="0">
-                <a:solidFill>
-                  <a:srgbClr val="1C2430"/>
-                </a:solidFill>
-                <a:latin typeface="Vazir" panose="020B0603030804020204" pitchFamily="34" charset="-78"/>
-                <a:cs typeface="Vazir" panose="020B0603030804020204" pitchFamily="34" charset="-78"/>
-              </a:rPr>
-              <a:t>• مناسب نمایش کیفی به داوران</a:t>
-            </a:r>
-          </a:p>
-          <a:p>
-            <a:pPr algn="r" rtl="1">
+              <a:rPr sz="1300" b="0" dirty="0" err="1">
+                <a:solidFill>
+                  <a:srgbClr val="1C2430"/>
+                </a:solidFill>
+                <a:latin typeface="Vazir" panose="020B0603030804020204" pitchFamily="34" charset="-78"/>
+                <a:cs typeface="Vazir" panose="020B0603030804020204" pitchFamily="34" charset="-78"/>
+              </a:rPr>
+              <a:t>مناسب</a:t>
+            </a:r>
+            <a:r>
+              <a:rPr sz="1300" b="0" dirty="0">
+                <a:solidFill>
+                  <a:srgbClr val="1C2430"/>
+                </a:solidFill>
+                <a:latin typeface="Vazir" panose="020B0603030804020204" pitchFamily="34" charset="-78"/>
+                <a:cs typeface="Vazir" panose="020B0603030804020204" pitchFamily="34" charset="-78"/>
+              </a:rPr>
+              <a:t> </a:t>
+            </a:r>
+            <a:r>
+              <a:rPr sz="1300" b="0" dirty="0" err="1">
+                <a:solidFill>
+                  <a:srgbClr val="1C2430"/>
+                </a:solidFill>
+                <a:latin typeface="Vazir" panose="020B0603030804020204" pitchFamily="34" charset="-78"/>
+                <a:cs typeface="Vazir" panose="020B0603030804020204" pitchFamily="34" charset="-78"/>
+              </a:rPr>
+              <a:t>نمایش</a:t>
+            </a:r>
+            <a:r>
+              <a:rPr sz="1300" b="0" dirty="0">
+                <a:solidFill>
+                  <a:srgbClr val="1C2430"/>
+                </a:solidFill>
+                <a:latin typeface="Vazir" panose="020B0603030804020204" pitchFamily="34" charset="-78"/>
+                <a:cs typeface="Vazir" panose="020B0603030804020204" pitchFamily="34" charset="-78"/>
+              </a:rPr>
+              <a:t> </a:t>
+            </a:r>
+            <a:r>
+              <a:rPr sz="1300" b="0" dirty="0" err="1">
+                <a:solidFill>
+                  <a:srgbClr val="1C2430"/>
+                </a:solidFill>
+                <a:latin typeface="Vazir" panose="020B0603030804020204" pitchFamily="34" charset="-78"/>
+                <a:cs typeface="Vazir" panose="020B0603030804020204" pitchFamily="34" charset="-78"/>
+              </a:rPr>
+              <a:t>کیف</a:t>
+            </a:r>
+            <a:r>
+              <a:rPr lang="fa-IR" sz="1300" b="0" dirty="0">
+                <a:solidFill>
+                  <a:srgbClr val="1C2430"/>
+                </a:solidFill>
+                <a:latin typeface="Vazir" panose="020B0603030804020204" pitchFamily="34" charset="-78"/>
+                <a:cs typeface="Vazir" panose="020B0603030804020204" pitchFamily="34" charset="-78"/>
+              </a:rPr>
+              <a:t>ی</a:t>
+            </a:r>
+            <a:endParaRPr sz="1300" b="0" dirty="0">
+              <a:solidFill>
+                <a:srgbClr val="1C2430"/>
+              </a:solidFill>
+              <a:latin typeface="Vazir" panose="020B0603030804020204" pitchFamily="34" charset="-78"/>
+              <a:cs typeface="Vazir" panose="020B0603030804020204" pitchFamily="34" charset="-78"/>
+            </a:endParaRPr>
+          </a:p>
+          <a:p>
+            <a:pPr marL="285750" indent="-285750" algn="r" rtl="1">
               <a:spcAft>
                 <a:spcPts val="1200"/>
               </a:spcAft>
+              <a:buFont typeface="Arial" panose="020B0604020202020204" pitchFamily="34" charset="0"/>
+              <a:buChar char="•"/>
             </a:pPr>
             <a:r>
-              <a:rPr sz="1300" b="0">
-                <a:solidFill>
-                  <a:srgbClr val="1C2430"/>
-                </a:solidFill>
-                <a:latin typeface="Vazir" panose="020B0603030804020204" pitchFamily="34" charset="-78"/>
-                <a:cs typeface="Vazir" panose="020B0603030804020204" pitchFamily="34" charset="-78"/>
-              </a:rPr>
-              <a:t>• Pipeline واقعی روی ویدئو/وب‌کم همین مدل را استفاده می‌کند</a:t>
-            </a:r>
+              <a:rPr sz="1300" b="0" dirty="0">
+                <a:solidFill>
+                  <a:srgbClr val="1C2430"/>
+                </a:solidFill>
+                <a:latin typeface="Vazir" panose="020B0603030804020204" pitchFamily="34" charset="-78"/>
+                <a:cs typeface="Vazir" panose="020B0603030804020204" pitchFamily="34" charset="-78"/>
+              </a:rPr>
+              <a:t>Pipeline </a:t>
+            </a:r>
+            <a:r>
+              <a:rPr lang="fa-IR" sz="1300" b="0" dirty="0">
+                <a:solidFill>
+                  <a:srgbClr val="1C2430"/>
+                </a:solidFill>
+                <a:latin typeface="Vazir" panose="020B0603030804020204" pitchFamily="34" charset="-78"/>
+                <a:cs typeface="Vazir" panose="020B0603030804020204" pitchFamily="34" charset="-78"/>
+              </a:rPr>
+              <a:t> </a:t>
+            </a:r>
+            <a:r>
+              <a:rPr sz="1300" b="0" dirty="0" err="1">
+                <a:solidFill>
+                  <a:srgbClr val="1C2430"/>
+                </a:solidFill>
+                <a:latin typeface="Vazir" panose="020B0603030804020204" pitchFamily="34" charset="-78"/>
+                <a:cs typeface="Vazir" panose="020B0603030804020204" pitchFamily="34" charset="-78"/>
+              </a:rPr>
+              <a:t>واقعی</a:t>
+            </a:r>
+            <a:r>
+              <a:rPr sz="1300" b="0" dirty="0">
+                <a:solidFill>
+                  <a:srgbClr val="1C2430"/>
+                </a:solidFill>
+                <a:latin typeface="Vazir" panose="020B0603030804020204" pitchFamily="34" charset="-78"/>
+                <a:cs typeface="Vazir" panose="020B0603030804020204" pitchFamily="34" charset="-78"/>
+              </a:rPr>
+              <a:t> </a:t>
+            </a:r>
+            <a:r>
+              <a:rPr sz="1300" b="0" dirty="0" err="1">
+                <a:solidFill>
+                  <a:srgbClr val="1C2430"/>
+                </a:solidFill>
+                <a:latin typeface="Vazir" panose="020B0603030804020204" pitchFamily="34" charset="-78"/>
+                <a:cs typeface="Vazir" panose="020B0603030804020204" pitchFamily="34" charset="-78"/>
+              </a:rPr>
+              <a:t>روی</a:t>
+            </a:r>
+            <a:r>
+              <a:rPr sz="1300" b="0" dirty="0">
+                <a:solidFill>
+                  <a:srgbClr val="1C2430"/>
+                </a:solidFill>
+                <a:latin typeface="Vazir" panose="020B0603030804020204" pitchFamily="34" charset="-78"/>
+                <a:cs typeface="Vazir" panose="020B0603030804020204" pitchFamily="34" charset="-78"/>
+              </a:rPr>
+              <a:t> </a:t>
+            </a:r>
+            <a:r>
+              <a:rPr sz="1300" b="0" dirty="0" err="1">
+                <a:solidFill>
+                  <a:srgbClr val="1C2430"/>
+                </a:solidFill>
+                <a:latin typeface="Vazir" panose="020B0603030804020204" pitchFamily="34" charset="-78"/>
+                <a:cs typeface="Vazir" panose="020B0603030804020204" pitchFamily="34" charset="-78"/>
+              </a:rPr>
+              <a:t>ویدئو</a:t>
+            </a:r>
+            <a:r>
+              <a:rPr sz="1300" b="0" dirty="0">
+                <a:solidFill>
+                  <a:srgbClr val="1C2430"/>
+                </a:solidFill>
+                <a:latin typeface="Vazir" panose="020B0603030804020204" pitchFamily="34" charset="-78"/>
+                <a:cs typeface="Vazir" panose="020B0603030804020204" pitchFamily="34" charset="-78"/>
+              </a:rPr>
+              <a:t>/</a:t>
+            </a:r>
+            <a:r>
+              <a:rPr sz="1300" b="0" dirty="0" err="1">
+                <a:solidFill>
+                  <a:srgbClr val="1C2430"/>
+                </a:solidFill>
+                <a:latin typeface="Vazir" panose="020B0603030804020204" pitchFamily="34" charset="-78"/>
+                <a:cs typeface="Vazir" panose="020B0603030804020204" pitchFamily="34" charset="-78"/>
+              </a:rPr>
+              <a:t>وب‌کم</a:t>
+            </a:r>
+            <a:r>
+              <a:rPr sz="1300" b="0" dirty="0">
+                <a:solidFill>
+                  <a:srgbClr val="1C2430"/>
+                </a:solidFill>
+                <a:latin typeface="Vazir" panose="020B0603030804020204" pitchFamily="34" charset="-78"/>
+                <a:cs typeface="Vazir" panose="020B0603030804020204" pitchFamily="34" charset="-78"/>
+              </a:rPr>
+              <a:t> </a:t>
+            </a:r>
+            <a:r>
+              <a:rPr sz="1300" b="0" dirty="0" err="1">
+                <a:solidFill>
+                  <a:srgbClr val="1C2430"/>
+                </a:solidFill>
+                <a:latin typeface="Vazir" panose="020B0603030804020204" pitchFamily="34" charset="-78"/>
+                <a:cs typeface="Vazir" panose="020B0603030804020204" pitchFamily="34" charset="-78"/>
+              </a:rPr>
+              <a:t>همین</a:t>
+            </a:r>
+            <a:r>
+              <a:rPr sz="1300" b="0" dirty="0">
+                <a:solidFill>
+                  <a:srgbClr val="1C2430"/>
+                </a:solidFill>
+                <a:latin typeface="Vazir" panose="020B0603030804020204" pitchFamily="34" charset="-78"/>
+                <a:cs typeface="Vazir" panose="020B0603030804020204" pitchFamily="34" charset="-78"/>
+              </a:rPr>
+              <a:t> </a:t>
+            </a:r>
+            <a:r>
+              <a:rPr sz="1300" b="0" dirty="0" err="1">
+                <a:solidFill>
+                  <a:srgbClr val="1C2430"/>
+                </a:solidFill>
+                <a:latin typeface="Vazir" panose="020B0603030804020204" pitchFamily="34" charset="-78"/>
+                <a:cs typeface="Vazir" panose="020B0603030804020204" pitchFamily="34" charset="-78"/>
+              </a:rPr>
+              <a:t>مدل</a:t>
+            </a:r>
+            <a:r>
+              <a:rPr sz="1300" b="0" dirty="0">
+                <a:solidFill>
+                  <a:srgbClr val="1C2430"/>
+                </a:solidFill>
+                <a:latin typeface="Vazir" panose="020B0603030804020204" pitchFamily="34" charset="-78"/>
+                <a:cs typeface="Vazir" panose="020B0603030804020204" pitchFamily="34" charset="-78"/>
+              </a:rPr>
+              <a:t> </a:t>
+            </a:r>
+            <a:r>
+              <a:rPr sz="1300" b="0" dirty="0" err="1">
+                <a:solidFill>
+                  <a:srgbClr val="1C2430"/>
+                </a:solidFill>
+                <a:latin typeface="Vazir" panose="020B0603030804020204" pitchFamily="34" charset="-78"/>
+                <a:cs typeface="Vazir" panose="020B0603030804020204" pitchFamily="34" charset="-78"/>
+              </a:rPr>
+              <a:t>را</a:t>
+            </a:r>
+            <a:r>
+              <a:rPr sz="1300" b="0" dirty="0">
+                <a:solidFill>
+                  <a:srgbClr val="1C2430"/>
+                </a:solidFill>
+                <a:latin typeface="Vazir" panose="020B0603030804020204" pitchFamily="34" charset="-78"/>
+                <a:cs typeface="Vazir" panose="020B0603030804020204" pitchFamily="34" charset="-78"/>
+              </a:rPr>
+              <a:t> </a:t>
+            </a:r>
+            <a:r>
+              <a:rPr sz="1300" b="0" dirty="0" err="1">
+                <a:solidFill>
+                  <a:srgbClr val="1C2430"/>
+                </a:solidFill>
+                <a:latin typeface="Vazir" panose="020B0603030804020204" pitchFamily="34" charset="-78"/>
+                <a:cs typeface="Vazir" panose="020B0603030804020204" pitchFamily="34" charset="-78"/>
+              </a:rPr>
+              <a:t>استفاده</a:t>
+            </a:r>
+            <a:r>
+              <a:rPr sz="1300" b="0" dirty="0">
+                <a:solidFill>
+                  <a:srgbClr val="1C2430"/>
+                </a:solidFill>
+                <a:latin typeface="Vazir" panose="020B0603030804020204" pitchFamily="34" charset="-78"/>
+                <a:cs typeface="Vazir" panose="020B0603030804020204" pitchFamily="34" charset="-78"/>
+              </a:rPr>
+              <a:t> </a:t>
+            </a:r>
+            <a:r>
+              <a:rPr sz="1300" b="0" dirty="0" err="1">
+                <a:solidFill>
+                  <a:srgbClr val="1C2430"/>
+                </a:solidFill>
+                <a:latin typeface="Vazir" panose="020B0603030804020204" pitchFamily="34" charset="-78"/>
+                <a:cs typeface="Vazir" panose="020B0603030804020204" pitchFamily="34" charset="-78"/>
+              </a:rPr>
+              <a:t>می‌کند</a:t>
+            </a:r>
+            <a:endParaRPr sz="1300" b="0" dirty="0">
+              <a:solidFill>
+                <a:srgbClr val="1C2430"/>
+              </a:solidFill>
+              <a:latin typeface="Vazir" panose="020B0603030804020204" pitchFamily="34" charset="-78"/>
+              <a:cs typeface="Vazir" panose="020B0603030804020204" pitchFamily="34" charset="-78"/>
+            </a:endParaRPr>
           </a:p>
         </p:txBody>
       </p:sp>
@@ -9761,14 +10455,74 @@
           <a:p>
             <a:pPr algn="r" rtl="1"/>
             <a:r>
-              <a:rPr sz="1200" b="0">
+              <a:rPr sz="1200" b="0" dirty="0" err="1">
                 <a:solidFill>
                   <a:srgbClr val="5A6A7A"/>
                 </a:solidFill>
                 <a:latin typeface="Vazir" panose="020B0603030804020204" pitchFamily="34" charset="-78"/>
                 <a:cs typeface="Vazir" panose="020B0603030804020204" pitchFamily="34" charset="-78"/>
               </a:rPr>
-              <a:t>تبدیل ODGT به فرمت YOLO</a:t>
+              <a:t>تبدیل</a:t>
+            </a:r>
+            <a:r>
+              <a:rPr sz="1200" b="0" dirty="0">
+                <a:solidFill>
+                  <a:srgbClr val="5A6A7A"/>
+                </a:solidFill>
+                <a:latin typeface="Vazir" panose="020B0603030804020204" pitchFamily="34" charset="-78"/>
+                <a:cs typeface="Vazir" panose="020B0603030804020204" pitchFamily="34" charset="-78"/>
+              </a:rPr>
+              <a:t> ODGT </a:t>
+            </a:r>
+            <a:r>
+              <a:rPr lang="fa-IR" sz="1200" b="0" dirty="0">
+                <a:solidFill>
+                  <a:srgbClr val="5A6A7A"/>
+                </a:solidFill>
+                <a:latin typeface="Vazir" panose="020B0603030804020204" pitchFamily="34" charset="-78"/>
+                <a:cs typeface="Vazir" panose="020B0603030804020204" pitchFamily="34" charset="-78"/>
+              </a:rPr>
+              <a:t> </a:t>
+            </a:r>
+            <a:r>
+              <a:rPr sz="1200" b="0" dirty="0" err="1">
+                <a:solidFill>
+                  <a:srgbClr val="5A6A7A"/>
+                </a:solidFill>
+                <a:latin typeface="Vazir" panose="020B0603030804020204" pitchFamily="34" charset="-78"/>
+                <a:cs typeface="Vazir" panose="020B0603030804020204" pitchFamily="34" charset="-78"/>
+              </a:rPr>
+              <a:t>به</a:t>
+            </a:r>
+            <a:r>
+              <a:rPr sz="1200" b="0" dirty="0">
+                <a:solidFill>
+                  <a:srgbClr val="5A6A7A"/>
+                </a:solidFill>
+                <a:latin typeface="Vazir" panose="020B0603030804020204" pitchFamily="34" charset="-78"/>
+                <a:cs typeface="Vazir" panose="020B0603030804020204" pitchFamily="34" charset="-78"/>
+              </a:rPr>
+              <a:t> </a:t>
+            </a:r>
+            <a:r>
+              <a:rPr sz="1200" b="0" dirty="0" err="1">
+                <a:solidFill>
+                  <a:srgbClr val="5A6A7A"/>
+                </a:solidFill>
+                <a:latin typeface="Vazir" panose="020B0603030804020204" pitchFamily="34" charset="-78"/>
+                <a:cs typeface="Vazir" panose="020B0603030804020204" pitchFamily="34" charset="-78"/>
+              </a:rPr>
+              <a:t>فرمت</a:t>
+            </a:r>
+            <a:r>
+              <a:rPr sz="1200" b="0" dirty="0">
+                <a:solidFill>
+                  <a:srgbClr val="5A6A7A"/>
+                </a:solidFill>
+                <a:latin typeface="Vazir" panose="020B0603030804020204" pitchFamily="34" charset="-78"/>
+                <a:cs typeface="Vazir" panose="020B0603030804020204" pitchFamily="34" charset="-78"/>
+              </a:rPr>
+              <a:t> YOLO</a:t>
             </a:r>
           </a:p>
         </p:txBody>
@@ -10827,15 +11581,52 @@
           <a:p>
             <a:pPr algn="r" rtl="1"/>
             <a:r>
-              <a:rPr sz="1500" b="1">
+              <a:rPr sz="1500" b="1" dirty="0" err="1">
                 <a:solidFill>
                   <a:srgbClr val="0B1F3A"/>
                 </a:solidFill>
                 <a:latin typeface="Vazir" panose="020B0603030804020204" pitchFamily="34" charset="-78"/>
                 <a:cs typeface="Vazir" panose="020B0603030804020204" pitchFamily="34" charset="-78"/>
               </a:rPr>
-              <a:t>ByteTrack / ردیابی</a:t>
-            </a:r>
+              <a:t>ByteTrack</a:t>
+            </a:r>
+            <a:r>
+              <a:rPr sz="1500" b="1" dirty="0">
+                <a:solidFill>
+                  <a:srgbClr val="0B1F3A"/>
+                </a:solidFill>
+                <a:latin typeface="Vazir" panose="020B0603030804020204" pitchFamily="34" charset="-78"/>
+                <a:cs typeface="Vazir" panose="020B0603030804020204" pitchFamily="34" charset="-78"/>
+              </a:rPr>
+              <a:t> </a:t>
+            </a:r>
+            <a:r>
+              <a:rPr lang="fa-IR" sz="1500" b="1" dirty="0">
+                <a:solidFill>
+                  <a:srgbClr val="0B1F3A"/>
+                </a:solidFill>
+                <a:latin typeface="Vazir" panose="020B0603030804020204" pitchFamily="34" charset="-78"/>
+                <a:cs typeface="Vazir" panose="020B0603030804020204" pitchFamily="34" charset="-78"/>
+              </a:rPr>
+              <a:t> / </a:t>
+            </a:r>
+            <a:r>
+              <a:rPr sz="1500" b="1" dirty="0" err="1">
+                <a:solidFill>
+                  <a:srgbClr val="0B1F3A"/>
+                </a:solidFill>
+                <a:latin typeface="Vazir" panose="020B0603030804020204" pitchFamily="34" charset="-78"/>
+                <a:cs typeface="Vazir" panose="020B0603030804020204" pitchFamily="34" charset="-78"/>
+              </a:rPr>
+              <a:t>ردیابی</a:t>
+            </a:r>
+            <a:endParaRPr sz="1500" b="1" dirty="0">
+              <a:solidFill>
+                <a:srgbClr val="0B1F3A"/>
+              </a:solidFill>
+              <a:latin typeface="Vazir" panose="020B0603030804020204" pitchFamily="34" charset="-78"/>
+              <a:cs typeface="Vazir" panose="020B0603030804020204" pitchFamily="34" charset="-78"/>
+            </a:endParaRPr>
           </a:p>
         </p:txBody>
       </p:sp>
@@ -10861,89 +11652,323 @@
           </a:bodyPr>
           <a:lstStyle/>
           <a:p>
-            <a:pPr algn="r" rtl="1">
+            <a:pPr marL="285750" indent="-285750" algn="r" rtl="1">
               <a:spcAft>
                 <a:spcPts val="700"/>
               </a:spcAft>
+              <a:buFont typeface="Arial" panose="020B0604020202020204" pitchFamily="34" charset="0"/>
+              <a:buChar char="•"/>
             </a:pPr>
             <a:r>
-              <a:rPr sz="1300" b="0">
-                <a:solidFill>
-                  <a:srgbClr val="1C2430"/>
-                </a:solidFill>
-                <a:latin typeface="Vazir" panose="020B0603030804020204" pitchFamily="34" charset="-78"/>
-                <a:cs typeface="Vazir" panose="020B0603030804020204" pitchFamily="34" charset="-78"/>
-              </a:rPr>
-              <a:t>• بدون آموزش اضافه؛ post-processing روی detectionها</a:t>
-            </a:r>
-          </a:p>
-          <a:p>
-            <a:pPr algn="r" rtl="1">
+              <a:rPr lang="fa-IR" sz="1300" dirty="0">
+                <a:solidFill>
+                  <a:srgbClr val="1C2430"/>
+                </a:solidFill>
+                <a:latin typeface="Vazir" panose="020B0603030804020204" pitchFamily="34" charset="-78"/>
+                <a:cs typeface="Vazir" panose="020B0603030804020204" pitchFamily="34" charset="-78"/>
+              </a:rPr>
+              <a:t>بدون آموزش اضافه؛ </a:t>
+            </a:r>
+            <a:r>
+              <a:rPr lang="en-US" sz="1300" dirty="0">
+                <a:solidFill>
+                  <a:srgbClr val="1C2430"/>
+                </a:solidFill>
+                <a:latin typeface="Vazir" panose="020B0603030804020204" pitchFamily="34" charset="-78"/>
+                <a:cs typeface="Vazir" panose="020B0603030804020204" pitchFamily="34" charset="-78"/>
+              </a:rPr>
+              <a:t>post-processing  </a:t>
+            </a:r>
+            <a:r>
+              <a:rPr lang="fa-IR" sz="1300" dirty="0">
+                <a:solidFill>
+                  <a:srgbClr val="1C2430"/>
+                </a:solidFill>
+                <a:latin typeface="Vazir" panose="020B0603030804020204" pitchFamily="34" charset="-78"/>
+                <a:cs typeface="Vazir" panose="020B0603030804020204" pitchFamily="34" charset="-78"/>
+              </a:rPr>
+              <a:t>روی </a:t>
+            </a:r>
+            <a:r>
+              <a:rPr lang="en-US" sz="1300" dirty="0">
+                <a:solidFill>
+                  <a:srgbClr val="1C2430"/>
+                </a:solidFill>
+                <a:latin typeface="Vazir" panose="020B0603030804020204" pitchFamily="34" charset="-78"/>
+                <a:cs typeface="Vazir" panose="020B0603030804020204" pitchFamily="34" charset="-78"/>
+              </a:rPr>
+              <a:t>detection</a:t>
+            </a:r>
+            <a:r>
+              <a:rPr lang="fa-IR" sz="1300" dirty="0">
+                <a:solidFill>
+                  <a:srgbClr val="1C2430"/>
+                </a:solidFill>
+                <a:latin typeface="Vazir" panose="020B0603030804020204" pitchFamily="34" charset="-78"/>
+                <a:cs typeface="Vazir" panose="020B0603030804020204" pitchFamily="34" charset="-78"/>
+              </a:rPr>
+              <a:t>ها</a:t>
+            </a:r>
+          </a:p>
+          <a:p>
+            <a:pPr marL="285750" indent="-285750" algn="r" rtl="1">
               <a:spcAft>
                 <a:spcPts val="700"/>
               </a:spcAft>
+              <a:buFont typeface="Arial" panose="020B0604020202020204" pitchFamily="34" charset="0"/>
+              <a:buChar char="•"/>
             </a:pPr>
             <a:r>
-              <a:rPr sz="1300" b="0">
-                <a:solidFill>
-                  <a:srgbClr val="1C2430"/>
-                </a:solidFill>
-                <a:latin typeface="Vazir" panose="020B0603030804020204" pitchFamily="34" charset="-78"/>
-                <a:cs typeface="Vazir" panose="020B0603030804020204" pitchFamily="34" charset="-78"/>
-              </a:rPr>
-              <a:t>• Track ID پایدار حتی با انسداد کوتاه</a:t>
-            </a:r>
-          </a:p>
-          <a:p>
-            <a:pPr algn="r" rtl="1">
+              <a:rPr lang="en-US" sz="1300" dirty="0">
+                <a:solidFill>
+                  <a:srgbClr val="1C2430"/>
+                </a:solidFill>
+                <a:latin typeface="Vazir" panose="020B0603030804020204" pitchFamily="34" charset="-78"/>
+                <a:cs typeface="Vazir" panose="020B0603030804020204" pitchFamily="34" charset="-78"/>
+              </a:rPr>
+              <a:t>Track ID </a:t>
+            </a:r>
+            <a:r>
+              <a:rPr lang="fa-IR" sz="1300" dirty="0">
+                <a:solidFill>
+                  <a:srgbClr val="1C2430"/>
+                </a:solidFill>
+                <a:latin typeface="Vazir" panose="020B0603030804020204" pitchFamily="34" charset="-78"/>
+                <a:cs typeface="Vazir" panose="020B0603030804020204" pitchFamily="34" charset="-78"/>
+              </a:rPr>
+              <a:t>پایدار حتی با انسداد کوتاه</a:t>
+            </a:r>
+          </a:p>
+          <a:p>
+            <a:pPr marL="285750" indent="-285750" algn="r" rtl="1">
               <a:spcAft>
                 <a:spcPts val="700"/>
               </a:spcAft>
+              <a:buFont typeface="Arial" panose="020B0604020202020204" pitchFamily="34" charset="0"/>
+              <a:buChar char="•"/>
             </a:pPr>
             <a:r>
-              <a:rPr sz="1300" b="0">
-                <a:solidFill>
-                  <a:srgbClr val="1C2430"/>
-                </a:solidFill>
-                <a:latin typeface="Vazir" panose="020B0603030804020204" pitchFamily="34" charset="-78"/>
-                <a:cs typeface="Vazir" panose="020B0603030804020204" pitchFamily="34" charset="-78"/>
-              </a:rPr>
-              <a:t>• کیفیت وابسته به confidence و FPS است</a:t>
-            </a:r>
-          </a:p>
-          <a:p>
-            <a:pPr algn="r" rtl="1">
+              <a:rPr lang="fa-IR" sz="1300" dirty="0">
+                <a:solidFill>
+                  <a:srgbClr val="1C2430"/>
+                </a:solidFill>
+                <a:latin typeface="Vazir" panose="020B0603030804020204" pitchFamily="34" charset="-78"/>
+                <a:cs typeface="Vazir" panose="020B0603030804020204" pitchFamily="34" charset="-78"/>
+              </a:rPr>
+              <a:t>کیفیت وابسته به </a:t>
+            </a:r>
+            <a:r>
+              <a:rPr lang="en-US" sz="1300" dirty="0">
+                <a:solidFill>
+                  <a:srgbClr val="1C2430"/>
+                </a:solidFill>
+                <a:latin typeface="Vazir" panose="020B0603030804020204" pitchFamily="34" charset="-78"/>
+                <a:cs typeface="Vazir" panose="020B0603030804020204" pitchFamily="34" charset="-78"/>
+              </a:rPr>
+              <a:t>confidence </a:t>
+            </a:r>
+            <a:r>
+              <a:rPr lang="fa-IR" sz="1300" dirty="0">
+                <a:solidFill>
+                  <a:srgbClr val="1C2430"/>
+                </a:solidFill>
+                <a:latin typeface="Vazir" panose="020B0603030804020204" pitchFamily="34" charset="-78"/>
+                <a:cs typeface="Vazir" panose="020B0603030804020204" pitchFamily="34" charset="-78"/>
+              </a:rPr>
+              <a:t>و </a:t>
+            </a:r>
+            <a:r>
+              <a:rPr lang="en-US" sz="1300" dirty="0">
+                <a:solidFill>
+                  <a:srgbClr val="1C2430"/>
+                </a:solidFill>
+                <a:latin typeface="Vazir" panose="020B0603030804020204" pitchFamily="34" charset="-78"/>
+                <a:cs typeface="Vazir" panose="020B0603030804020204" pitchFamily="34" charset="-78"/>
+              </a:rPr>
+              <a:t>FPS </a:t>
+            </a:r>
+            <a:r>
+              <a:rPr lang="fa-IR" sz="1300" dirty="0">
+                <a:solidFill>
+                  <a:srgbClr val="1C2430"/>
+                </a:solidFill>
+                <a:latin typeface="Vazir" panose="020B0603030804020204" pitchFamily="34" charset="-78"/>
+                <a:cs typeface="Vazir" panose="020B0603030804020204" pitchFamily="34" charset="-78"/>
+              </a:rPr>
+              <a:t>است</a:t>
+            </a:r>
+          </a:p>
+          <a:p>
+            <a:pPr marL="285750" indent="-285750" algn="r" rtl="1">
               <a:spcAft>
                 <a:spcPts val="700"/>
               </a:spcAft>
+              <a:buFont typeface="Arial" panose="020B0604020202020204" pitchFamily="34" charset="0"/>
+              <a:buChar char="•"/>
             </a:pPr>
             <a:r>
-              <a:rPr sz="1300" b="0">
-                <a:solidFill>
-                  <a:srgbClr val="1C2430"/>
-                </a:solidFill>
-                <a:latin typeface="Vazir" panose="020B0603030804020204" pitchFamily="34" charset="-78"/>
-                <a:cs typeface="Vazir" panose="020B0603030804020204" pitchFamily="34" charset="-78"/>
-              </a:rPr>
-              <a:t>• BoT-SORT به‌عنوان جایگزین (Kalman + appearance)</a:t>
-            </a:r>
-          </a:p>
-          <a:p>
-            <a:pPr algn="r" rtl="1">
+              <a:rPr lang="en-US" sz="1300" dirty="0" err="1">
+                <a:solidFill>
+                  <a:srgbClr val="1C2430"/>
+                </a:solidFill>
+                <a:latin typeface="Vazir" panose="020B0603030804020204" pitchFamily="34" charset="-78"/>
+                <a:cs typeface="Vazir" panose="020B0603030804020204" pitchFamily="34" charset="-78"/>
+              </a:rPr>
+              <a:t>BoT</a:t>
+            </a:r>
+            <a:r>
+              <a:rPr lang="en-US" sz="1300" dirty="0">
+                <a:solidFill>
+                  <a:srgbClr val="1C2430"/>
+                </a:solidFill>
+                <a:latin typeface="Vazir" panose="020B0603030804020204" pitchFamily="34" charset="-78"/>
+                <a:cs typeface="Vazir" panose="020B0603030804020204" pitchFamily="34" charset="-78"/>
+              </a:rPr>
+              <a:t>-SORT </a:t>
+            </a:r>
+            <a:r>
+              <a:rPr lang="fa-IR" sz="1300" dirty="0">
+                <a:solidFill>
+                  <a:srgbClr val="1C2430"/>
+                </a:solidFill>
+                <a:latin typeface="Vazir" panose="020B0603030804020204" pitchFamily="34" charset="-78"/>
+                <a:cs typeface="Vazir" panose="020B0603030804020204" pitchFamily="34" charset="-78"/>
+              </a:rPr>
+              <a:t> </a:t>
+            </a:r>
+            <a:r>
+              <a:rPr lang="fa-IR" sz="1300" dirty="0" err="1">
+                <a:solidFill>
+                  <a:srgbClr val="1C2430"/>
+                </a:solidFill>
+                <a:latin typeface="Vazir" panose="020B0603030804020204" pitchFamily="34" charset="-78"/>
+                <a:cs typeface="Vazir" panose="020B0603030804020204" pitchFamily="34" charset="-78"/>
+              </a:rPr>
+              <a:t>به‌عنوان</a:t>
+            </a:r>
+            <a:r>
+              <a:rPr lang="fa-IR" sz="1300" dirty="0">
+                <a:solidFill>
+                  <a:srgbClr val="1C2430"/>
+                </a:solidFill>
+                <a:latin typeface="Vazir" panose="020B0603030804020204" pitchFamily="34" charset="-78"/>
+                <a:cs typeface="Vazir" panose="020B0603030804020204" pitchFamily="34" charset="-78"/>
+              </a:rPr>
+              <a:t> جایگزین </a:t>
+            </a:r>
+            <a:r>
+              <a:rPr lang="en-US" sz="1300" dirty="0">
+                <a:solidFill>
+                  <a:srgbClr val="1C2430"/>
+                </a:solidFill>
+                <a:latin typeface="Vazir" panose="020B0603030804020204" pitchFamily="34" charset="-78"/>
+                <a:cs typeface="Vazir" panose="020B0603030804020204" pitchFamily="34" charset="-78"/>
+              </a:rPr>
+              <a:t>Kalman + appearance)</a:t>
+            </a:r>
+            <a:r>
+              <a:rPr lang="fa-IR" sz="1300" dirty="0">
+                <a:solidFill>
+                  <a:srgbClr val="1C2430"/>
+                </a:solidFill>
+                <a:latin typeface="Vazir" panose="020B0603030804020204" pitchFamily="34" charset="-78"/>
+                <a:cs typeface="Vazir" panose="020B0603030804020204" pitchFamily="34" charset="-78"/>
+              </a:rPr>
+              <a:t>)</a:t>
+            </a:r>
+            <a:endParaRPr lang="en-US" sz="1300" dirty="0">
+              <a:solidFill>
+                <a:srgbClr val="1C2430"/>
+              </a:solidFill>
+              <a:latin typeface="Vazir" panose="020B0603030804020204" pitchFamily="34" charset="-78"/>
+              <a:cs typeface="Vazir" panose="020B0603030804020204" pitchFamily="34" charset="-78"/>
+            </a:endParaRPr>
+          </a:p>
+          <a:p>
+            <a:pPr marL="285750" indent="-285750" algn="r" rtl="1">
               <a:spcAft>
                 <a:spcPts val="700"/>
               </a:spcAft>
+              <a:buFont typeface="Arial" panose="020B0604020202020204" pitchFamily="34" charset="0"/>
+              <a:buChar char="•"/>
             </a:pPr>
             <a:r>
-              <a:rPr sz="1300" b="0">
-                <a:solidFill>
-                  <a:srgbClr val="1C2430"/>
-                </a:solidFill>
-                <a:latin typeface="Vazir" panose="020B0603030804020204" pitchFamily="34" charset="-78"/>
-                <a:cs typeface="Vazir" panose="020B0603030804020204" pitchFamily="34" charset="-78"/>
-              </a:rPr>
-              <a:t>• فعال‌سازی از طریق yaml ردیاب در Ultralytics</a:t>
-            </a:r>
+              <a:rPr lang="fa-IR" sz="1300" dirty="0" err="1">
+                <a:solidFill>
+                  <a:srgbClr val="1C2430"/>
+                </a:solidFill>
+                <a:latin typeface="Vazir" panose="020B0603030804020204" pitchFamily="34" charset="-78"/>
+                <a:cs typeface="Vazir" panose="020B0603030804020204" pitchFamily="34" charset="-78"/>
+              </a:rPr>
+              <a:t>فعال‌سازی</a:t>
+            </a:r>
+            <a:r>
+              <a:rPr lang="fa-IR" sz="1300" dirty="0">
+                <a:solidFill>
+                  <a:srgbClr val="1C2430"/>
+                </a:solidFill>
+                <a:latin typeface="Vazir" panose="020B0603030804020204" pitchFamily="34" charset="-78"/>
+                <a:cs typeface="Vazir" panose="020B0603030804020204" pitchFamily="34" charset="-78"/>
+              </a:rPr>
+              <a:t> از طریق </a:t>
+            </a:r>
+            <a:r>
+              <a:rPr lang="en-US" sz="1300" dirty="0" err="1">
+                <a:solidFill>
+                  <a:srgbClr val="1C2430"/>
+                </a:solidFill>
+                <a:latin typeface="Vazir" panose="020B0603030804020204" pitchFamily="34" charset="-78"/>
+                <a:cs typeface="Vazir" panose="020B0603030804020204" pitchFamily="34" charset="-78"/>
+              </a:rPr>
+              <a:t>yaml</a:t>
+            </a:r>
+            <a:r>
+              <a:rPr lang="en-US" sz="1300" dirty="0">
+                <a:solidFill>
+                  <a:srgbClr val="1C2430"/>
+                </a:solidFill>
+                <a:latin typeface="Vazir" panose="020B0603030804020204" pitchFamily="34" charset="-78"/>
+                <a:cs typeface="Vazir" panose="020B0603030804020204" pitchFamily="34" charset="-78"/>
+              </a:rPr>
+              <a:t> </a:t>
+            </a:r>
+            <a:r>
+              <a:rPr lang="fa-IR" sz="1300" dirty="0" err="1">
+                <a:solidFill>
+                  <a:srgbClr val="1C2430"/>
+                </a:solidFill>
+                <a:latin typeface="Vazir" panose="020B0603030804020204" pitchFamily="34" charset="-78"/>
+                <a:cs typeface="Vazir" panose="020B0603030804020204" pitchFamily="34" charset="-78"/>
+              </a:rPr>
+              <a:t>ردیاب</a:t>
+            </a:r>
+            <a:r>
+              <a:rPr lang="fa-IR" sz="1300" dirty="0">
+                <a:solidFill>
+                  <a:srgbClr val="1C2430"/>
+                </a:solidFill>
+                <a:latin typeface="Vazir" panose="020B0603030804020204" pitchFamily="34" charset="-78"/>
+                <a:cs typeface="Vazir" panose="020B0603030804020204" pitchFamily="34" charset="-78"/>
+              </a:rPr>
+              <a:t> در </a:t>
+            </a:r>
+            <a:r>
+              <a:rPr lang="en-US" sz="1300" dirty="0" err="1">
+                <a:solidFill>
+                  <a:srgbClr val="1C2430"/>
+                </a:solidFill>
+                <a:latin typeface="Vazir" panose="020B0603030804020204" pitchFamily="34" charset="-78"/>
+                <a:cs typeface="Vazir" panose="020B0603030804020204" pitchFamily="34" charset="-78"/>
+              </a:rPr>
+              <a:t>Ultralytics</a:t>
+            </a:r>
+            <a:endParaRPr lang="en-US" sz="1300" dirty="0">
+              <a:solidFill>
+                <a:srgbClr val="1C2430"/>
+              </a:solidFill>
+              <a:latin typeface="Vazir" panose="020B0603030804020204" pitchFamily="34" charset="-78"/>
+              <a:cs typeface="Vazir" panose="020B0603030804020204" pitchFamily="34" charset="-78"/>
+            </a:endParaRPr>
           </a:p>
         </p:txBody>
       </p:sp>
@@ -11061,15 +12086,62 @@
           <a:p>
             <a:pPr algn="r" rtl="1"/>
             <a:r>
-              <a:rPr sz="1500" b="1">
+              <a:rPr lang="en-US" sz="1500" b="1" dirty="0" err="1">
                 <a:solidFill>
                   <a:srgbClr val="0B1F3A"/>
                 </a:solidFill>
                 <a:latin typeface="Vazir" panose="020B0603030804020204" pitchFamily="34" charset="-78"/>
                 <a:cs typeface="Vazir" panose="020B0603030804020204" pitchFamily="34" charset="-78"/>
               </a:rPr>
-              <a:t>DeepFace / چهره</a:t>
-            </a:r>
+              <a:t>D</a:t>
+            </a:r>
+            <a:r>
+              <a:rPr sz="1500" b="1" dirty="0" err="1">
+                <a:solidFill>
+                  <a:srgbClr val="0B1F3A"/>
+                </a:solidFill>
+                <a:latin typeface="Vazir" panose="020B0603030804020204" pitchFamily="34" charset="-78"/>
+                <a:cs typeface="Vazir" panose="020B0603030804020204" pitchFamily="34" charset="-78"/>
+              </a:rPr>
+              <a:t>eepFace</a:t>
+            </a:r>
+            <a:r>
+              <a:rPr sz="1500" b="1" dirty="0">
+                <a:solidFill>
+                  <a:srgbClr val="0B1F3A"/>
+                </a:solidFill>
+                <a:latin typeface="Vazir" panose="020B0603030804020204" pitchFamily="34" charset="-78"/>
+                <a:cs typeface="Vazir" panose="020B0603030804020204" pitchFamily="34" charset="-78"/>
+              </a:rPr>
+              <a:t> </a:t>
+            </a:r>
+            <a:r>
+              <a:rPr lang="fa-IR" sz="1500" b="1" dirty="0">
+                <a:solidFill>
+                  <a:srgbClr val="0B1F3A"/>
+                </a:solidFill>
+                <a:latin typeface="Vazir" panose="020B0603030804020204" pitchFamily="34" charset="-78"/>
+                <a:cs typeface="Vazir" panose="020B0603030804020204" pitchFamily="34" charset="-78"/>
+              </a:rPr>
+              <a:t> / </a:t>
+            </a:r>
+            <a:r>
+              <a:rPr sz="1500" b="1" dirty="0" err="1">
+                <a:solidFill>
+                  <a:srgbClr val="0B1F3A"/>
+                </a:solidFill>
+                <a:latin typeface="Vazir" panose="020B0603030804020204" pitchFamily="34" charset="-78"/>
+                <a:cs typeface="Vazir" panose="020B0603030804020204" pitchFamily="34" charset="-78"/>
+              </a:rPr>
+              <a:t>چهره</a:t>
+            </a:r>
+            <a:endParaRPr sz="1500" b="1" dirty="0">
+              <a:solidFill>
+                <a:srgbClr val="0B1F3A"/>
+              </a:solidFill>
+              <a:latin typeface="Vazir" panose="020B0603030804020204" pitchFamily="34" charset="-78"/>
+              <a:cs typeface="Vazir" panose="020B0603030804020204" pitchFamily="34" charset="-78"/>
+            </a:endParaRPr>
           </a:p>
         </p:txBody>
       </p:sp>
@@ -11082,7 +12154,7 @@
         <p:spPr>
           <a:xfrm>
             <a:off x="594360" y="1554480"/>
-            <a:ext cx="5257800" cy="1451679"/>
+            <a:ext cx="5257800" cy="1941557"/>
           </a:xfrm>
           <a:prstGeom prst="rect">
             <a:avLst/>
@@ -11095,88 +12167,652 @@
           </a:bodyPr>
           <a:lstStyle/>
           <a:p>
-            <a:pPr algn="r" rtl="1">
+            <a:pPr marL="285750" indent="-285750" algn="r" rtl="1">
+              <a:spcAft>
+                <a:spcPts val="700"/>
+              </a:spcAft>
+              <a:buFont typeface="Arial" panose="020B0604020202020204" pitchFamily="34" charset="0"/>
+              <a:buChar char="•"/>
+            </a:pPr>
+            <a:r>
+              <a:rPr sz="1300" b="0" dirty="0">
+                <a:solidFill>
+                  <a:srgbClr val="1C2430"/>
+                </a:solidFill>
+                <a:latin typeface="Vazir" panose="020B0603030804020204" pitchFamily="34" charset="-78"/>
+                <a:cs typeface="Vazir" panose="020B0603030804020204" pitchFamily="34" charset="-78"/>
+              </a:rPr>
+              <a:t>Facenet512</a:t>
+            </a:r>
+            <a:r>
+              <a:rPr lang="fa-IR" sz="1300" b="0" dirty="0">
+                <a:solidFill>
+                  <a:srgbClr val="1C2430"/>
+                </a:solidFill>
+                <a:latin typeface="Vazir" panose="020B0603030804020204" pitchFamily="34" charset="-78"/>
+                <a:cs typeface="Vazir" panose="020B0603030804020204" pitchFamily="34" charset="-78"/>
+              </a:rPr>
+              <a:t> </a:t>
+            </a:r>
+            <a:r>
+              <a:rPr sz="1300" b="0" dirty="0">
+                <a:solidFill>
+                  <a:srgbClr val="1C2430"/>
+                </a:solidFill>
+                <a:latin typeface="Vazir" panose="020B0603030804020204" pitchFamily="34" charset="-78"/>
+                <a:cs typeface="Vazir" panose="020B0603030804020204" pitchFamily="34" charset="-78"/>
+              </a:rPr>
+              <a:t> </a:t>
+            </a:r>
+            <a:r>
+              <a:rPr sz="1300" b="0" dirty="0" err="1">
+                <a:solidFill>
+                  <a:srgbClr val="1C2430"/>
+                </a:solidFill>
+                <a:latin typeface="Vazir" panose="020B0603030804020204" pitchFamily="34" charset="-78"/>
+                <a:cs typeface="Vazir" panose="020B0603030804020204" pitchFamily="34" charset="-78"/>
+              </a:rPr>
+              <a:t>از</a:t>
+            </a:r>
+            <a:r>
+              <a:rPr sz="1300" b="0" dirty="0">
+                <a:solidFill>
+                  <a:srgbClr val="1C2430"/>
+                </a:solidFill>
+                <a:latin typeface="Vazir" panose="020B0603030804020204" pitchFamily="34" charset="-78"/>
+                <a:cs typeface="Vazir" panose="020B0603030804020204" pitchFamily="34" charset="-78"/>
+              </a:rPr>
+              <a:t> </a:t>
+            </a:r>
+            <a:r>
+              <a:rPr sz="1300" b="0" dirty="0" err="1">
+                <a:solidFill>
+                  <a:srgbClr val="1C2430"/>
+                </a:solidFill>
+                <a:latin typeface="Vazir" panose="020B0603030804020204" pitchFamily="34" charset="-78"/>
+                <a:cs typeface="Vazir" panose="020B0603030804020204" pitchFamily="34" charset="-78"/>
+              </a:rPr>
+              <a:t>پیش‌آموزش‌دیده</a:t>
+            </a:r>
+            <a:r>
+              <a:rPr sz="1300" b="0" dirty="0">
+                <a:solidFill>
+                  <a:srgbClr val="1C2430"/>
+                </a:solidFill>
+                <a:latin typeface="Vazir" panose="020B0603030804020204" pitchFamily="34" charset="-78"/>
+                <a:cs typeface="Vazir" panose="020B0603030804020204" pitchFamily="34" charset="-78"/>
+              </a:rPr>
+              <a:t> – </a:t>
+            </a:r>
+            <a:r>
+              <a:rPr lang="fa-IR" sz="1300" b="0" dirty="0">
+                <a:solidFill>
+                  <a:srgbClr val="1C2430"/>
+                </a:solidFill>
+                <a:latin typeface="Vazir" panose="020B0603030804020204" pitchFamily="34" charset="-78"/>
+                <a:cs typeface="Vazir" panose="020B0603030804020204" pitchFamily="34" charset="-78"/>
+              </a:rPr>
+              <a:t> </a:t>
+            </a:r>
+            <a:r>
+              <a:rPr sz="1300" b="0" dirty="0" err="1">
+                <a:solidFill>
+                  <a:srgbClr val="1C2430"/>
+                </a:solidFill>
+                <a:latin typeface="Vazir" panose="020B0603030804020204" pitchFamily="34" charset="-78"/>
+                <a:cs typeface="Vazir" panose="020B0603030804020204" pitchFamily="34" charset="-78"/>
+              </a:rPr>
+              <a:t>بدون</a:t>
+            </a:r>
+            <a:r>
+              <a:rPr sz="1300" b="0" dirty="0">
+                <a:solidFill>
+                  <a:srgbClr val="1C2430"/>
+                </a:solidFill>
+                <a:latin typeface="Vazir" panose="020B0603030804020204" pitchFamily="34" charset="-78"/>
+                <a:cs typeface="Vazir" panose="020B0603030804020204" pitchFamily="34" charset="-78"/>
+              </a:rPr>
+              <a:t> train </a:t>
+            </a:r>
+            <a:r>
+              <a:rPr lang="fa-IR" sz="1300" b="0" dirty="0">
+                <a:solidFill>
+                  <a:srgbClr val="1C2430"/>
+                </a:solidFill>
+                <a:latin typeface="Vazir" panose="020B0603030804020204" pitchFamily="34" charset="-78"/>
+                <a:cs typeface="Vazir" panose="020B0603030804020204" pitchFamily="34" charset="-78"/>
+              </a:rPr>
+              <a:t> </a:t>
+            </a:r>
+            <a:r>
+              <a:rPr sz="1300" b="0" dirty="0" err="1">
+                <a:solidFill>
+                  <a:srgbClr val="1C2430"/>
+                </a:solidFill>
+                <a:latin typeface="Vazir" panose="020B0603030804020204" pitchFamily="34" charset="-78"/>
+                <a:cs typeface="Vazir" panose="020B0603030804020204" pitchFamily="34" charset="-78"/>
+              </a:rPr>
+              <a:t>از</a:t>
+            </a:r>
+            <a:r>
+              <a:rPr sz="1300" b="0" dirty="0">
+                <a:solidFill>
+                  <a:srgbClr val="1C2430"/>
+                </a:solidFill>
+                <a:latin typeface="Vazir" panose="020B0603030804020204" pitchFamily="34" charset="-78"/>
+                <a:cs typeface="Vazir" panose="020B0603030804020204" pitchFamily="34" charset="-78"/>
+              </a:rPr>
+              <a:t> </a:t>
+            </a:r>
+            <a:r>
+              <a:rPr sz="1300" b="0" dirty="0" err="1">
+                <a:solidFill>
+                  <a:srgbClr val="1C2430"/>
+                </a:solidFill>
+                <a:latin typeface="Vazir" panose="020B0603030804020204" pitchFamily="34" charset="-78"/>
+                <a:cs typeface="Vazir" panose="020B0603030804020204" pitchFamily="34" charset="-78"/>
+              </a:rPr>
+              <a:t>صفر</a:t>
+            </a:r>
+            <a:endParaRPr sz="1300" b="0" dirty="0">
+              <a:solidFill>
+                <a:srgbClr val="1C2430"/>
+              </a:solidFill>
+              <a:latin typeface="Vazir" panose="020B0603030804020204" pitchFamily="34" charset="-78"/>
+              <a:cs typeface="Vazir" panose="020B0603030804020204" pitchFamily="34" charset="-78"/>
+            </a:endParaRPr>
+          </a:p>
+          <a:p>
+            <a:pPr marL="285750" indent="-285750" algn="r" rtl="1">
+              <a:spcAft>
+                <a:spcPts val="700"/>
+              </a:spcAft>
+              <a:buFont typeface="Arial" panose="020B0604020202020204" pitchFamily="34" charset="0"/>
+              <a:buChar char="•"/>
+            </a:pPr>
+            <a:r>
+              <a:rPr sz="1300" b="0" dirty="0" err="1">
+                <a:solidFill>
+                  <a:srgbClr val="1C2430"/>
+                </a:solidFill>
+                <a:latin typeface="Vazir" panose="020B0603030804020204" pitchFamily="34" charset="-78"/>
+                <a:cs typeface="Vazir" panose="020B0603030804020204" pitchFamily="34" charset="-78"/>
+              </a:rPr>
+              <a:t>گالری</a:t>
+            </a:r>
+            <a:r>
+              <a:rPr sz="1300" b="0" dirty="0">
+                <a:solidFill>
+                  <a:srgbClr val="1C2430"/>
+                </a:solidFill>
+                <a:latin typeface="Vazir" panose="020B0603030804020204" pitchFamily="34" charset="-78"/>
+                <a:cs typeface="Vazir" panose="020B0603030804020204" pitchFamily="34" charset="-78"/>
+              </a:rPr>
+              <a:t> </a:t>
+            </a:r>
+            <a:r>
+              <a:rPr sz="1300" b="0" dirty="0" err="1">
+                <a:solidFill>
+                  <a:srgbClr val="1C2430"/>
+                </a:solidFill>
+                <a:latin typeface="Vazir" panose="020B0603030804020204" pitchFamily="34" charset="-78"/>
+                <a:cs typeface="Vazir" panose="020B0603030804020204" pitchFamily="34" charset="-78"/>
+              </a:rPr>
+              <a:t>known_faces</a:t>
+            </a:r>
+            <a:r>
+              <a:rPr sz="1300" b="0" dirty="0">
+                <a:solidFill>
+                  <a:srgbClr val="1C2430"/>
+                </a:solidFill>
+                <a:latin typeface="Vazir" panose="020B0603030804020204" pitchFamily="34" charset="-78"/>
+                <a:cs typeface="Vazir" panose="020B0603030804020204" pitchFamily="34" charset="-78"/>
+              </a:rPr>
+              <a:t> </a:t>
+            </a:r>
+            <a:r>
+              <a:rPr lang="fa-IR" sz="1300" b="0" dirty="0">
+                <a:solidFill>
+                  <a:srgbClr val="1C2430"/>
+                </a:solidFill>
+                <a:latin typeface="Vazir" panose="020B0603030804020204" pitchFamily="34" charset="-78"/>
+                <a:cs typeface="Vazir" panose="020B0603030804020204" pitchFamily="34" charset="-78"/>
+              </a:rPr>
+              <a:t> </a:t>
+            </a:r>
+            <a:r>
+              <a:rPr sz="1300" b="0" dirty="0" err="1">
+                <a:solidFill>
+                  <a:srgbClr val="1C2430"/>
+                </a:solidFill>
+                <a:latin typeface="Vazir" panose="020B0603030804020204" pitchFamily="34" charset="-78"/>
+                <a:cs typeface="Vazir" panose="020B0603030804020204" pitchFamily="34" charset="-78"/>
+              </a:rPr>
+              <a:t>با</a:t>
+            </a:r>
+            <a:r>
+              <a:rPr lang="fa-IR" sz="1300" b="0" dirty="0">
+                <a:solidFill>
+                  <a:srgbClr val="1C2430"/>
+                </a:solidFill>
+                <a:latin typeface="Vazir" panose="020B0603030804020204" pitchFamily="34" charset="-78"/>
+                <a:cs typeface="Vazir" panose="020B0603030804020204" pitchFamily="34" charset="-78"/>
+              </a:rPr>
+              <a:t> ۵</a:t>
+            </a:r>
+            <a:r>
+              <a:rPr sz="1300" b="0" dirty="0">
+                <a:solidFill>
+                  <a:srgbClr val="1C2430"/>
+                </a:solidFill>
+                <a:latin typeface="Vazir" panose="020B0603030804020204" pitchFamily="34" charset="-78"/>
+                <a:cs typeface="Vazir" panose="020B0603030804020204" pitchFamily="34" charset="-78"/>
+              </a:rPr>
+              <a:t> </a:t>
+            </a:r>
+            <a:r>
+              <a:rPr lang="fa-IR" sz="1300" b="0" dirty="0">
+                <a:solidFill>
+                  <a:srgbClr val="1C2430"/>
+                </a:solidFill>
+                <a:latin typeface="Vazir" panose="020B0603030804020204" pitchFamily="34" charset="-78"/>
+                <a:cs typeface="Vazir" panose="020B0603030804020204" pitchFamily="34" charset="-78"/>
+              </a:rPr>
+              <a:t> </a:t>
+            </a:r>
+            <a:r>
+              <a:rPr sz="1300" b="0" dirty="0" err="1">
+                <a:solidFill>
+                  <a:srgbClr val="1C2430"/>
+                </a:solidFill>
+                <a:latin typeface="Vazir" panose="020B0603030804020204" pitchFamily="34" charset="-78"/>
+                <a:cs typeface="Vazir" panose="020B0603030804020204" pitchFamily="34" charset="-78"/>
+              </a:rPr>
+              <a:t>تصویر</a:t>
+            </a:r>
+            <a:r>
+              <a:rPr sz="1300" b="0" dirty="0">
+                <a:solidFill>
+                  <a:srgbClr val="1C2430"/>
+                </a:solidFill>
+                <a:latin typeface="Vazir" panose="020B0603030804020204" pitchFamily="34" charset="-78"/>
+                <a:cs typeface="Vazir" panose="020B0603030804020204" pitchFamily="34" charset="-78"/>
+              </a:rPr>
+              <a:t> </a:t>
+            </a:r>
+            <a:r>
+              <a:rPr sz="1300" b="0" dirty="0" err="1">
+                <a:solidFill>
+                  <a:srgbClr val="1C2430"/>
+                </a:solidFill>
+                <a:latin typeface="Vazir" panose="020B0603030804020204" pitchFamily="34" charset="-78"/>
+                <a:cs typeface="Vazir" panose="020B0603030804020204" pitchFamily="34" charset="-78"/>
+              </a:rPr>
+              <a:t>ثبت‌شده</a:t>
+            </a:r>
+            <a:endParaRPr sz="1300" b="0" dirty="0">
+              <a:solidFill>
+                <a:srgbClr val="1C2430"/>
+              </a:solidFill>
+              <a:latin typeface="Vazir" panose="020B0603030804020204" pitchFamily="34" charset="-78"/>
+              <a:cs typeface="Vazir" panose="020B0603030804020204" pitchFamily="34" charset="-78"/>
+            </a:endParaRPr>
+          </a:p>
+          <a:p>
+            <a:pPr marL="285750" indent="-285750" algn="r" rtl="1">
+              <a:spcAft>
+                <a:spcPts val="700"/>
+              </a:spcAft>
+              <a:buFont typeface="Arial" panose="020B0604020202020204" pitchFamily="34" charset="0"/>
+              <a:buChar char="•"/>
+            </a:pPr>
+            <a:r>
+              <a:rPr sz="1300" b="0" dirty="0" err="1">
+                <a:solidFill>
+                  <a:srgbClr val="1C2430"/>
+                </a:solidFill>
+                <a:latin typeface="Vazir" panose="020B0603030804020204" pitchFamily="34" charset="-78"/>
+                <a:cs typeface="Vazir" panose="020B0603030804020204" pitchFamily="34" charset="-78"/>
+              </a:rPr>
+              <a:t>بدون</a:t>
+            </a:r>
+            <a:r>
+              <a:rPr sz="1300" b="0" dirty="0">
+                <a:solidFill>
+                  <a:srgbClr val="1C2430"/>
+                </a:solidFill>
+                <a:latin typeface="Vazir" panose="020B0603030804020204" pitchFamily="34" charset="-78"/>
+                <a:cs typeface="Vazir" panose="020B0603030804020204" pitchFamily="34" charset="-78"/>
+              </a:rPr>
+              <a:t> </a:t>
+            </a:r>
+            <a:r>
+              <a:rPr sz="1300" b="0" dirty="0" err="1">
+                <a:solidFill>
+                  <a:srgbClr val="1C2430"/>
+                </a:solidFill>
+                <a:latin typeface="Vazir" panose="020B0603030804020204" pitchFamily="34" charset="-78"/>
+                <a:cs typeface="Vazir" panose="020B0603030804020204" pitchFamily="34" charset="-78"/>
+              </a:rPr>
+              <a:t>گالری</a:t>
+            </a:r>
+            <a:r>
+              <a:rPr sz="1300" b="0" dirty="0">
+                <a:solidFill>
+                  <a:srgbClr val="1C2430"/>
+                </a:solidFill>
+                <a:latin typeface="Vazir" panose="020B0603030804020204" pitchFamily="34" charset="-78"/>
+                <a:cs typeface="Vazir" panose="020B0603030804020204" pitchFamily="34" charset="-78"/>
+              </a:rPr>
+              <a:t> ← </a:t>
+            </a:r>
+            <a:r>
+              <a:rPr sz="1300" b="0" dirty="0" err="1">
+                <a:solidFill>
+                  <a:srgbClr val="1C2430"/>
+                </a:solidFill>
+                <a:latin typeface="Vazir" panose="020B0603030804020204" pitchFamily="34" charset="-78"/>
+                <a:cs typeface="Vazir" panose="020B0603030804020204" pitchFamily="34" charset="-78"/>
+              </a:rPr>
+              <a:t>برچسب</a:t>
+            </a:r>
+            <a:r>
+              <a:rPr lang="en-US" sz="1300" dirty="0">
+                <a:solidFill>
+                  <a:srgbClr val="1C2430"/>
+                </a:solidFill>
+                <a:latin typeface="Vazir" panose="020B0603030804020204" pitchFamily="34" charset="-78"/>
+                <a:cs typeface="Vazir" panose="020B0603030804020204" pitchFamily="34" charset="-78"/>
+              </a:rPr>
+              <a:t>» </a:t>
+            </a:r>
+            <a:r>
+              <a:rPr sz="1300" b="0" dirty="0" err="1">
+                <a:solidFill>
+                  <a:srgbClr val="1C2430"/>
+                </a:solidFill>
+                <a:latin typeface="Vazir" panose="020B0603030804020204" pitchFamily="34" charset="-78"/>
+                <a:cs typeface="Vazir" panose="020B0603030804020204" pitchFamily="34" charset="-78"/>
+              </a:rPr>
+              <a:t>ناشنا</a:t>
+            </a:r>
+            <a:r>
+              <a:rPr lang="fa-IR" sz="1300" b="0" dirty="0">
+                <a:solidFill>
+                  <a:srgbClr val="1C2430"/>
+                </a:solidFill>
+                <a:latin typeface="Vazir" panose="020B0603030804020204" pitchFamily="34" charset="-78"/>
+                <a:cs typeface="Vazir" panose="020B0603030804020204" pitchFamily="34" charset="-78"/>
+              </a:rPr>
+              <a:t>س</a:t>
+            </a:r>
+            <a:r>
+              <a:rPr lang="en-US" sz="1300" dirty="0">
+                <a:solidFill>
+                  <a:srgbClr val="1C2430"/>
+                </a:solidFill>
+                <a:latin typeface="Vazir" panose="020B0603030804020204" pitchFamily="34" charset="-78"/>
+                <a:cs typeface="Vazir" panose="020B0603030804020204" pitchFamily="34" charset="-78"/>
+              </a:rPr>
+              <a:t>«</a:t>
+            </a:r>
+            <a:endParaRPr sz="1300" b="0" dirty="0">
+              <a:solidFill>
+                <a:srgbClr val="1C2430"/>
+              </a:solidFill>
+              <a:latin typeface="Vazir" panose="020B0603030804020204" pitchFamily="34" charset="-78"/>
+              <a:cs typeface="Vazir" panose="020B0603030804020204" pitchFamily="34" charset="-78"/>
+            </a:endParaRPr>
+          </a:p>
+          <a:p>
+            <a:pPr marL="285750" indent="-285750" algn="r" rtl="1">
+              <a:spcAft>
+                <a:spcPts val="700"/>
+              </a:spcAft>
+              <a:buFont typeface="Arial" panose="020B0604020202020204" pitchFamily="34" charset="0"/>
+              <a:buChar char="•"/>
+            </a:pPr>
+            <a:r>
+              <a:rPr sz="1300" b="0" dirty="0" err="1">
+                <a:solidFill>
+                  <a:srgbClr val="1C2430"/>
+                </a:solidFill>
+                <a:latin typeface="Vazir" panose="020B0603030804020204" pitchFamily="34" charset="-78"/>
+                <a:cs typeface="Vazir" panose="020B0603030804020204" pitchFamily="34" charset="-78"/>
+              </a:rPr>
+              <a:t>آستانه</a:t>
+            </a:r>
+            <a:r>
+              <a:rPr sz="1300" b="0" dirty="0">
+                <a:solidFill>
+                  <a:srgbClr val="1C2430"/>
+                </a:solidFill>
+                <a:latin typeface="Vazir" panose="020B0603030804020204" pitchFamily="34" charset="-78"/>
+                <a:cs typeface="Vazir" panose="020B0603030804020204" pitchFamily="34" charset="-78"/>
+              </a:rPr>
+              <a:t> </a:t>
+            </a:r>
+            <a:r>
+              <a:rPr sz="1300" b="0" dirty="0" err="1">
+                <a:solidFill>
+                  <a:srgbClr val="1C2430"/>
+                </a:solidFill>
+                <a:latin typeface="Vazir" panose="020B0603030804020204" pitchFamily="34" charset="-78"/>
+                <a:cs typeface="Vazir" panose="020B0603030804020204" pitchFamily="34" charset="-78"/>
+              </a:rPr>
+              <a:t>کسینوسی</a:t>
+            </a:r>
+            <a:r>
+              <a:rPr sz="1300" b="0" dirty="0">
+                <a:solidFill>
+                  <a:srgbClr val="1C2430"/>
+                </a:solidFill>
+                <a:latin typeface="Vazir" panose="020B0603030804020204" pitchFamily="34" charset="-78"/>
+                <a:cs typeface="Vazir" panose="020B0603030804020204" pitchFamily="34" charset="-78"/>
+              </a:rPr>
+              <a:t> </a:t>
+            </a:r>
+            <a:r>
+              <a:rPr sz="1300" b="0" dirty="0" err="1">
+                <a:solidFill>
+                  <a:srgbClr val="1C2430"/>
+                </a:solidFill>
+                <a:latin typeface="Vazir" panose="020B0603030804020204" pitchFamily="34" charset="-78"/>
+                <a:cs typeface="Vazir" panose="020B0603030804020204" pitchFamily="34" charset="-78"/>
+              </a:rPr>
+              <a:t>برای</a:t>
+            </a:r>
+            <a:r>
+              <a:rPr sz="1300" b="0" dirty="0">
+                <a:solidFill>
+                  <a:srgbClr val="1C2430"/>
+                </a:solidFill>
+                <a:latin typeface="Vazir" panose="020B0603030804020204" pitchFamily="34" charset="-78"/>
+                <a:cs typeface="Vazir" panose="020B0603030804020204" pitchFamily="34" charset="-78"/>
+              </a:rPr>
+              <a:t> </a:t>
+            </a:r>
+            <a:r>
+              <a:rPr sz="1300" b="0" dirty="0" err="1">
+                <a:solidFill>
+                  <a:srgbClr val="1C2430"/>
+                </a:solidFill>
+                <a:latin typeface="Vazir" panose="020B0603030804020204" pitchFamily="34" charset="-78"/>
+                <a:cs typeface="Vazir" panose="020B0603030804020204" pitchFamily="34" charset="-78"/>
+              </a:rPr>
+              <a:t>پذیرش</a:t>
+            </a:r>
+            <a:r>
+              <a:rPr lang="fa-IR" sz="1300" b="0" dirty="0">
+                <a:solidFill>
+                  <a:srgbClr val="1C2430"/>
+                </a:solidFill>
+                <a:latin typeface="Vazir" panose="020B0603030804020204" pitchFamily="34" charset="-78"/>
+                <a:cs typeface="Vazir" panose="020B0603030804020204" pitchFamily="34" charset="-78"/>
+              </a:rPr>
+              <a:t> </a:t>
+            </a:r>
+            <a:r>
+              <a:rPr lang="en-US" sz="1300" b="0" dirty="0">
+                <a:solidFill>
+                  <a:srgbClr val="1C2430"/>
+                </a:solidFill>
+                <a:latin typeface="Vazir" panose="020B0603030804020204" pitchFamily="34" charset="-78"/>
+                <a:cs typeface="Vazir" panose="020B0603030804020204" pitchFamily="34" charset="-78"/>
+              </a:rPr>
+              <a:t>/</a:t>
+            </a:r>
+            <a:r>
+              <a:rPr lang="fa-IR" sz="1300" b="0" dirty="0">
+                <a:solidFill>
+                  <a:srgbClr val="1C2430"/>
+                </a:solidFill>
+                <a:latin typeface="Vazir" panose="020B0603030804020204" pitchFamily="34" charset="-78"/>
+                <a:cs typeface="Vazir" panose="020B0603030804020204" pitchFamily="34" charset="-78"/>
+              </a:rPr>
+              <a:t> </a:t>
+            </a:r>
+            <a:r>
+              <a:rPr sz="1300" b="0" dirty="0">
+                <a:solidFill>
+                  <a:srgbClr val="1C2430"/>
+                </a:solidFill>
+                <a:latin typeface="Vazir" panose="020B0603030804020204" pitchFamily="34" charset="-78"/>
+                <a:cs typeface="Vazir" panose="020B0603030804020204" pitchFamily="34" charset="-78"/>
+              </a:rPr>
+              <a:t> </a:t>
+            </a:r>
+            <a:r>
+              <a:rPr sz="1300" b="0" dirty="0" err="1">
+                <a:solidFill>
+                  <a:srgbClr val="1C2430"/>
+                </a:solidFill>
+                <a:latin typeface="Vazir" panose="020B0603030804020204" pitchFamily="34" charset="-78"/>
+                <a:cs typeface="Vazir" panose="020B0603030804020204" pitchFamily="34" charset="-78"/>
+              </a:rPr>
+              <a:t>رد</a:t>
+            </a:r>
+            <a:endParaRPr lang="fa-IR" sz="1300" dirty="0">
+              <a:solidFill>
+                <a:srgbClr val="1C2430"/>
+              </a:solidFill>
+              <a:latin typeface="Vazir" panose="020B0603030804020204" pitchFamily="34" charset="-78"/>
+              <a:cs typeface="Vazir" panose="020B0603030804020204" pitchFamily="34" charset="-78"/>
+            </a:endParaRPr>
+          </a:p>
+          <a:p>
+            <a:pPr marL="285750" indent="-285750" algn="r" rtl="1">
+              <a:spcAft>
+                <a:spcPts val="700"/>
+              </a:spcAft>
+              <a:buFont typeface="Arial" panose="020B0604020202020204" pitchFamily="34" charset="0"/>
+              <a:buChar char="•"/>
+            </a:pPr>
+            <a:r>
+              <a:rPr lang="fa-IR" sz="1300" dirty="0" err="1">
+                <a:solidFill>
+                  <a:srgbClr val="1C2430"/>
+                </a:solidFill>
+                <a:latin typeface="Vazir" panose="020B0603030804020204" pitchFamily="34" charset="-78"/>
+                <a:cs typeface="Vazir" panose="020B0603030804020204" pitchFamily="34" charset="-78"/>
+              </a:rPr>
+              <a:t>تست‌ها</a:t>
+            </a:r>
+            <a:r>
+              <a:rPr lang="fa-IR" sz="1300" dirty="0">
+                <a:solidFill>
+                  <a:srgbClr val="1C2430"/>
+                </a:solidFill>
+                <a:latin typeface="Vazir" panose="020B0603030804020204" pitchFamily="34" charset="-78"/>
+                <a:cs typeface="Vazir" panose="020B0603030804020204" pitchFamily="34" charset="-78"/>
+              </a:rPr>
+              <a:t>:</a:t>
+            </a:r>
+          </a:p>
+          <a:p>
+            <a:pPr algn="ctr">
               <a:spcAft>
                 <a:spcPts val="700"/>
               </a:spcAft>
             </a:pPr>
             <a:r>
-              <a:rPr sz="1300" b="0">
-                <a:solidFill>
-                  <a:srgbClr val="1C2430"/>
-                </a:solidFill>
-                <a:latin typeface="Vazir" panose="020B0603030804020204" pitchFamily="34" charset="-78"/>
-                <a:cs typeface="Vazir" panose="020B0603030804020204" pitchFamily="34" charset="-78"/>
-              </a:rPr>
-              <a:t>• Facenet512 از پیش‌آموزش‌دیده – بدون train از صفر</a:t>
-            </a:r>
-          </a:p>
-          <a:p>
-            <a:pPr algn="r" rtl="1">
-              <a:spcAft>
-                <a:spcPts val="700"/>
-              </a:spcAft>
-            </a:pPr>
-            <a:r>
-              <a:rPr sz="1300" b="0">
-                <a:solidFill>
-                  <a:srgbClr val="1C2430"/>
-                </a:solidFill>
-                <a:latin typeface="Vazir" panose="020B0603030804020204" pitchFamily="34" charset="-78"/>
-                <a:cs typeface="Vazir" panose="020B0603030804020204" pitchFamily="34" charset="-78"/>
-              </a:rPr>
-              <a:t>• گالری known_faces با ۵ تصویر ثبت‌شده</a:t>
-            </a:r>
-          </a:p>
-          <a:p>
-            <a:pPr algn="r" rtl="1">
-              <a:spcAft>
-                <a:spcPts val="700"/>
-              </a:spcAft>
-            </a:pPr>
-            <a:r>
-              <a:rPr sz="1300" b="0">
-                <a:solidFill>
-                  <a:srgbClr val="1C2430"/>
-                </a:solidFill>
-                <a:latin typeface="Vazir" panose="020B0603030804020204" pitchFamily="34" charset="-78"/>
-                <a:cs typeface="Vazir" panose="020B0603030804020204" pitchFamily="34" charset="-78"/>
-              </a:rPr>
-              <a:t>• بدون گالری ← برچسب «ناشناس»</a:t>
-            </a:r>
-          </a:p>
-          <a:p>
-            <a:pPr algn="r" rtl="1">
-              <a:spcAft>
-                <a:spcPts val="700"/>
-              </a:spcAft>
-            </a:pPr>
-            <a:r>
-              <a:rPr sz="1300" b="0">
-                <a:solidFill>
-                  <a:srgbClr val="1C2430"/>
-                </a:solidFill>
-                <a:latin typeface="Vazir" panose="020B0603030804020204" pitchFamily="34" charset="-78"/>
-                <a:cs typeface="Vazir" panose="020B0603030804020204" pitchFamily="34" charset="-78"/>
-              </a:rPr>
-              <a:t>• آستانه کسینوسی برای پذیرش / رد</a:t>
-            </a:r>
-          </a:p>
-          <a:p>
-            <a:pPr algn="r" rtl="1">
-              <a:spcAft>
-                <a:spcPts val="700"/>
-              </a:spcAft>
-            </a:pPr>
-            <a:r>
-              <a:rPr sz="1300" b="0">
-                <a:solidFill>
-                  <a:srgbClr val="1C2430"/>
-                </a:solidFill>
-                <a:latin typeface="Vazir" panose="020B0603030804020204" pitchFamily="34" charset="-78"/>
-                <a:cs typeface="Vazir" panose="020B0603030804020204" pitchFamily="34" charset="-78"/>
-              </a:rPr>
-              <a:t>• تست‌ها: smoke_test PASS؛ / و /api/status = ۲۰۰</a:t>
+              <a:rPr lang="fa-IR" sz="1300" dirty="0">
+                <a:solidFill>
+                  <a:srgbClr val="1C2430"/>
+                </a:solidFill>
+                <a:latin typeface="Vazir" panose="020B0603030804020204" pitchFamily="34" charset="-78"/>
+                <a:cs typeface="Vazir" panose="020B0603030804020204" pitchFamily="34" charset="-78"/>
+              </a:rPr>
+              <a:t> </a:t>
+            </a:r>
+            <a:r>
+              <a:rPr lang="en-US" sz="1300" dirty="0" err="1">
+                <a:solidFill>
+                  <a:srgbClr val="1C2430"/>
+                </a:solidFill>
+                <a:latin typeface="Vazir" panose="020B0603030804020204" pitchFamily="34" charset="-78"/>
+                <a:cs typeface="Vazir" panose="020B0603030804020204" pitchFamily="34" charset="-78"/>
+              </a:rPr>
+              <a:t>smoke_test</a:t>
+            </a:r>
+            <a:r>
+              <a:rPr lang="en-US" sz="1300" dirty="0">
+                <a:solidFill>
+                  <a:srgbClr val="1C2430"/>
+                </a:solidFill>
+                <a:latin typeface="Vazir" panose="020B0603030804020204" pitchFamily="34" charset="-78"/>
+                <a:cs typeface="Vazir" panose="020B0603030804020204" pitchFamily="34" charset="-78"/>
+              </a:rPr>
+              <a:t>: PASS</a:t>
+            </a:r>
+            <a:br>
+              <a:rPr lang="fa-IR" sz="1300" dirty="0">
+                <a:solidFill>
+                  <a:srgbClr val="1C2430"/>
+                </a:solidFill>
+                <a:latin typeface="Vazir" panose="020B0603030804020204" pitchFamily="34" charset="-78"/>
+                <a:cs typeface="Vazir" panose="020B0603030804020204" pitchFamily="34" charset="-78"/>
+              </a:rPr>
+            </a:br>
+            <a:r>
+              <a:rPr lang="en-US" sz="1300" dirty="0">
+                <a:solidFill>
+                  <a:srgbClr val="1C2430"/>
+                </a:solidFill>
+                <a:latin typeface="Vazir" panose="020B0603030804020204" pitchFamily="34" charset="-78"/>
+                <a:cs typeface="Vazir" panose="020B0603030804020204" pitchFamily="34" charset="-78"/>
+              </a:rPr>
+              <a:t>/</a:t>
+            </a:r>
+            <a:r>
+              <a:rPr lang="en-US" sz="1300" dirty="0" err="1">
+                <a:solidFill>
+                  <a:srgbClr val="1C2430"/>
+                </a:solidFill>
+                <a:latin typeface="Vazir" panose="020B0603030804020204" pitchFamily="34" charset="-78"/>
+                <a:cs typeface="Vazir" panose="020B0603030804020204" pitchFamily="34" charset="-78"/>
+              </a:rPr>
+              <a:t>api</a:t>
+            </a:r>
+            <a:r>
+              <a:rPr lang="en-US" sz="1300" dirty="0">
+                <a:solidFill>
+                  <a:srgbClr val="1C2430"/>
+                </a:solidFill>
+                <a:latin typeface="Vazir" panose="020B0603030804020204" pitchFamily="34" charset="-78"/>
+                <a:cs typeface="Vazir" panose="020B0603030804020204" pitchFamily="34" charset="-78"/>
+              </a:rPr>
+              <a:t>/status = </a:t>
+            </a:r>
+            <a:r>
+              <a:rPr lang="fa-IR" sz="1300" dirty="0">
+                <a:solidFill>
+                  <a:srgbClr val="1C2430"/>
+                </a:solidFill>
+                <a:latin typeface="Vazir" panose="020B0603030804020204" pitchFamily="34" charset="-78"/>
+                <a:cs typeface="Vazir" panose="020B0603030804020204" pitchFamily="34" charset="-78"/>
+              </a:rPr>
+              <a:t> 200</a:t>
             </a:r>
           </a:p>
         </p:txBody>
@@ -13681,89 +15317,724 @@
           </a:bodyPr>
           <a:lstStyle/>
           <a:p>
-            <a:pPr algn="r" rtl="1">
+            <a:pPr marL="285750" indent="-285750" algn="r" rtl="1">
               <a:spcAft>
                 <a:spcPts val="1100"/>
               </a:spcAft>
+              <a:buFont typeface="Arial" panose="020B0604020202020204" pitchFamily="34" charset="0"/>
+              <a:buChar char="•"/>
             </a:pPr>
             <a:r>
-              <a:rPr sz="1300" b="0">
-                <a:solidFill>
-                  <a:srgbClr val="1C2430"/>
-                </a:solidFill>
-                <a:latin typeface="Vazir" panose="020B0603030804020204" pitchFamily="34" charset="-78"/>
-                <a:cs typeface="Vazir" panose="020B0603030804020204" pitchFamily="34" charset="-78"/>
-              </a:rPr>
-              <a:t>• DeepFace وابستگی سنگین به TensorFlow دارد</a:t>
-            </a:r>
-          </a:p>
-          <a:p>
-            <a:pPr algn="r" rtl="1">
+              <a:rPr sz="1300" b="0" dirty="0" err="1">
+                <a:solidFill>
+                  <a:srgbClr val="1C2430"/>
+                </a:solidFill>
+                <a:latin typeface="Vazir" panose="020B0603030804020204" pitchFamily="34" charset="-78"/>
+                <a:cs typeface="Vazir" panose="020B0603030804020204" pitchFamily="34" charset="-78"/>
+              </a:rPr>
+              <a:t>DeepFace</a:t>
+            </a:r>
+            <a:r>
+              <a:rPr sz="1300" b="0" dirty="0">
+                <a:solidFill>
+                  <a:srgbClr val="1C2430"/>
+                </a:solidFill>
+                <a:latin typeface="Vazir" panose="020B0603030804020204" pitchFamily="34" charset="-78"/>
+                <a:cs typeface="Vazir" panose="020B0603030804020204" pitchFamily="34" charset="-78"/>
+              </a:rPr>
+              <a:t> </a:t>
+            </a:r>
+            <a:r>
+              <a:rPr sz="1300" b="0" dirty="0" err="1">
+                <a:solidFill>
+                  <a:srgbClr val="1C2430"/>
+                </a:solidFill>
+                <a:latin typeface="Vazir" panose="020B0603030804020204" pitchFamily="34" charset="-78"/>
+                <a:cs typeface="Vazir" panose="020B0603030804020204" pitchFamily="34" charset="-78"/>
+              </a:rPr>
+              <a:t>وابستگی</a:t>
+            </a:r>
+            <a:r>
+              <a:rPr sz="1300" b="0" dirty="0">
+                <a:solidFill>
+                  <a:srgbClr val="1C2430"/>
+                </a:solidFill>
+                <a:latin typeface="Vazir" panose="020B0603030804020204" pitchFamily="34" charset="-78"/>
+                <a:cs typeface="Vazir" panose="020B0603030804020204" pitchFamily="34" charset="-78"/>
+              </a:rPr>
+              <a:t> </a:t>
+            </a:r>
+            <a:r>
+              <a:rPr sz="1300" b="0" dirty="0" err="1">
+                <a:solidFill>
+                  <a:srgbClr val="1C2430"/>
+                </a:solidFill>
+                <a:latin typeface="Vazir" panose="020B0603030804020204" pitchFamily="34" charset="-78"/>
+                <a:cs typeface="Vazir" panose="020B0603030804020204" pitchFamily="34" charset="-78"/>
+              </a:rPr>
+              <a:t>سنگین</a:t>
+            </a:r>
+            <a:r>
+              <a:rPr sz="1300" b="0" dirty="0">
+                <a:solidFill>
+                  <a:srgbClr val="1C2430"/>
+                </a:solidFill>
+                <a:latin typeface="Vazir" panose="020B0603030804020204" pitchFamily="34" charset="-78"/>
+                <a:cs typeface="Vazir" panose="020B0603030804020204" pitchFamily="34" charset="-78"/>
+              </a:rPr>
+              <a:t> </a:t>
+            </a:r>
+            <a:r>
+              <a:rPr sz="1300" b="0" dirty="0" err="1">
+                <a:solidFill>
+                  <a:srgbClr val="1C2430"/>
+                </a:solidFill>
+                <a:latin typeface="Vazir" panose="020B0603030804020204" pitchFamily="34" charset="-78"/>
+                <a:cs typeface="Vazir" panose="020B0603030804020204" pitchFamily="34" charset="-78"/>
+              </a:rPr>
+              <a:t>به</a:t>
+            </a:r>
+            <a:r>
+              <a:rPr sz="1300" b="0" dirty="0">
+                <a:solidFill>
+                  <a:srgbClr val="1C2430"/>
+                </a:solidFill>
+                <a:latin typeface="Vazir" panose="020B0603030804020204" pitchFamily="34" charset="-78"/>
+                <a:cs typeface="Vazir" panose="020B0603030804020204" pitchFamily="34" charset="-78"/>
+              </a:rPr>
+              <a:t> TensorFlow </a:t>
+            </a:r>
+            <a:r>
+              <a:rPr lang="fa-IR" sz="1300" b="0" dirty="0">
+                <a:solidFill>
+                  <a:srgbClr val="1C2430"/>
+                </a:solidFill>
+                <a:latin typeface="Vazir" panose="020B0603030804020204" pitchFamily="34" charset="-78"/>
+                <a:cs typeface="Vazir" panose="020B0603030804020204" pitchFamily="34" charset="-78"/>
+              </a:rPr>
+              <a:t> </a:t>
+            </a:r>
+            <a:r>
+              <a:rPr sz="1300" b="0" dirty="0" err="1">
+                <a:solidFill>
+                  <a:srgbClr val="1C2430"/>
+                </a:solidFill>
+                <a:latin typeface="Vazir" panose="020B0603030804020204" pitchFamily="34" charset="-78"/>
+                <a:cs typeface="Vazir" panose="020B0603030804020204" pitchFamily="34" charset="-78"/>
+              </a:rPr>
+              <a:t>دارد</a:t>
+            </a:r>
+            <a:endParaRPr sz="1300" b="0" dirty="0">
+              <a:solidFill>
+                <a:srgbClr val="1C2430"/>
+              </a:solidFill>
+              <a:latin typeface="Vazir" panose="020B0603030804020204" pitchFamily="34" charset="-78"/>
+              <a:cs typeface="Vazir" panose="020B0603030804020204" pitchFamily="34" charset="-78"/>
+            </a:endParaRPr>
+          </a:p>
+          <a:p>
+            <a:pPr marL="285750" indent="-285750" algn="r" rtl="1">
               <a:spcAft>
                 <a:spcPts val="1100"/>
               </a:spcAft>
+              <a:buFont typeface="Arial" panose="020B0604020202020204" pitchFamily="34" charset="0"/>
+              <a:buChar char="•"/>
             </a:pPr>
             <a:r>
-              <a:rPr sz="1300" b="0">
-                <a:solidFill>
-                  <a:srgbClr val="1C2430"/>
-                </a:solidFill>
-                <a:latin typeface="Vazir" panose="020B0603030804020204" pitchFamily="34" charset="-78"/>
-                <a:cs typeface="Vazir" panose="020B0603030804020204" pitchFamily="34" charset="-78"/>
-              </a:rPr>
-              <a:t>• استریم MJPEG عمدتاً برای یک کلاینت همزمان</a:t>
-            </a:r>
-          </a:p>
-          <a:p>
-            <a:pPr algn="r" rtl="1">
+              <a:rPr sz="1300" b="0" dirty="0" err="1">
+                <a:solidFill>
+                  <a:srgbClr val="1C2430"/>
+                </a:solidFill>
+                <a:latin typeface="Vazir" panose="020B0603030804020204" pitchFamily="34" charset="-78"/>
+                <a:cs typeface="Vazir" panose="020B0603030804020204" pitchFamily="34" charset="-78"/>
+              </a:rPr>
+              <a:t>استریم</a:t>
+            </a:r>
+            <a:r>
+              <a:rPr sz="1300" b="0" dirty="0">
+                <a:solidFill>
+                  <a:srgbClr val="1C2430"/>
+                </a:solidFill>
+                <a:latin typeface="Vazir" panose="020B0603030804020204" pitchFamily="34" charset="-78"/>
+                <a:cs typeface="Vazir" panose="020B0603030804020204" pitchFamily="34" charset="-78"/>
+              </a:rPr>
+              <a:t> MJPEG </a:t>
+            </a:r>
+            <a:r>
+              <a:rPr lang="fa-IR" sz="1300" b="0" dirty="0">
+                <a:solidFill>
+                  <a:srgbClr val="1C2430"/>
+                </a:solidFill>
+                <a:latin typeface="Vazir" panose="020B0603030804020204" pitchFamily="34" charset="-78"/>
+                <a:cs typeface="Vazir" panose="020B0603030804020204" pitchFamily="34" charset="-78"/>
+              </a:rPr>
+              <a:t> </a:t>
+            </a:r>
+            <a:r>
+              <a:rPr sz="1300" b="0" dirty="0" err="1">
+                <a:solidFill>
+                  <a:srgbClr val="1C2430"/>
+                </a:solidFill>
+                <a:latin typeface="Vazir" panose="020B0603030804020204" pitchFamily="34" charset="-78"/>
+                <a:cs typeface="Vazir" panose="020B0603030804020204" pitchFamily="34" charset="-78"/>
+              </a:rPr>
+              <a:t>عمدتاً</a:t>
+            </a:r>
+            <a:r>
+              <a:rPr sz="1300" b="0" dirty="0">
+                <a:solidFill>
+                  <a:srgbClr val="1C2430"/>
+                </a:solidFill>
+                <a:latin typeface="Vazir" panose="020B0603030804020204" pitchFamily="34" charset="-78"/>
+                <a:cs typeface="Vazir" panose="020B0603030804020204" pitchFamily="34" charset="-78"/>
+              </a:rPr>
+              <a:t> </a:t>
+            </a:r>
+            <a:r>
+              <a:rPr sz="1300" b="0" dirty="0" err="1">
+                <a:solidFill>
+                  <a:srgbClr val="1C2430"/>
+                </a:solidFill>
+                <a:latin typeface="Vazir" panose="020B0603030804020204" pitchFamily="34" charset="-78"/>
+                <a:cs typeface="Vazir" panose="020B0603030804020204" pitchFamily="34" charset="-78"/>
+              </a:rPr>
+              <a:t>برای</a:t>
+            </a:r>
+            <a:r>
+              <a:rPr sz="1300" b="0" dirty="0">
+                <a:solidFill>
+                  <a:srgbClr val="1C2430"/>
+                </a:solidFill>
+                <a:latin typeface="Vazir" panose="020B0603030804020204" pitchFamily="34" charset="-78"/>
+                <a:cs typeface="Vazir" panose="020B0603030804020204" pitchFamily="34" charset="-78"/>
+              </a:rPr>
+              <a:t> </a:t>
+            </a:r>
+            <a:r>
+              <a:rPr sz="1300" b="0" dirty="0" err="1">
+                <a:solidFill>
+                  <a:srgbClr val="1C2430"/>
+                </a:solidFill>
+                <a:latin typeface="Vazir" panose="020B0603030804020204" pitchFamily="34" charset="-78"/>
+                <a:cs typeface="Vazir" panose="020B0603030804020204" pitchFamily="34" charset="-78"/>
+              </a:rPr>
+              <a:t>یک</a:t>
+            </a:r>
+            <a:r>
+              <a:rPr sz="1300" b="0" dirty="0">
+                <a:solidFill>
+                  <a:srgbClr val="1C2430"/>
+                </a:solidFill>
+                <a:latin typeface="Vazir" panose="020B0603030804020204" pitchFamily="34" charset="-78"/>
+                <a:cs typeface="Vazir" panose="020B0603030804020204" pitchFamily="34" charset="-78"/>
+              </a:rPr>
+              <a:t> </a:t>
+            </a:r>
+            <a:r>
+              <a:rPr sz="1300" b="0" dirty="0" err="1">
+                <a:solidFill>
+                  <a:srgbClr val="1C2430"/>
+                </a:solidFill>
+                <a:latin typeface="Vazir" panose="020B0603030804020204" pitchFamily="34" charset="-78"/>
+                <a:cs typeface="Vazir" panose="020B0603030804020204" pitchFamily="34" charset="-78"/>
+              </a:rPr>
+              <a:t>کلاینت</a:t>
+            </a:r>
+            <a:r>
+              <a:rPr sz="1300" b="0" dirty="0">
+                <a:solidFill>
+                  <a:srgbClr val="1C2430"/>
+                </a:solidFill>
+                <a:latin typeface="Vazir" panose="020B0603030804020204" pitchFamily="34" charset="-78"/>
+                <a:cs typeface="Vazir" panose="020B0603030804020204" pitchFamily="34" charset="-78"/>
+              </a:rPr>
+              <a:t> </a:t>
+            </a:r>
+            <a:r>
+              <a:rPr sz="1300" b="0" dirty="0" err="1">
+                <a:solidFill>
+                  <a:srgbClr val="1C2430"/>
+                </a:solidFill>
+                <a:latin typeface="Vazir" panose="020B0603030804020204" pitchFamily="34" charset="-78"/>
+                <a:cs typeface="Vazir" panose="020B0603030804020204" pitchFamily="34" charset="-78"/>
+              </a:rPr>
+              <a:t>همزمان</a:t>
+            </a:r>
+            <a:endParaRPr sz="1300" b="0" dirty="0">
+              <a:solidFill>
+                <a:srgbClr val="1C2430"/>
+              </a:solidFill>
+              <a:latin typeface="Vazir" panose="020B0603030804020204" pitchFamily="34" charset="-78"/>
+              <a:cs typeface="Vazir" panose="020B0603030804020204" pitchFamily="34" charset="-78"/>
+            </a:endParaRPr>
+          </a:p>
+          <a:p>
+            <a:pPr marL="285750" indent="-285750" algn="r" rtl="1">
               <a:spcAft>
                 <a:spcPts val="1100"/>
               </a:spcAft>
+              <a:buFont typeface="Arial" panose="020B0604020202020204" pitchFamily="34" charset="0"/>
+              <a:buChar char="•"/>
             </a:pPr>
             <a:r>
-              <a:rPr sz="1300" b="0">
-                <a:solidFill>
-                  <a:srgbClr val="1C2430"/>
-                </a:solidFill>
-                <a:latin typeface="Vazir" panose="020B0603030804020204" pitchFamily="34" charset="-78"/>
-                <a:cs typeface="Vazir" panose="020B0603030804020204" pitchFamily="34" charset="-78"/>
-              </a:rPr>
-              <a:t>• شناسایی چهره روی برش کلی بدن، نه ROI دقیق صورت</a:t>
-            </a:r>
-          </a:p>
-          <a:p>
-            <a:pPr algn="r" rtl="1">
+              <a:rPr sz="1300" b="0" dirty="0" err="1">
+                <a:solidFill>
+                  <a:srgbClr val="1C2430"/>
+                </a:solidFill>
+                <a:latin typeface="Vazir" panose="020B0603030804020204" pitchFamily="34" charset="-78"/>
+                <a:cs typeface="Vazir" panose="020B0603030804020204" pitchFamily="34" charset="-78"/>
+              </a:rPr>
+              <a:t>شناسایی</a:t>
+            </a:r>
+            <a:r>
+              <a:rPr sz="1300" b="0" dirty="0">
+                <a:solidFill>
+                  <a:srgbClr val="1C2430"/>
+                </a:solidFill>
+                <a:latin typeface="Vazir" panose="020B0603030804020204" pitchFamily="34" charset="-78"/>
+                <a:cs typeface="Vazir" panose="020B0603030804020204" pitchFamily="34" charset="-78"/>
+              </a:rPr>
+              <a:t> </a:t>
+            </a:r>
+            <a:r>
+              <a:rPr sz="1300" b="0" dirty="0" err="1">
+                <a:solidFill>
+                  <a:srgbClr val="1C2430"/>
+                </a:solidFill>
+                <a:latin typeface="Vazir" panose="020B0603030804020204" pitchFamily="34" charset="-78"/>
+                <a:cs typeface="Vazir" panose="020B0603030804020204" pitchFamily="34" charset="-78"/>
+              </a:rPr>
+              <a:t>چهره</a:t>
+            </a:r>
+            <a:r>
+              <a:rPr sz="1300" b="0" dirty="0">
+                <a:solidFill>
+                  <a:srgbClr val="1C2430"/>
+                </a:solidFill>
+                <a:latin typeface="Vazir" panose="020B0603030804020204" pitchFamily="34" charset="-78"/>
+                <a:cs typeface="Vazir" panose="020B0603030804020204" pitchFamily="34" charset="-78"/>
+              </a:rPr>
+              <a:t> </a:t>
+            </a:r>
+            <a:r>
+              <a:rPr sz="1300" b="0" dirty="0" err="1">
+                <a:solidFill>
+                  <a:srgbClr val="1C2430"/>
+                </a:solidFill>
+                <a:latin typeface="Vazir" panose="020B0603030804020204" pitchFamily="34" charset="-78"/>
+                <a:cs typeface="Vazir" panose="020B0603030804020204" pitchFamily="34" charset="-78"/>
+              </a:rPr>
+              <a:t>روی</a:t>
+            </a:r>
+            <a:r>
+              <a:rPr sz="1300" b="0" dirty="0">
+                <a:solidFill>
+                  <a:srgbClr val="1C2430"/>
+                </a:solidFill>
+                <a:latin typeface="Vazir" panose="020B0603030804020204" pitchFamily="34" charset="-78"/>
+                <a:cs typeface="Vazir" panose="020B0603030804020204" pitchFamily="34" charset="-78"/>
+              </a:rPr>
+              <a:t> </a:t>
+            </a:r>
+            <a:r>
+              <a:rPr sz="1300" b="0" dirty="0" err="1">
+                <a:solidFill>
+                  <a:srgbClr val="1C2430"/>
+                </a:solidFill>
+                <a:latin typeface="Vazir" panose="020B0603030804020204" pitchFamily="34" charset="-78"/>
+                <a:cs typeface="Vazir" panose="020B0603030804020204" pitchFamily="34" charset="-78"/>
+              </a:rPr>
+              <a:t>برش</a:t>
+            </a:r>
+            <a:r>
+              <a:rPr sz="1300" b="0" dirty="0">
+                <a:solidFill>
+                  <a:srgbClr val="1C2430"/>
+                </a:solidFill>
+                <a:latin typeface="Vazir" panose="020B0603030804020204" pitchFamily="34" charset="-78"/>
+                <a:cs typeface="Vazir" panose="020B0603030804020204" pitchFamily="34" charset="-78"/>
+              </a:rPr>
+              <a:t> </a:t>
+            </a:r>
+            <a:r>
+              <a:rPr sz="1300" b="0" dirty="0" err="1">
+                <a:solidFill>
+                  <a:srgbClr val="1C2430"/>
+                </a:solidFill>
+                <a:latin typeface="Vazir" panose="020B0603030804020204" pitchFamily="34" charset="-78"/>
+                <a:cs typeface="Vazir" panose="020B0603030804020204" pitchFamily="34" charset="-78"/>
+              </a:rPr>
+              <a:t>کلی</a:t>
+            </a:r>
+            <a:r>
+              <a:rPr sz="1300" b="0" dirty="0">
+                <a:solidFill>
+                  <a:srgbClr val="1C2430"/>
+                </a:solidFill>
+                <a:latin typeface="Vazir" panose="020B0603030804020204" pitchFamily="34" charset="-78"/>
+                <a:cs typeface="Vazir" panose="020B0603030804020204" pitchFamily="34" charset="-78"/>
+              </a:rPr>
+              <a:t> </a:t>
+            </a:r>
+            <a:r>
+              <a:rPr sz="1300" b="0" dirty="0" err="1">
+                <a:solidFill>
+                  <a:srgbClr val="1C2430"/>
+                </a:solidFill>
+                <a:latin typeface="Vazir" panose="020B0603030804020204" pitchFamily="34" charset="-78"/>
+                <a:cs typeface="Vazir" panose="020B0603030804020204" pitchFamily="34" charset="-78"/>
+              </a:rPr>
+              <a:t>بدن</a:t>
+            </a:r>
+            <a:r>
+              <a:rPr sz="1300" b="0" dirty="0">
+                <a:solidFill>
+                  <a:srgbClr val="1C2430"/>
+                </a:solidFill>
+                <a:latin typeface="Vazir" panose="020B0603030804020204" pitchFamily="34" charset="-78"/>
+                <a:cs typeface="Vazir" panose="020B0603030804020204" pitchFamily="34" charset="-78"/>
+              </a:rPr>
+              <a:t>، </a:t>
+            </a:r>
+            <a:r>
+              <a:rPr sz="1300" b="0" dirty="0" err="1">
+                <a:solidFill>
+                  <a:srgbClr val="1C2430"/>
+                </a:solidFill>
+                <a:latin typeface="Vazir" panose="020B0603030804020204" pitchFamily="34" charset="-78"/>
+                <a:cs typeface="Vazir" panose="020B0603030804020204" pitchFamily="34" charset="-78"/>
+              </a:rPr>
+              <a:t>نه</a:t>
+            </a:r>
+            <a:r>
+              <a:rPr sz="1300" b="0" dirty="0">
+                <a:solidFill>
+                  <a:srgbClr val="1C2430"/>
+                </a:solidFill>
+                <a:latin typeface="Vazir" panose="020B0603030804020204" pitchFamily="34" charset="-78"/>
+                <a:cs typeface="Vazir" panose="020B0603030804020204" pitchFamily="34" charset="-78"/>
+              </a:rPr>
+              <a:t> ROI </a:t>
+            </a:r>
+            <a:r>
+              <a:rPr lang="fa-IR" sz="1300" b="0" dirty="0">
+                <a:solidFill>
+                  <a:srgbClr val="1C2430"/>
+                </a:solidFill>
+                <a:latin typeface="Vazir" panose="020B0603030804020204" pitchFamily="34" charset="-78"/>
+                <a:cs typeface="Vazir" panose="020B0603030804020204" pitchFamily="34" charset="-78"/>
+              </a:rPr>
+              <a:t> </a:t>
+            </a:r>
+            <a:r>
+              <a:rPr sz="1300" b="0" dirty="0" err="1">
+                <a:solidFill>
+                  <a:srgbClr val="1C2430"/>
+                </a:solidFill>
+                <a:latin typeface="Vazir" panose="020B0603030804020204" pitchFamily="34" charset="-78"/>
+                <a:cs typeface="Vazir" panose="020B0603030804020204" pitchFamily="34" charset="-78"/>
+              </a:rPr>
+              <a:t>دقیق</a:t>
+            </a:r>
+            <a:r>
+              <a:rPr sz="1300" b="0" dirty="0">
+                <a:solidFill>
+                  <a:srgbClr val="1C2430"/>
+                </a:solidFill>
+                <a:latin typeface="Vazir" panose="020B0603030804020204" pitchFamily="34" charset="-78"/>
+                <a:cs typeface="Vazir" panose="020B0603030804020204" pitchFamily="34" charset="-78"/>
+              </a:rPr>
+              <a:t> </a:t>
+            </a:r>
+            <a:r>
+              <a:rPr sz="1300" b="0" dirty="0" err="1">
+                <a:solidFill>
+                  <a:srgbClr val="1C2430"/>
+                </a:solidFill>
+                <a:latin typeface="Vazir" panose="020B0603030804020204" pitchFamily="34" charset="-78"/>
+                <a:cs typeface="Vazir" panose="020B0603030804020204" pitchFamily="34" charset="-78"/>
+              </a:rPr>
+              <a:t>صورت</a:t>
+            </a:r>
+            <a:endParaRPr sz="1300" b="0" dirty="0">
+              <a:solidFill>
+                <a:srgbClr val="1C2430"/>
+              </a:solidFill>
+              <a:latin typeface="Vazir" panose="020B0603030804020204" pitchFamily="34" charset="-78"/>
+              <a:cs typeface="Vazir" panose="020B0603030804020204" pitchFamily="34" charset="-78"/>
+            </a:endParaRPr>
+          </a:p>
+          <a:p>
+            <a:pPr marL="285750" indent="-285750" algn="r" rtl="1">
               <a:spcAft>
                 <a:spcPts val="1100"/>
               </a:spcAft>
+              <a:buFont typeface="Arial" panose="020B0604020202020204" pitchFamily="34" charset="0"/>
+              <a:buChar char="•"/>
             </a:pPr>
             <a:r>
-              <a:rPr sz="1300" b="0">
-                <a:solidFill>
-                  <a:srgbClr val="1C2430"/>
-                </a:solidFill>
-                <a:latin typeface="Vazir" panose="020B0603030804020204" pitchFamily="34" charset="-78"/>
-                <a:cs typeface="Vazir" panose="020B0603030804020204" pitchFamily="34" charset="-78"/>
-              </a:rPr>
-              <a:t>• ارتقای بیشتر mAP نیازمند GPU قوی‌تر و داده محلی</a:t>
-            </a:r>
-          </a:p>
-          <a:p>
-            <a:pPr algn="r" rtl="1">
+              <a:rPr sz="1300" b="0" dirty="0" err="1">
+                <a:solidFill>
+                  <a:srgbClr val="1C2430"/>
+                </a:solidFill>
+                <a:latin typeface="Vazir" panose="020B0603030804020204" pitchFamily="34" charset="-78"/>
+                <a:cs typeface="Vazir" panose="020B0603030804020204" pitchFamily="34" charset="-78"/>
+              </a:rPr>
+              <a:t>ارتقای</a:t>
+            </a:r>
+            <a:r>
+              <a:rPr sz="1300" b="0" dirty="0">
+                <a:solidFill>
+                  <a:srgbClr val="1C2430"/>
+                </a:solidFill>
+                <a:latin typeface="Vazir" panose="020B0603030804020204" pitchFamily="34" charset="-78"/>
+                <a:cs typeface="Vazir" panose="020B0603030804020204" pitchFamily="34" charset="-78"/>
+              </a:rPr>
+              <a:t> </a:t>
+            </a:r>
+            <a:r>
+              <a:rPr sz="1300" b="0" dirty="0" err="1">
+                <a:solidFill>
+                  <a:srgbClr val="1C2430"/>
+                </a:solidFill>
+                <a:latin typeface="Vazir" panose="020B0603030804020204" pitchFamily="34" charset="-78"/>
+                <a:cs typeface="Vazir" panose="020B0603030804020204" pitchFamily="34" charset="-78"/>
+              </a:rPr>
+              <a:t>بیشتر</a:t>
+            </a:r>
+            <a:r>
+              <a:rPr sz="1300" b="0" dirty="0">
+                <a:solidFill>
+                  <a:srgbClr val="1C2430"/>
+                </a:solidFill>
+                <a:latin typeface="Vazir" panose="020B0603030804020204" pitchFamily="34" charset="-78"/>
+                <a:cs typeface="Vazir" panose="020B0603030804020204" pitchFamily="34" charset="-78"/>
+              </a:rPr>
+              <a:t> </a:t>
+            </a:r>
+            <a:r>
+              <a:rPr sz="1300" b="0" dirty="0" err="1">
+                <a:solidFill>
+                  <a:srgbClr val="1C2430"/>
+                </a:solidFill>
+                <a:latin typeface="Vazir" panose="020B0603030804020204" pitchFamily="34" charset="-78"/>
+                <a:cs typeface="Vazir" panose="020B0603030804020204" pitchFamily="34" charset="-78"/>
+              </a:rPr>
+              <a:t>mAP</a:t>
+            </a:r>
+            <a:r>
+              <a:rPr sz="1300" b="0" dirty="0">
+                <a:solidFill>
+                  <a:srgbClr val="1C2430"/>
+                </a:solidFill>
+                <a:latin typeface="Vazir" panose="020B0603030804020204" pitchFamily="34" charset="-78"/>
+                <a:cs typeface="Vazir" panose="020B0603030804020204" pitchFamily="34" charset="-78"/>
+              </a:rPr>
+              <a:t> </a:t>
+            </a:r>
+            <a:r>
+              <a:rPr lang="fa-IR" sz="1300" b="0" dirty="0">
+                <a:solidFill>
+                  <a:srgbClr val="1C2430"/>
+                </a:solidFill>
+                <a:latin typeface="Vazir" panose="020B0603030804020204" pitchFamily="34" charset="-78"/>
+                <a:cs typeface="Vazir" panose="020B0603030804020204" pitchFamily="34" charset="-78"/>
+              </a:rPr>
+              <a:t> </a:t>
+            </a:r>
+            <a:r>
+              <a:rPr sz="1300" b="0" dirty="0" err="1">
+                <a:solidFill>
+                  <a:srgbClr val="1C2430"/>
+                </a:solidFill>
+                <a:latin typeface="Vazir" panose="020B0603030804020204" pitchFamily="34" charset="-78"/>
+                <a:cs typeface="Vazir" panose="020B0603030804020204" pitchFamily="34" charset="-78"/>
+              </a:rPr>
+              <a:t>نیازمند</a:t>
+            </a:r>
+            <a:r>
+              <a:rPr sz="1300" b="0" dirty="0">
+                <a:solidFill>
+                  <a:srgbClr val="1C2430"/>
+                </a:solidFill>
+                <a:latin typeface="Vazir" panose="020B0603030804020204" pitchFamily="34" charset="-78"/>
+                <a:cs typeface="Vazir" panose="020B0603030804020204" pitchFamily="34" charset="-78"/>
+              </a:rPr>
+              <a:t> GPU </a:t>
+            </a:r>
+            <a:r>
+              <a:rPr lang="fa-IR" sz="1300" b="0" dirty="0">
+                <a:solidFill>
+                  <a:srgbClr val="1C2430"/>
+                </a:solidFill>
+                <a:latin typeface="Vazir" panose="020B0603030804020204" pitchFamily="34" charset="-78"/>
+                <a:cs typeface="Vazir" panose="020B0603030804020204" pitchFamily="34" charset="-78"/>
+              </a:rPr>
+              <a:t> </a:t>
+            </a:r>
+            <a:r>
+              <a:rPr sz="1300" b="0" dirty="0" err="1">
+                <a:solidFill>
+                  <a:srgbClr val="1C2430"/>
+                </a:solidFill>
+                <a:latin typeface="Vazir" panose="020B0603030804020204" pitchFamily="34" charset="-78"/>
+                <a:cs typeface="Vazir" panose="020B0603030804020204" pitchFamily="34" charset="-78"/>
+              </a:rPr>
+              <a:t>قوی‌تر</a:t>
+            </a:r>
+            <a:r>
+              <a:rPr sz="1300" b="0" dirty="0">
+                <a:solidFill>
+                  <a:srgbClr val="1C2430"/>
+                </a:solidFill>
+                <a:latin typeface="Vazir" panose="020B0603030804020204" pitchFamily="34" charset="-78"/>
+                <a:cs typeface="Vazir" panose="020B0603030804020204" pitchFamily="34" charset="-78"/>
+              </a:rPr>
+              <a:t> و </a:t>
+            </a:r>
+            <a:r>
+              <a:rPr sz="1300" b="0" dirty="0" err="1">
+                <a:solidFill>
+                  <a:srgbClr val="1C2430"/>
+                </a:solidFill>
+                <a:latin typeface="Vazir" panose="020B0603030804020204" pitchFamily="34" charset="-78"/>
+                <a:cs typeface="Vazir" panose="020B0603030804020204" pitchFamily="34" charset="-78"/>
+              </a:rPr>
+              <a:t>داده</a:t>
+            </a:r>
+            <a:r>
+              <a:rPr sz="1300" b="0" dirty="0">
+                <a:solidFill>
+                  <a:srgbClr val="1C2430"/>
+                </a:solidFill>
+                <a:latin typeface="Vazir" panose="020B0603030804020204" pitchFamily="34" charset="-78"/>
+                <a:cs typeface="Vazir" panose="020B0603030804020204" pitchFamily="34" charset="-78"/>
+              </a:rPr>
+              <a:t> </a:t>
+            </a:r>
+            <a:r>
+              <a:rPr sz="1300" b="0" dirty="0" err="1">
+                <a:solidFill>
+                  <a:srgbClr val="1C2430"/>
+                </a:solidFill>
+                <a:latin typeface="Vazir" panose="020B0603030804020204" pitchFamily="34" charset="-78"/>
+                <a:cs typeface="Vazir" panose="020B0603030804020204" pitchFamily="34" charset="-78"/>
+              </a:rPr>
+              <a:t>محلی</a:t>
+            </a:r>
+            <a:endParaRPr sz="1300" b="0" dirty="0">
+              <a:solidFill>
+                <a:srgbClr val="1C2430"/>
+              </a:solidFill>
+              <a:latin typeface="Vazir" panose="020B0603030804020204" pitchFamily="34" charset="-78"/>
+              <a:cs typeface="Vazir" panose="020B0603030804020204" pitchFamily="34" charset="-78"/>
+            </a:endParaRPr>
+          </a:p>
+          <a:p>
+            <a:pPr marL="285750" indent="-285750" algn="r" rtl="1">
               <a:spcAft>
                 <a:spcPts val="1100"/>
               </a:spcAft>
+              <a:buFont typeface="Arial" panose="020B0604020202020204" pitchFamily="34" charset="0"/>
+              <a:buChar char="•"/>
             </a:pPr>
             <a:r>
-              <a:rPr sz="1300" b="0">
-                <a:solidFill>
-                  <a:srgbClr val="1C2430"/>
-                </a:solidFill>
-                <a:latin typeface="Vazir" panose="020B0603030804020204" pitchFamily="34" charset="-78"/>
-                <a:cs typeface="Vazir" panose="020B0603030804020204" pitchFamily="34" charset="-78"/>
-              </a:rPr>
-              <a:t>• صحنه‌های بسیار شلوغ همچنان چالش‌برانگیزند</a:t>
-            </a:r>
+              <a:rPr sz="1300" b="0" dirty="0" err="1">
+                <a:solidFill>
+                  <a:srgbClr val="1C2430"/>
+                </a:solidFill>
+                <a:latin typeface="Vazir" panose="020B0603030804020204" pitchFamily="34" charset="-78"/>
+                <a:cs typeface="Vazir" panose="020B0603030804020204" pitchFamily="34" charset="-78"/>
+              </a:rPr>
+              <a:t>صحنه‌های</a:t>
+            </a:r>
+            <a:r>
+              <a:rPr sz="1300" b="0" dirty="0">
+                <a:solidFill>
+                  <a:srgbClr val="1C2430"/>
+                </a:solidFill>
+                <a:latin typeface="Vazir" panose="020B0603030804020204" pitchFamily="34" charset="-78"/>
+                <a:cs typeface="Vazir" panose="020B0603030804020204" pitchFamily="34" charset="-78"/>
+              </a:rPr>
+              <a:t> </a:t>
+            </a:r>
+            <a:r>
+              <a:rPr sz="1300" b="0" dirty="0" err="1">
+                <a:solidFill>
+                  <a:srgbClr val="1C2430"/>
+                </a:solidFill>
+                <a:latin typeface="Vazir" panose="020B0603030804020204" pitchFamily="34" charset="-78"/>
+                <a:cs typeface="Vazir" panose="020B0603030804020204" pitchFamily="34" charset="-78"/>
+              </a:rPr>
+              <a:t>بسیار</a:t>
+            </a:r>
+            <a:r>
+              <a:rPr sz="1300" b="0" dirty="0">
+                <a:solidFill>
+                  <a:srgbClr val="1C2430"/>
+                </a:solidFill>
+                <a:latin typeface="Vazir" panose="020B0603030804020204" pitchFamily="34" charset="-78"/>
+                <a:cs typeface="Vazir" panose="020B0603030804020204" pitchFamily="34" charset="-78"/>
+              </a:rPr>
+              <a:t> </a:t>
+            </a:r>
+            <a:r>
+              <a:rPr sz="1300" b="0" dirty="0" err="1">
+                <a:solidFill>
+                  <a:srgbClr val="1C2430"/>
+                </a:solidFill>
+                <a:latin typeface="Vazir" panose="020B0603030804020204" pitchFamily="34" charset="-78"/>
+                <a:cs typeface="Vazir" panose="020B0603030804020204" pitchFamily="34" charset="-78"/>
+              </a:rPr>
+              <a:t>شلوغ</a:t>
+            </a:r>
+            <a:r>
+              <a:rPr sz="1300" b="0" dirty="0">
+                <a:solidFill>
+                  <a:srgbClr val="1C2430"/>
+                </a:solidFill>
+                <a:latin typeface="Vazir" panose="020B0603030804020204" pitchFamily="34" charset="-78"/>
+                <a:cs typeface="Vazir" panose="020B0603030804020204" pitchFamily="34" charset="-78"/>
+              </a:rPr>
+              <a:t> </a:t>
+            </a:r>
+            <a:r>
+              <a:rPr sz="1300" b="0" dirty="0" err="1">
+                <a:solidFill>
+                  <a:srgbClr val="1C2430"/>
+                </a:solidFill>
+                <a:latin typeface="Vazir" panose="020B0603030804020204" pitchFamily="34" charset="-78"/>
+                <a:cs typeface="Vazir" panose="020B0603030804020204" pitchFamily="34" charset="-78"/>
+              </a:rPr>
+              <a:t>همچنان</a:t>
+            </a:r>
+            <a:r>
+              <a:rPr sz="1300" b="0" dirty="0">
+                <a:solidFill>
+                  <a:srgbClr val="1C2430"/>
+                </a:solidFill>
+                <a:latin typeface="Vazir" panose="020B0603030804020204" pitchFamily="34" charset="-78"/>
+                <a:cs typeface="Vazir" panose="020B0603030804020204" pitchFamily="34" charset="-78"/>
+              </a:rPr>
+              <a:t> </a:t>
+            </a:r>
+            <a:r>
+              <a:rPr sz="1300" b="0" dirty="0" err="1">
+                <a:solidFill>
+                  <a:srgbClr val="1C2430"/>
+                </a:solidFill>
+                <a:latin typeface="Vazir" panose="020B0603030804020204" pitchFamily="34" charset="-78"/>
+                <a:cs typeface="Vazir" panose="020B0603030804020204" pitchFamily="34" charset="-78"/>
+              </a:rPr>
+              <a:t>چالش‌برانگیزند</a:t>
+            </a:r>
+            <a:endParaRPr sz="1300" b="0" dirty="0">
+              <a:solidFill>
+                <a:srgbClr val="1C2430"/>
+              </a:solidFill>
+              <a:latin typeface="Vazir" panose="020B0603030804020204" pitchFamily="34" charset="-78"/>
+              <a:cs typeface="Vazir" panose="020B0603030804020204" pitchFamily="34" charset="-78"/>
+            </a:endParaRPr>
           </a:p>
         </p:txBody>
       </p:sp>
@@ -13915,89 +16186,560 @@
           </a:bodyPr>
           <a:lstStyle/>
           <a:p>
-            <a:pPr algn="r" rtl="1">
+            <a:pPr marL="285750" indent="-285750" algn="r" rtl="1">
               <a:spcAft>
                 <a:spcPts val="1100"/>
               </a:spcAft>
+              <a:buFont typeface="Arial" panose="020B0604020202020204" pitchFamily="34" charset="0"/>
+              <a:buChar char="•"/>
             </a:pPr>
             <a:r>
-              <a:rPr sz="1300" b="0">
-                <a:solidFill>
-                  <a:srgbClr val="1C2430"/>
-                </a:solidFill>
-                <a:latin typeface="Vazir" panose="020B0603030804020204" pitchFamily="34" charset="-78"/>
-                <a:cs typeface="Vazir" panose="020B0603030804020204" pitchFamily="34" charset="-78"/>
-              </a:rPr>
-              <a:t>• آموزش روی ویدئوهای محلی دانشگاه / محیط هدف</a:t>
-            </a:r>
-          </a:p>
-          <a:p>
-            <a:pPr algn="r" rtl="1">
+              <a:rPr sz="1300" b="0" dirty="0" err="1">
+                <a:solidFill>
+                  <a:srgbClr val="1C2430"/>
+                </a:solidFill>
+                <a:latin typeface="Vazir" panose="020B0603030804020204" pitchFamily="34" charset="-78"/>
+                <a:cs typeface="Vazir" panose="020B0603030804020204" pitchFamily="34" charset="-78"/>
+              </a:rPr>
+              <a:t>آموزش</a:t>
+            </a:r>
+            <a:r>
+              <a:rPr sz="1300" b="0" dirty="0">
+                <a:solidFill>
+                  <a:srgbClr val="1C2430"/>
+                </a:solidFill>
+                <a:latin typeface="Vazir" panose="020B0603030804020204" pitchFamily="34" charset="-78"/>
+                <a:cs typeface="Vazir" panose="020B0603030804020204" pitchFamily="34" charset="-78"/>
+              </a:rPr>
+              <a:t> </a:t>
+            </a:r>
+            <a:r>
+              <a:rPr sz="1300" b="0" dirty="0" err="1">
+                <a:solidFill>
+                  <a:srgbClr val="1C2430"/>
+                </a:solidFill>
+                <a:latin typeface="Vazir" panose="020B0603030804020204" pitchFamily="34" charset="-78"/>
+                <a:cs typeface="Vazir" panose="020B0603030804020204" pitchFamily="34" charset="-78"/>
+              </a:rPr>
+              <a:t>روی</a:t>
+            </a:r>
+            <a:r>
+              <a:rPr sz="1300" b="0" dirty="0">
+                <a:solidFill>
+                  <a:srgbClr val="1C2430"/>
+                </a:solidFill>
+                <a:latin typeface="Vazir" panose="020B0603030804020204" pitchFamily="34" charset="-78"/>
+                <a:cs typeface="Vazir" panose="020B0603030804020204" pitchFamily="34" charset="-78"/>
+              </a:rPr>
+              <a:t> </a:t>
+            </a:r>
+            <a:r>
+              <a:rPr sz="1300" b="0" dirty="0" err="1">
+                <a:solidFill>
+                  <a:srgbClr val="1C2430"/>
+                </a:solidFill>
+                <a:latin typeface="Vazir" panose="020B0603030804020204" pitchFamily="34" charset="-78"/>
+                <a:cs typeface="Vazir" panose="020B0603030804020204" pitchFamily="34" charset="-78"/>
+              </a:rPr>
+              <a:t>ویدئوهای</a:t>
+            </a:r>
+            <a:r>
+              <a:rPr sz="1300" b="0" dirty="0">
+                <a:solidFill>
+                  <a:srgbClr val="1C2430"/>
+                </a:solidFill>
+                <a:latin typeface="Vazir" panose="020B0603030804020204" pitchFamily="34" charset="-78"/>
+                <a:cs typeface="Vazir" panose="020B0603030804020204" pitchFamily="34" charset="-78"/>
+              </a:rPr>
+              <a:t> </a:t>
+            </a:r>
+            <a:r>
+              <a:rPr sz="1300" b="0" dirty="0" err="1">
+                <a:solidFill>
+                  <a:srgbClr val="1C2430"/>
+                </a:solidFill>
+                <a:latin typeface="Vazir" panose="020B0603030804020204" pitchFamily="34" charset="-78"/>
+                <a:cs typeface="Vazir" panose="020B0603030804020204" pitchFamily="34" charset="-78"/>
+              </a:rPr>
+              <a:t>محلی</a:t>
+            </a:r>
+            <a:r>
+              <a:rPr sz="1300" b="0" dirty="0">
+                <a:solidFill>
+                  <a:srgbClr val="1C2430"/>
+                </a:solidFill>
+                <a:latin typeface="Vazir" panose="020B0603030804020204" pitchFamily="34" charset="-78"/>
+                <a:cs typeface="Vazir" panose="020B0603030804020204" pitchFamily="34" charset="-78"/>
+              </a:rPr>
+              <a:t> </a:t>
+            </a:r>
+            <a:r>
+              <a:rPr sz="1300" b="0" dirty="0" err="1">
+                <a:solidFill>
+                  <a:srgbClr val="1C2430"/>
+                </a:solidFill>
+                <a:latin typeface="Vazir" panose="020B0603030804020204" pitchFamily="34" charset="-78"/>
+                <a:cs typeface="Vazir" panose="020B0603030804020204" pitchFamily="34" charset="-78"/>
+              </a:rPr>
+              <a:t>دانشگاه</a:t>
+            </a:r>
+            <a:r>
+              <a:rPr sz="1300" b="0" dirty="0">
+                <a:solidFill>
+                  <a:srgbClr val="1C2430"/>
+                </a:solidFill>
+                <a:latin typeface="Vazir" panose="020B0603030804020204" pitchFamily="34" charset="-78"/>
+                <a:cs typeface="Vazir" panose="020B0603030804020204" pitchFamily="34" charset="-78"/>
+              </a:rPr>
+              <a:t> / </a:t>
+            </a:r>
+            <a:r>
+              <a:rPr sz="1300" b="0" dirty="0" err="1">
+                <a:solidFill>
+                  <a:srgbClr val="1C2430"/>
+                </a:solidFill>
+                <a:latin typeface="Vazir" panose="020B0603030804020204" pitchFamily="34" charset="-78"/>
+                <a:cs typeface="Vazir" panose="020B0603030804020204" pitchFamily="34" charset="-78"/>
+              </a:rPr>
+              <a:t>محیط</a:t>
+            </a:r>
+            <a:r>
+              <a:rPr sz="1300" b="0" dirty="0">
+                <a:solidFill>
+                  <a:srgbClr val="1C2430"/>
+                </a:solidFill>
+                <a:latin typeface="Vazir" panose="020B0603030804020204" pitchFamily="34" charset="-78"/>
+                <a:cs typeface="Vazir" panose="020B0603030804020204" pitchFamily="34" charset="-78"/>
+              </a:rPr>
+              <a:t> </a:t>
+            </a:r>
+            <a:r>
+              <a:rPr sz="1300" b="0" dirty="0" err="1">
+                <a:solidFill>
+                  <a:srgbClr val="1C2430"/>
+                </a:solidFill>
+                <a:latin typeface="Vazir" panose="020B0603030804020204" pitchFamily="34" charset="-78"/>
+                <a:cs typeface="Vazir" panose="020B0603030804020204" pitchFamily="34" charset="-78"/>
+              </a:rPr>
+              <a:t>هدف</a:t>
+            </a:r>
+            <a:endParaRPr sz="1300" b="0" dirty="0">
+              <a:solidFill>
+                <a:srgbClr val="1C2430"/>
+              </a:solidFill>
+              <a:latin typeface="Vazir" panose="020B0603030804020204" pitchFamily="34" charset="-78"/>
+              <a:cs typeface="Vazir" panose="020B0603030804020204" pitchFamily="34" charset="-78"/>
+            </a:endParaRPr>
+          </a:p>
+          <a:p>
+            <a:pPr marL="285750" indent="-285750" algn="r" rtl="1">
               <a:spcAft>
                 <a:spcPts val="1100"/>
               </a:spcAft>
+              <a:buFont typeface="Arial" panose="020B0604020202020204" pitchFamily="34" charset="0"/>
+              <a:buChar char="•"/>
             </a:pPr>
             <a:r>
-              <a:rPr sz="1300" b="0">
-                <a:solidFill>
-                  <a:srgbClr val="1C2430"/>
-                </a:solidFill>
-                <a:latin typeface="Vazir" panose="020B0603030804020204" pitchFamily="34" charset="-78"/>
-                <a:cs typeface="Vazir" panose="020B0603030804020204" pitchFamily="34" charset="-78"/>
-              </a:rPr>
-              <a:t>• استقرار با TensorRT یا ONNX برای کاهش تأخیر</a:t>
-            </a:r>
-          </a:p>
-          <a:p>
-            <a:pPr algn="r" rtl="1">
+              <a:rPr sz="1300" b="0" dirty="0" err="1">
+                <a:solidFill>
+                  <a:srgbClr val="1C2430"/>
+                </a:solidFill>
+                <a:latin typeface="Vazir" panose="020B0603030804020204" pitchFamily="34" charset="-78"/>
+                <a:cs typeface="Vazir" panose="020B0603030804020204" pitchFamily="34" charset="-78"/>
+              </a:rPr>
+              <a:t>استقرار</a:t>
+            </a:r>
+            <a:r>
+              <a:rPr sz="1300" b="0" dirty="0">
+                <a:solidFill>
+                  <a:srgbClr val="1C2430"/>
+                </a:solidFill>
+                <a:latin typeface="Vazir" panose="020B0603030804020204" pitchFamily="34" charset="-78"/>
+                <a:cs typeface="Vazir" panose="020B0603030804020204" pitchFamily="34" charset="-78"/>
+              </a:rPr>
+              <a:t> </a:t>
+            </a:r>
+            <a:r>
+              <a:rPr sz="1300" b="0" dirty="0" err="1">
+                <a:solidFill>
+                  <a:srgbClr val="1C2430"/>
+                </a:solidFill>
+                <a:latin typeface="Vazir" panose="020B0603030804020204" pitchFamily="34" charset="-78"/>
+                <a:cs typeface="Vazir" panose="020B0603030804020204" pitchFamily="34" charset="-78"/>
+              </a:rPr>
+              <a:t>باTensorRT</a:t>
+            </a:r>
+            <a:r>
+              <a:rPr sz="1300" b="0" dirty="0">
+                <a:solidFill>
+                  <a:srgbClr val="1C2430"/>
+                </a:solidFill>
+                <a:latin typeface="Vazir" panose="020B0603030804020204" pitchFamily="34" charset="-78"/>
+                <a:cs typeface="Vazir" panose="020B0603030804020204" pitchFamily="34" charset="-78"/>
+              </a:rPr>
+              <a:t> </a:t>
+            </a:r>
+            <a:r>
+              <a:rPr lang="fa-IR" sz="1300" b="0" dirty="0">
+                <a:solidFill>
+                  <a:srgbClr val="1C2430"/>
+                </a:solidFill>
+                <a:latin typeface="Vazir" panose="020B0603030804020204" pitchFamily="34" charset="-78"/>
+                <a:cs typeface="Vazir" panose="020B0603030804020204" pitchFamily="34" charset="-78"/>
+              </a:rPr>
+              <a:t> </a:t>
+            </a:r>
+            <a:r>
+              <a:rPr sz="1300" b="0" dirty="0" err="1">
+                <a:solidFill>
+                  <a:srgbClr val="1C2430"/>
+                </a:solidFill>
+                <a:latin typeface="Vazir" panose="020B0603030804020204" pitchFamily="34" charset="-78"/>
+                <a:cs typeface="Vazir" panose="020B0603030804020204" pitchFamily="34" charset="-78"/>
+              </a:rPr>
+              <a:t>یاONNX</a:t>
+            </a:r>
+            <a:r>
+              <a:rPr sz="1300" b="0" dirty="0">
+                <a:solidFill>
+                  <a:srgbClr val="1C2430"/>
+                </a:solidFill>
+                <a:latin typeface="Vazir" panose="020B0603030804020204" pitchFamily="34" charset="-78"/>
+                <a:cs typeface="Vazir" panose="020B0603030804020204" pitchFamily="34" charset="-78"/>
+              </a:rPr>
+              <a:t> </a:t>
+            </a:r>
+            <a:r>
+              <a:rPr lang="fa-IR" sz="1300" b="0" dirty="0">
+                <a:solidFill>
+                  <a:srgbClr val="1C2430"/>
+                </a:solidFill>
+                <a:latin typeface="Vazir" panose="020B0603030804020204" pitchFamily="34" charset="-78"/>
+                <a:cs typeface="Vazir" panose="020B0603030804020204" pitchFamily="34" charset="-78"/>
+              </a:rPr>
+              <a:t> </a:t>
+            </a:r>
+            <a:r>
+              <a:rPr sz="1300" b="0" dirty="0" err="1">
+                <a:solidFill>
+                  <a:srgbClr val="1C2430"/>
+                </a:solidFill>
+                <a:latin typeface="Vazir" panose="020B0603030804020204" pitchFamily="34" charset="-78"/>
+                <a:cs typeface="Vazir" panose="020B0603030804020204" pitchFamily="34" charset="-78"/>
+              </a:rPr>
+              <a:t>برای</a:t>
+            </a:r>
+            <a:r>
+              <a:rPr sz="1300" b="0" dirty="0">
+                <a:solidFill>
+                  <a:srgbClr val="1C2430"/>
+                </a:solidFill>
+                <a:latin typeface="Vazir" panose="020B0603030804020204" pitchFamily="34" charset="-78"/>
+                <a:cs typeface="Vazir" panose="020B0603030804020204" pitchFamily="34" charset="-78"/>
+              </a:rPr>
+              <a:t> </a:t>
+            </a:r>
+            <a:r>
+              <a:rPr sz="1300" b="0" dirty="0" err="1">
+                <a:solidFill>
+                  <a:srgbClr val="1C2430"/>
+                </a:solidFill>
+                <a:latin typeface="Vazir" panose="020B0603030804020204" pitchFamily="34" charset="-78"/>
+                <a:cs typeface="Vazir" panose="020B0603030804020204" pitchFamily="34" charset="-78"/>
+              </a:rPr>
+              <a:t>کاهش</a:t>
+            </a:r>
+            <a:r>
+              <a:rPr sz="1300" b="0" dirty="0">
+                <a:solidFill>
+                  <a:srgbClr val="1C2430"/>
+                </a:solidFill>
+                <a:latin typeface="Vazir" panose="020B0603030804020204" pitchFamily="34" charset="-78"/>
+                <a:cs typeface="Vazir" panose="020B0603030804020204" pitchFamily="34" charset="-78"/>
+              </a:rPr>
+              <a:t> </a:t>
+            </a:r>
+            <a:r>
+              <a:rPr sz="1300" b="0" dirty="0" err="1">
+                <a:solidFill>
+                  <a:srgbClr val="1C2430"/>
+                </a:solidFill>
+                <a:latin typeface="Vazir" panose="020B0603030804020204" pitchFamily="34" charset="-78"/>
+                <a:cs typeface="Vazir" panose="020B0603030804020204" pitchFamily="34" charset="-78"/>
+              </a:rPr>
+              <a:t>تأخیر</a:t>
+            </a:r>
+            <a:endParaRPr sz="1300" b="0" dirty="0">
+              <a:solidFill>
+                <a:srgbClr val="1C2430"/>
+              </a:solidFill>
+              <a:latin typeface="Vazir" panose="020B0603030804020204" pitchFamily="34" charset="-78"/>
+              <a:cs typeface="Vazir" panose="020B0603030804020204" pitchFamily="34" charset="-78"/>
+            </a:endParaRPr>
+          </a:p>
+          <a:p>
+            <a:pPr marL="285750" indent="-285750" algn="r" rtl="1">
               <a:spcAft>
                 <a:spcPts val="1100"/>
               </a:spcAft>
+              <a:buFont typeface="Arial" panose="020B0604020202020204" pitchFamily="34" charset="0"/>
+              <a:buChar char="•"/>
             </a:pPr>
             <a:r>
-              <a:rPr sz="1300" b="0">
-                <a:solidFill>
-                  <a:srgbClr val="1C2430"/>
-                </a:solidFill>
-                <a:latin typeface="Vazir" panose="020B0603030804020204" pitchFamily="34" charset="-78"/>
-                <a:cs typeface="Vazir" panose="020B0603030804020204" pitchFamily="34" charset="-78"/>
-              </a:rPr>
-              <a:t>• Re-ID چنددوربینه در چارچوب BoT-SORT</a:t>
-            </a:r>
-          </a:p>
-          <a:p>
-            <a:pPr algn="r" rtl="1">
+              <a:rPr sz="1300" b="0" dirty="0">
+                <a:solidFill>
+                  <a:srgbClr val="1C2430"/>
+                </a:solidFill>
+                <a:latin typeface="Vazir" panose="020B0603030804020204" pitchFamily="34" charset="-78"/>
+                <a:cs typeface="Vazir" panose="020B0603030804020204" pitchFamily="34" charset="-78"/>
+              </a:rPr>
+              <a:t>Re-ID </a:t>
+            </a:r>
+            <a:r>
+              <a:rPr lang="fa-IR" sz="1300" b="0" dirty="0">
+                <a:solidFill>
+                  <a:srgbClr val="1C2430"/>
+                </a:solidFill>
+                <a:latin typeface="Vazir" panose="020B0603030804020204" pitchFamily="34" charset="-78"/>
+                <a:cs typeface="Vazir" panose="020B0603030804020204" pitchFamily="34" charset="-78"/>
+              </a:rPr>
+              <a:t> </a:t>
+            </a:r>
+            <a:r>
+              <a:rPr sz="1300" b="0" dirty="0" err="1">
+                <a:solidFill>
+                  <a:srgbClr val="1C2430"/>
+                </a:solidFill>
+                <a:latin typeface="Vazir" panose="020B0603030804020204" pitchFamily="34" charset="-78"/>
+                <a:cs typeface="Vazir" panose="020B0603030804020204" pitchFamily="34" charset="-78"/>
+              </a:rPr>
+              <a:t>چنددوربینه</a:t>
+            </a:r>
+            <a:r>
+              <a:rPr sz="1300" b="0" dirty="0">
+                <a:solidFill>
+                  <a:srgbClr val="1C2430"/>
+                </a:solidFill>
+                <a:latin typeface="Vazir" panose="020B0603030804020204" pitchFamily="34" charset="-78"/>
+                <a:cs typeface="Vazir" panose="020B0603030804020204" pitchFamily="34" charset="-78"/>
+              </a:rPr>
+              <a:t> </a:t>
+            </a:r>
+            <a:r>
+              <a:rPr sz="1300" b="0" dirty="0" err="1">
+                <a:solidFill>
+                  <a:srgbClr val="1C2430"/>
+                </a:solidFill>
+                <a:latin typeface="Vazir" panose="020B0603030804020204" pitchFamily="34" charset="-78"/>
+                <a:cs typeface="Vazir" panose="020B0603030804020204" pitchFamily="34" charset="-78"/>
+              </a:rPr>
+              <a:t>در</a:t>
+            </a:r>
+            <a:r>
+              <a:rPr sz="1300" b="0" dirty="0">
+                <a:solidFill>
+                  <a:srgbClr val="1C2430"/>
+                </a:solidFill>
+                <a:latin typeface="Vazir" panose="020B0603030804020204" pitchFamily="34" charset="-78"/>
+                <a:cs typeface="Vazir" panose="020B0603030804020204" pitchFamily="34" charset="-78"/>
+              </a:rPr>
+              <a:t> </a:t>
+            </a:r>
+            <a:r>
+              <a:rPr sz="1300" b="0" dirty="0" err="1">
+                <a:solidFill>
+                  <a:srgbClr val="1C2430"/>
+                </a:solidFill>
+                <a:latin typeface="Vazir" panose="020B0603030804020204" pitchFamily="34" charset="-78"/>
+                <a:cs typeface="Vazir" panose="020B0603030804020204" pitchFamily="34" charset="-78"/>
+              </a:rPr>
+              <a:t>چارچوب</a:t>
+            </a:r>
+            <a:r>
+              <a:rPr sz="1300" b="0" dirty="0">
+                <a:solidFill>
+                  <a:srgbClr val="1C2430"/>
+                </a:solidFill>
+                <a:latin typeface="Vazir" panose="020B0603030804020204" pitchFamily="34" charset="-78"/>
+                <a:cs typeface="Vazir" panose="020B0603030804020204" pitchFamily="34" charset="-78"/>
+              </a:rPr>
+              <a:t> </a:t>
+            </a:r>
+            <a:r>
+              <a:rPr sz="1300" b="0" dirty="0" err="1">
+                <a:solidFill>
+                  <a:srgbClr val="1C2430"/>
+                </a:solidFill>
+                <a:latin typeface="Vazir" panose="020B0603030804020204" pitchFamily="34" charset="-78"/>
+                <a:cs typeface="Vazir" panose="020B0603030804020204" pitchFamily="34" charset="-78"/>
+              </a:rPr>
+              <a:t>BoT</a:t>
+            </a:r>
+            <a:r>
+              <a:rPr sz="1300" b="0" dirty="0">
+                <a:solidFill>
+                  <a:srgbClr val="1C2430"/>
+                </a:solidFill>
+                <a:latin typeface="Vazir" panose="020B0603030804020204" pitchFamily="34" charset="-78"/>
+                <a:cs typeface="Vazir" panose="020B0603030804020204" pitchFamily="34" charset="-78"/>
+              </a:rPr>
+              <a:t>-SORT</a:t>
+            </a:r>
+          </a:p>
+          <a:p>
+            <a:pPr marL="285750" indent="-285750" algn="r" rtl="1">
               <a:spcAft>
                 <a:spcPts val="1100"/>
               </a:spcAft>
+              <a:buFont typeface="Arial" panose="020B0604020202020204" pitchFamily="34" charset="0"/>
+              <a:buChar char="•"/>
             </a:pPr>
             <a:r>
-              <a:rPr sz="1300" b="0">
-                <a:solidFill>
-                  <a:srgbClr val="1C2430"/>
-                </a:solidFill>
-                <a:latin typeface="Vazir" panose="020B0603030804020204" pitchFamily="34" charset="-78"/>
-                <a:cs typeface="Vazir" panose="020B0603030804020204" pitchFamily="34" charset="-78"/>
-              </a:rPr>
-              <a:t>• اجرا روی Jetson / Raspberry Pi</a:t>
-            </a:r>
-          </a:p>
-          <a:p>
-            <a:pPr algn="r" rtl="1">
+              <a:rPr sz="1300" b="0" dirty="0" err="1">
+                <a:solidFill>
+                  <a:srgbClr val="1C2430"/>
+                </a:solidFill>
+                <a:latin typeface="Vazir" panose="020B0603030804020204" pitchFamily="34" charset="-78"/>
+                <a:cs typeface="Vazir" panose="020B0603030804020204" pitchFamily="34" charset="-78"/>
+              </a:rPr>
+              <a:t>اجرا</a:t>
+            </a:r>
+            <a:r>
+              <a:rPr sz="1300" b="0" dirty="0">
+                <a:solidFill>
+                  <a:srgbClr val="1C2430"/>
+                </a:solidFill>
+                <a:latin typeface="Vazir" panose="020B0603030804020204" pitchFamily="34" charset="-78"/>
+                <a:cs typeface="Vazir" panose="020B0603030804020204" pitchFamily="34" charset="-78"/>
+              </a:rPr>
+              <a:t> </a:t>
+            </a:r>
+            <a:r>
+              <a:rPr sz="1300" b="0" dirty="0" err="1">
+                <a:solidFill>
+                  <a:srgbClr val="1C2430"/>
+                </a:solidFill>
+                <a:latin typeface="Vazir" panose="020B0603030804020204" pitchFamily="34" charset="-78"/>
+                <a:cs typeface="Vazir" panose="020B0603030804020204" pitchFamily="34" charset="-78"/>
+              </a:rPr>
+              <a:t>روی</a:t>
+            </a:r>
+            <a:r>
+              <a:rPr sz="1300" b="0" dirty="0">
+                <a:solidFill>
+                  <a:srgbClr val="1C2430"/>
+                </a:solidFill>
+                <a:latin typeface="Vazir" panose="020B0603030804020204" pitchFamily="34" charset="-78"/>
+                <a:cs typeface="Vazir" panose="020B0603030804020204" pitchFamily="34" charset="-78"/>
+              </a:rPr>
+              <a:t> Jetson / Raspberry Pi</a:t>
+            </a:r>
+          </a:p>
+          <a:p>
+            <a:pPr marL="285750" indent="-285750" algn="r" rtl="1">
               <a:spcAft>
                 <a:spcPts val="1100"/>
               </a:spcAft>
+              <a:buFont typeface="Arial" panose="020B0604020202020204" pitchFamily="34" charset="0"/>
+              <a:buChar char="•"/>
             </a:pPr>
             <a:r>
-              <a:rPr sz="1300" b="0">
-                <a:solidFill>
-                  <a:srgbClr val="1C2430"/>
-                </a:solidFill>
-                <a:latin typeface="Vazir" panose="020B0603030804020204" pitchFamily="34" charset="-78"/>
-                <a:cs typeface="Vazir" panose="020B0603030804020204" pitchFamily="34" charset="-78"/>
-              </a:rPr>
-              <a:t>• داشبورد تحلیل رفتار و تراکم جمعیت</a:t>
-            </a:r>
+              <a:rPr sz="1300" b="0" dirty="0" err="1">
+                <a:solidFill>
+                  <a:srgbClr val="1C2430"/>
+                </a:solidFill>
+                <a:latin typeface="Vazir" panose="020B0603030804020204" pitchFamily="34" charset="-78"/>
+                <a:cs typeface="Vazir" panose="020B0603030804020204" pitchFamily="34" charset="-78"/>
+              </a:rPr>
+              <a:t>داشبورد</a:t>
+            </a:r>
+            <a:r>
+              <a:rPr sz="1300" b="0" dirty="0">
+                <a:solidFill>
+                  <a:srgbClr val="1C2430"/>
+                </a:solidFill>
+                <a:latin typeface="Vazir" panose="020B0603030804020204" pitchFamily="34" charset="-78"/>
+                <a:cs typeface="Vazir" panose="020B0603030804020204" pitchFamily="34" charset="-78"/>
+              </a:rPr>
+              <a:t> </a:t>
+            </a:r>
+            <a:r>
+              <a:rPr sz="1300" b="0" dirty="0" err="1">
+                <a:solidFill>
+                  <a:srgbClr val="1C2430"/>
+                </a:solidFill>
+                <a:latin typeface="Vazir" panose="020B0603030804020204" pitchFamily="34" charset="-78"/>
+                <a:cs typeface="Vazir" panose="020B0603030804020204" pitchFamily="34" charset="-78"/>
+              </a:rPr>
+              <a:t>تحلیل</a:t>
+            </a:r>
+            <a:r>
+              <a:rPr sz="1300" b="0" dirty="0">
+                <a:solidFill>
+                  <a:srgbClr val="1C2430"/>
+                </a:solidFill>
+                <a:latin typeface="Vazir" panose="020B0603030804020204" pitchFamily="34" charset="-78"/>
+                <a:cs typeface="Vazir" panose="020B0603030804020204" pitchFamily="34" charset="-78"/>
+              </a:rPr>
+              <a:t> </a:t>
+            </a:r>
+            <a:r>
+              <a:rPr sz="1300" b="0" dirty="0" err="1">
+                <a:solidFill>
+                  <a:srgbClr val="1C2430"/>
+                </a:solidFill>
+                <a:latin typeface="Vazir" panose="020B0603030804020204" pitchFamily="34" charset="-78"/>
+                <a:cs typeface="Vazir" panose="020B0603030804020204" pitchFamily="34" charset="-78"/>
+              </a:rPr>
+              <a:t>رفتار</a:t>
+            </a:r>
+            <a:r>
+              <a:rPr sz="1300" b="0" dirty="0">
+                <a:solidFill>
+                  <a:srgbClr val="1C2430"/>
+                </a:solidFill>
+                <a:latin typeface="Vazir" panose="020B0603030804020204" pitchFamily="34" charset="-78"/>
+                <a:cs typeface="Vazir" panose="020B0603030804020204" pitchFamily="34" charset="-78"/>
+              </a:rPr>
+              <a:t> و </a:t>
+            </a:r>
+            <a:r>
+              <a:rPr sz="1300" b="0" dirty="0" err="1">
+                <a:solidFill>
+                  <a:srgbClr val="1C2430"/>
+                </a:solidFill>
+                <a:latin typeface="Vazir" panose="020B0603030804020204" pitchFamily="34" charset="-78"/>
+                <a:cs typeface="Vazir" panose="020B0603030804020204" pitchFamily="34" charset="-78"/>
+              </a:rPr>
+              <a:t>تراکم</a:t>
+            </a:r>
+            <a:r>
+              <a:rPr sz="1300" b="0" dirty="0">
+                <a:solidFill>
+                  <a:srgbClr val="1C2430"/>
+                </a:solidFill>
+                <a:latin typeface="Vazir" panose="020B0603030804020204" pitchFamily="34" charset="-78"/>
+                <a:cs typeface="Vazir" panose="020B0603030804020204" pitchFamily="34" charset="-78"/>
+              </a:rPr>
+              <a:t> </a:t>
+            </a:r>
+            <a:r>
+              <a:rPr sz="1300" b="0" dirty="0" err="1">
+                <a:solidFill>
+                  <a:srgbClr val="1C2430"/>
+                </a:solidFill>
+                <a:latin typeface="Vazir" panose="020B0603030804020204" pitchFamily="34" charset="-78"/>
+                <a:cs typeface="Vazir" panose="020B0603030804020204" pitchFamily="34" charset="-78"/>
+              </a:rPr>
+              <a:t>جمعیت</a:t>
+            </a:r>
+            <a:endParaRPr sz="1300" b="0" dirty="0">
+              <a:solidFill>
+                <a:srgbClr val="1C2430"/>
+              </a:solidFill>
+              <a:latin typeface="Vazir" panose="020B0603030804020204" pitchFamily="34" charset="-78"/>
+              <a:cs typeface="Vazir" panose="020B0603030804020204" pitchFamily="34" charset="-78"/>
+            </a:endParaRPr>
           </a:p>
         </p:txBody>
       </p:sp>
@@ -14501,14 +17243,224 @@
           <a:p>
             <a:pPr algn="r" rtl="1"/>
             <a:r>
-              <a:rPr sz="1300" b="0">
-                <a:solidFill>
-                  <a:srgbClr val="1C2430"/>
-                </a:solidFill>
-                <a:latin typeface="Vazir" panose="020B0603030804020204" pitchFamily="34" charset="-78"/>
-                <a:cs typeface="Vazir" panose="020B0603030804020204" pitchFamily="34" charset="-78"/>
-              </a:rPr>
-              <a:t>تشخیص و ردیابی انسان با YOLO11 به‌همراه لایه اختیاری DeepFace پیاده‌سازی شد.</a:t>
+              <a:rPr sz="1300" b="0" dirty="0" err="1">
+                <a:solidFill>
+                  <a:srgbClr val="1C2430"/>
+                </a:solidFill>
+                <a:latin typeface="Vazir" panose="020B0603030804020204" pitchFamily="34" charset="-78"/>
+                <a:cs typeface="Vazir" panose="020B0603030804020204" pitchFamily="34" charset="-78"/>
+              </a:rPr>
+              <a:t>تشخیص</a:t>
+            </a:r>
+            <a:r>
+              <a:rPr sz="1300" b="0" dirty="0">
+                <a:solidFill>
+                  <a:srgbClr val="1C2430"/>
+                </a:solidFill>
+                <a:latin typeface="Vazir" panose="020B0603030804020204" pitchFamily="34" charset="-78"/>
+                <a:cs typeface="Vazir" panose="020B0603030804020204" pitchFamily="34" charset="-78"/>
+              </a:rPr>
+              <a:t> و </a:t>
+            </a:r>
+            <a:r>
+              <a:rPr sz="1300" b="0" dirty="0" err="1">
+                <a:solidFill>
+                  <a:srgbClr val="1C2430"/>
+                </a:solidFill>
+                <a:latin typeface="Vazir" panose="020B0603030804020204" pitchFamily="34" charset="-78"/>
+                <a:cs typeface="Vazir" panose="020B0603030804020204" pitchFamily="34" charset="-78"/>
+              </a:rPr>
+              <a:t>ردیابی</a:t>
+            </a:r>
+            <a:r>
+              <a:rPr sz="1300" b="0" dirty="0">
+                <a:solidFill>
+                  <a:srgbClr val="1C2430"/>
+                </a:solidFill>
+                <a:latin typeface="Vazir" panose="020B0603030804020204" pitchFamily="34" charset="-78"/>
+                <a:cs typeface="Vazir" panose="020B0603030804020204" pitchFamily="34" charset="-78"/>
+              </a:rPr>
+              <a:t> </a:t>
+            </a:r>
+            <a:r>
+              <a:rPr sz="1300" b="0" dirty="0" err="1">
+                <a:solidFill>
+                  <a:srgbClr val="1C2430"/>
+                </a:solidFill>
+                <a:latin typeface="Vazir" panose="020B0603030804020204" pitchFamily="34" charset="-78"/>
+                <a:cs typeface="Vazir" panose="020B0603030804020204" pitchFamily="34" charset="-78"/>
+              </a:rPr>
+              <a:t>انسان</a:t>
+            </a:r>
+            <a:r>
+              <a:rPr sz="1300" b="0" dirty="0">
+                <a:solidFill>
+                  <a:srgbClr val="1C2430"/>
+                </a:solidFill>
+                <a:latin typeface="Vazir" panose="020B0603030804020204" pitchFamily="34" charset="-78"/>
+                <a:cs typeface="Vazir" panose="020B0603030804020204" pitchFamily="34" charset="-78"/>
+              </a:rPr>
+              <a:t> </a:t>
+            </a:r>
+            <a:r>
+              <a:rPr sz="1300" b="0" dirty="0" err="1">
+                <a:solidFill>
+                  <a:srgbClr val="1C2430"/>
+                </a:solidFill>
+                <a:latin typeface="Vazir" panose="020B0603030804020204" pitchFamily="34" charset="-78"/>
+                <a:cs typeface="Vazir" panose="020B0603030804020204" pitchFamily="34" charset="-78"/>
+              </a:rPr>
+              <a:t>با</a:t>
+            </a:r>
+            <a:r>
+              <a:rPr sz="1300" b="0" dirty="0">
+                <a:solidFill>
+                  <a:srgbClr val="1C2430"/>
+                </a:solidFill>
+                <a:latin typeface="Vazir" panose="020B0603030804020204" pitchFamily="34" charset="-78"/>
+                <a:cs typeface="Vazir" panose="020B0603030804020204" pitchFamily="34" charset="-78"/>
+              </a:rPr>
+              <a:t> YOLO11 </a:t>
+            </a:r>
+            <a:r>
+              <a:rPr lang="fa-IR" sz="1300" b="0" dirty="0">
+                <a:solidFill>
+                  <a:srgbClr val="1C2430"/>
+                </a:solidFill>
+                <a:latin typeface="Vazir" panose="020B0603030804020204" pitchFamily="34" charset="-78"/>
+                <a:cs typeface="Vazir" panose="020B0603030804020204" pitchFamily="34" charset="-78"/>
+              </a:rPr>
+              <a:t> </a:t>
+            </a:r>
+            <a:r>
+              <a:rPr sz="1300" b="0" dirty="0" err="1">
+                <a:solidFill>
+                  <a:srgbClr val="1C2430"/>
+                </a:solidFill>
+                <a:latin typeface="Vazir" panose="020B0603030804020204" pitchFamily="34" charset="-78"/>
+                <a:cs typeface="Vazir" panose="020B0603030804020204" pitchFamily="34" charset="-78"/>
+              </a:rPr>
+              <a:t>به‌همراه</a:t>
+            </a:r>
+            <a:r>
+              <a:rPr sz="1300" b="0" dirty="0">
+                <a:solidFill>
+                  <a:srgbClr val="1C2430"/>
+                </a:solidFill>
+                <a:latin typeface="Vazir" panose="020B0603030804020204" pitchFamily="34" charset="-78"/>
+                <a:cs typeface="Vazir" panose="020B0603030804020204" pitchFamily="34" charset="-78"/>
+              </a:rPr>
+              <a:t> </a:t>
+            </a:r>
+            <a:r>
+              <a:rPr sz="1300" b="0" dirty="0" err="1">
+                <a:solidFill>
+                  <a:srgbClr val="1C2430"/>
+                </a:solidFill>
+                <a:latin typeface="Vazir" panose="020B0603030804020204" pitchFamily="34" charset="-78"/>
+                <a:cs typeface="Vazir" panose="020B0603030804020204" pitchFamily="34" charset="-78"/>
+              </a:rPr>
+              <a:t>لایه</a:t>
+            </a:r>
+            <a:r>
+              <a:rPr sz="1300" b="0" dirty="0">
+                <a:solidFill>
+                  <a:srgbClr val="1C2430"/>
+                </a:solidFill>
+                <a:latin typeface="Vazir" panose="020B0603030804020204" pitchFamily="34" charset="-78"/>
+                <a:cs typeface="Vazir" panose="020B0603030804020204" pitchFamily="34" charset="-78"/>
+              </a:rPr>
+              <a:t> </a:t>
+            </a:r>
+            <a:r>
+              <a:rPr sz="1300" b="0" dirty="0" err="1">
+                <a:solidFill>
+                  <a:srgbClr val="1C2430"/>
+                </a:solidFill>
+                <a:latin typeface="Vazir" panose="020B0603030804020204" pitchFamily="34" charset="-78"/>
+                <a:cs typeface="Vazir" panose="020B0603030804020204" pitchFamily="34" charset="-78"/>
+              </a:rPr>
+              <a:t>اختیاری</a:t>
+            </a:r>
+            <a:r>
+              <a:rPr sz="1300" b="0" dirty="0">
+                <a:solidFill>
+                  <a:srgbClr val="1C2430"/>
+                </a:solidFill>
+                <a:latin typeface="Vazir" panose="020B0603030804020204" pitchFamily="34" charset="-78"/>
+                <a:cs typeface="Vazir" panose="020B0603030804020204" pitchFamily="34" charset="-78"/>
+              </a:rPr>
+              <a:t> </a:t>
+            </a:r>
+            <a:r>
+              <a:rPr sz="1300" b="0" dirty="0" err="1">
+                <a:solidFill>
+                  <a:srgbClr val="1C2430"/>
+                </a:solidFill>
+                <a:latin typeface="Vazir" panose="020B0603030804020204" pitchFamily="34" charset="-78"/>
+                <a:cs typeface="Vazir" panose="020B0603030804020204" pitchFamily="34" charset="-78"/>
+              </a:rPr>
+              <a:t>DeepFace</a:t>
+            </a:r>
+            <a:r>
+              <a:rPr sz="1300" b="0" dirty="0">
+                <a:solidFill>
+                  <a:srgbClr val="1C2430"/>
+                </a:solidFill>
+                <a:latin typeface="Vazir" panose="020B0603030804020204" pitchFamily="34" charset="-78"/>
+                <a:cs typeface="Vazir" panose="020B0603030804020204" pitchFamily="34" charset="-78"/>
+              </a:rPr>
+              <a:t> </a:t>
+            </a:r>
+            <a:r>
+              <a:rPr lang="fa-IR" sz="1300" b="0" dirty="0">
+                <a:solidFill>
+                  <a:srgbClr val="1C2430"/>
+                </a:solidFill>
+                <a:latin typeface="Vazir" panose="020B0603030804020204" pitchFamily="34" charset="-78"/>
+                <a:cs typeface="Vazir" panose="020B0603030804020204" pitchFamily="34" charset="-78"/>
+              </a:rPr>
+              <a:t> </a:t>
+            </a:r>
+            <a:r>
+              <a:rPr sz="1300" b="0" dirty="0" err="1">
+                <a:solidFill>
+                  <a:srgbClr val="1C2430"/>
+                </a:solidFill>
+                <a:latin typeface="Vazir" panose="020B0603030804020204" pitchFamily="34" charset="-78"/>
+                <a:cs typeface="Vazir" panose="020B0603030804020204" pitchFamily="34" charset="-78"/>
+              </a:rPr>
+              <a:t>پیاده‌سازی</a:t>
+            </a:r>
+            <a:r>
+              <a:rPr sz="1300" b="0" dirty="0">
+                <a:solidFill>
+                  <a:srgbClr val="1C2430"/>
+                </a:solidFill>
+                <a:latin typeface="Vazir" panose="020B0603030804020204" pitchFamily="34" charset="-78"/>
+                <a:cs typeface="Vazir" panose="020B0603030804020204" pitchFamily="34" charset="-78"/>
+              </a:rPr>
+              <a:t> </a:t>
+            </a:r>
+            <a:r>
+              <a:rPr sz="1300" b="0" dirty="0" err="1">
+                <a:solidFill>
+                  <a:srgbClr val="1C2430"/>
+                </a:solidFill>
+                <a:latin typeface="Vazir" panose="020B0603030804020204" pitchFamily="34" charset="-78"/>
+                <a:cs typeface="Vazir" panose="020B0603030804020204" pitchFamily="34" charset="-78"/>
+              </a:rPr>
+              <a:t>شد</a:t>
+            </a:r>
+            <a:r>
+              <a:rPr sz="1300" b="0" dirty="0">
+                <a:solidFill>
+                  <a:srgbClr val="1C2430"/>
+                </a:solidFill>
+                <a:latin typeface="Vazir" panose="020B0603030804020204" pitchFamily="34" charset="-78"/>
+                <a:cs typeface="Vazir" panose="020B0603030804020204" pitchFamily="34" charset="-78"/>
+              </a:rPr>
+              <a:t>.</a:t>
             </a:r>
           </a:p>
         </p:txBody>
@@ -14661,14 +17613,104 @@
           <a:p>
             <a:pPr algn="r" rtl="1"/>
             <a:r>
-              <a:rPr sz="1300" b="0">
-                <a:solidFill>
-                  <a:srgbClr val="1C2430"/>
-                </a:solidFill>
-                <a:latin typeface="Vazir" panose="020B0603030804020204" pitchFamily="34" charset="-78"/>
-                <a:cs typeface="Vazir" panose="020B0603030804020204" pitchFamily="34" charset="-78"/>
-              </a:rPr>
-              <a:t>روی CrowdHuman: بهترین mAP50 = ۰٫۵۸۵ و mAP50-95 = ۰٫۳۳۴.</a:t>
+              <a:rPr sz="1300" b="0" dirty="0" err="1">
+                <a:solidFill>
+                  <a:srgbClr val="1C2430"/>
+                </a:solidFill>
+                <a:latin typeface="Vazir" panose="020B0603030804020204" pitchFamily="34" charset="-78"/>
+                <a:cs typeface="Vazir" panose="020B0603030804020204" pitchFamily="34" charset="-78"/>
+              </a:rPr>
+              <a:t>روی</a:t>
+            </a:r>
+            <a:r>
+              <a:rPr sz="1300" b="0" dirty="0">
+                <a:solidFill>
+                  <a:srgbClr val="1C2430"/>
+                </a:solidFill>
+                <a:latin typeface="Vazir" panose="020B0603030804020204" pitchFamily="34" charset="-78"/>
+                <a:cs typeface="Vazir" panose="020B0603030804020204" pitchFamily="34" charset="-78"/>
+              </a:rPr>
+              <a:t> </a:t>
+            </a:r>
+            <a:r>
+              <a:rPr sz="1300" b="0" dirty="0" err="1">
+                <a:solidFill>
+                  <a:srgbClr val="1C2430"/>
+                </a:solidFill>
+                <a:latin typeface="Vazir" panose="020B0603030804020204" pitchFamily="34" charset="-78"/>
+                <a:cs typeface="Vazir" panose="020B0603030804020204" pitchFamily="34" charset="-78"/>
+              </a:rPr>
+              <a:t>CrowdHuman</a:t>
+            </a:r>
+            <a:r>
+              <a:rPr lang="fa-IR" sz="1300" dirty="0">
+                <a:solidFill>
+                  <a:srgbClr val="1C2430"/>
+                </a:solidFill>
+                <a:latin typeface="Vazir" panose="020B0603030804020204" pitchFamily="34" charset="-78"/>
+                <a:cs typeface="Vazir" panose="020B0603030804020204" pitchFamily="34" charset="-78"/>
+              </a:rPr>
+              <a:t>: </a:t>
+            </a:r>
+            <a:r>
+              <a:rPr sz="1300" b="0" dirty="0" err="1">
+                <a:solidFill>
+                  <a:srgbClr val="1C2430"/>
+                </a:solidFill>
+                <a:latin typeface="Vazir" panose="020B0603030804020204" pitchFamily="34" charset="-78"/>
+                <a:cs typeface="Vazir" panose="020B0603030804020204" pitchFamily="34" charset="-78"/>
+              </a:rPr>
+              <a:t>بهترین</a:t>
+            </a:r>
+            <a:r>
+              <a:rPr sz="1300" b="0" dirty="0">
+                <a:solidFill>
+                  <a:srgbClr val="1C2430"/>
+                </a:solidFill>
+                <a:latin typeface="Vazir" panose="020B0603030804020204" pitchFamily="34" charset="-78"/>
+                <a:cs typeface="Vazir" panose="020B0603030804020204" pitchFamily="34" charset="-78"/>
+              </a:rPr>
+              <a:t> mAP50 </a:t>
+            </a:r>
+            <a:r>
+              <a:rPr lang="fa-IR" sz="1300" dirty="0">
+                <a:solidFill>
+                  <a:srgbClr val="1C2430"/>
+                </a:solidFill>
+                <a:latin typeface="Vazir" panose="020B0603030804020204" pitchFamily="34" charset="-78"/>
+                <a:cs typeface="Vazir" panose="020B0603030804020204" pitchFamily="34" charset="-78"/>
+              </a:rPr>
+              <a:t> =</a:t>
+            </a:r>
+            <a:r>
+              <a:rPr sz="1300" b="0" dirty="0">
+                <a:solidFill>
+                  <a:srgbClr val="1C2430"/>
+                </a:solidFill>
+                <a:latin typeface="Vazir" panose="020B0603030804020204" pitchFamily="34" charset="-78"/>
+                <a:cs typeface="Vazir" panose="020B0603030804020204" pitchFamily="34" charset="-78"/>
+              </a:rPr>
+              <a:t>۰٫۵۸۵ و mAP50-95 </a:t>
+            </a:r>
+            <a:r>
+              <a:rPr lang="fa-IR" sz="1300" b="0" dirty="0">
+                <a:solidFill>
+                  <a:srgbClr val="1C2430"/>
+                </a:solidFill>
+                <a:latin typeface="Vazir" panose="020B0603030804020204" pitchFamily="34" charset="-78"/>
+                <a:cs typeface="Vazir" panose="020B0603030804020204" pitchFamily="34" charset="-78"/>
+              </a:rPr>
+              <a:t> = </a:t>
+            </a:r>
+            <a:r>
+              <a:rPr sz="1300" b="0" dirty="0">
+                <a:solidFill>
+                  <a:srgbClr val="1C2430"/>
+                </a:solidFill>
+                <a:latin typeface="Vazir" panose="020B0603030804020204" pitchFamily="34" charset="-78"/>
+                <a:cs typeface="Vazir" panose="020B0603030804020204" pitchFamily="34" charset="-78"/>
+              </a:rPr>
+              <a:t>۰٫۳۳۴.</a:t>
             </a:r>
           </a:p>
         </p:txBody>
@@ -14821,15 +17863,162 @@
           <a:p>
             <a:pPr algn="r" rtl="1"/>
             <a:r>
-              <a:rPr sz="1300" b="0">
-                <a:solidFill>
-                  <a:srgbClr val="1C2430"/>
-                </a:solidFill>
-                <a:latin typeface="Vazir" panose="020B0603030804020204" pitchFamily="34" charset="-78"/>
-                <a:cs typeface="Vazir" panose="020B0603030804020204" pitchFamily="34" charset="-78"/>
-              </a:rPr>
-              <a:t>YOLO11 بدون anchor است؛ hyperparameterها برای دفاع مستند شده‌اند.</a:t>
-            </a:r>
+              <a:rPr sz="1300" b="0" dirty="0">
+                <a:solidFill>
+                  <a:srgbClr val="1C2430"/>
+                </a:solidFill>
+                <a:latin typeface="Vazir" panose="020B0603030804020204" pitchFamily="34" charset="-78"/>
+                <a:cs typeface="Vazir" panose="020B0603030804020204" pitchFamily="34" charset="-78"/>
+              </a:rPr>
+              <a:t>YOLO11 </a:t>
+            </a:r>
+            <a:r>
+              <a:rPr sz="1300" b="0" dirty="0" err="1">
+                <a:solidFill>
+                  <a:srgbClr val="1C2430"/>
+                </a:solidFill>
+                <a:latin typeface="Vazir" panose="020B0603030804020204" pitchFamily="34" charset="-78"/>
+                <a:cs typeface="Vazir" panose="020B0603030804020204" pitchFamily="34" charset="-78"/>
+              </a:rPr>
+              <a:t>بدون</a:t>
+            </a:r>
+            <a:r>
+              <a:rPr sz="1300" b="0" dirty="0">
+                <a:solidFill>
+                  <a:srgbClr val="1C2430"/>
+                </a:solidFill>
+                <a:latin typeface="Vazir" panose="020B0603030804020204" pitchFamily="34" charset="-78"/>
+                <a:cs typeface="Vazir" panose="020B0603030804020204" pitchFamily="34" charset="-78"/>
+              </a:rPr>
+              <a:t> anchor </a:t>
+            </a:r>
+            <a:r>
+              <a:rPr lang="fa-IR" sz="1300" b="0" dirty="0">
+                <a:solidFill>
+                  <a:srgbClr val="1C2430"/>
+                </a:solidFill>
+                <a:latin typeface="Vazir" panose="020B0603030804020204" pitchFamily="34" charset="-78"/>
+                <a:cs typeface="Vazir" panose="020B0603030804020204" pitchFamily="34" charset="-78"/>
+              </a:rPr>
+              <a:t> </a:t>
+            </a:r>
+            <a:r>
+              <a:rPr sz="1300" b="0" dirty="0" err="1">
+                <a:solidFill>
+                  <a:srgbClr val="1C2430"/>
+                </a:solidFill>
+                <a:latin typeface="Vazir" panose="020B0603030804020204" pitchFamily="34" charset="-78"/>
+                <a:cs typeface="Vazir" panose="020B0603030804020204" pitchFamily="34" charset="-78"/>
+              </a:rPr>
+              <a:t>است</a:t>
+            </a:r>
+            <a:r>
+              <a:rPr sz="1300" b="0" dirty="0">
+                <a:solidFill>
+                  <a:srgbClr val="1C2430"/>
+                </a:solidFill>
+                <a:latin typeface="Vazir" panose="020B0603030804020204" pitchFamily="34" charset="-78"/>
+                <a:cs typeface="Vazir" panose="020B0603030804020204" pitchFamily="34" charset="-78"/>
+              </a:rPr>
+              <a:t>؛ hyperparameter</a:t>
+            </a:r>
+            <a:r>
+              <a:rPr lang="fa-IR" sz="1300" b="0" dirty="0">
+                <a:solidFill>
+                  <a:srgbClr val="1C2430"/>
+                </a:solidFill>
+                <a:latin typeface="Vazir" panose="020B0603030804020204" pitchFamily="34" charset="-78"/>
+                <a:cs typeface="Vazir" panose="020B0603030804020204" pitchFamily="34" charset="-78"/>
+              </a:rPr>
+              <a:t> </a:t>
+            </a:r>
+            <a:r>
+              <a:rPr sz="1300" b="0" dirty="0" err="1">
+                <a:solidFill>
+                  <a:srgbClr val="1C2430"/>
+                </a:solidFill>
+                <a:latin typeface="Vazir" panose="020B0603030804020204" pitchFamily="34" charset="-78"/>
+                <a:cs typeface="Vazir" panose="020B0603030804020204" pitchFamily="34" charset="-78"/>
+              </a:rPr>
+              <a:t>ها</a:t>
+            </a:r>
+            <a:r>
+              <a:rPr sz="1300" b="0" dirty="0">
+                <a:solidFill>
+                  <a:srgbClr val="1C2430"/>
+                </a:solidFill>
+                <a:latin typeface="Vazir" panose="020B0603030804020204" pitchFamily="34" charset="-78"/>
+                <a:cs typeface="Vazir" panose="020B0603030804020204" pitchFamily="34" charset="-78"/>
+              </a:rPr>
+              <a:t> </a:t>
+            </a:r>
+            <a:r>
+              <a:rPr sz="1300" b="0" dirty="0" err="1">
+                <a:solidFill>
+                  <a:srgbClr val="1C2430"/>
+                </a:solidFill>
+                <a:latin typeface="Vazir" panose="020B0603030804020204" pitchFamily="34" charset="-78"/>
+                <a:cs typeface="Vazir" panose="020B0603030804020204" pitchFamily="34" charset="-78"/>
+              </a:rPr>
+              <a:t>برای</a:t>
+            </a:r>
+            <a:r>
+              <a:rPr lang="fa-IR" sz="1300" b="0" dirty="0">
+                <a:solidFill>
+                  <a:srgbClr val="1C2430"/>
+                </a:solidFill>
+                <a:latin typeface="Vazir" panose="020B0603030804020204" pitchFamily="34" charset="-78"/>
+                <a:cs typeface="Vazir" panose="020B0603030804020204" pitchFamily="34" charset="-78"/>
+              </a:rPr>
+              <a:t> </a:t>
+            </a:r>
+            <a:r>
+              <a:rPr lang="fa-IR" sz="1300" dirty="0">
+                <a:solidFill>
+                  <a:srgbClr val="1C2430"/>
+                </a:solidFill>
+                <a:latin typeface="Vazir" panose="020B0603030804020204" pitchFamily="34" charset="-78"/>
+                <a:cs typeface="Vazir" panose="020B0603030804020204" pitchFamily="34" charset="-78"/>
+              </a:rPr>
+              <a:t>مشاهده </a:t>
+            </a:r>
+            <a:r>
+              <a:rPr lang="fa-IR" sz="1300" b="0" dirty="0">
+                <a:solidFill>
+                  <a:srgbClr val="1C2430"/>
+                </a:solidFill>
+                <a:latin typeface="Vazir" panose="020B0603030804020204" pitchFamily="34" charset="-78"/>
+                <a:cs typeface="Vazir" panose="020B0603030804020204" pitchFamily="34" charset="-78"/>
+              </a:rPr>
+              <a:t>مستند </a:t>
+            </a:r>
+            <a:r>
+              <a:rPr lang="fa-IR" sz="1300" b="0" dirty="0" err="1">
+                <a:solidFill>
+                  <a:srgbClr val="1C2430"/>
+                </a:solidFill>
+                <a:latin typeface="Vazir" panose="020B0603030804020204" pitchFamily="34" charset="-78"/>
+                <a:cs typeface="Vazir" panose="020B0603030804020204" pitchFamily="34" charset="-78"/>
+              </a:rPr>
+              <a:t>شده‌اند</a:t>
+            </a:r>
+            <a:r>
+              <a:rPr lang="en-US" sz="1300" b="0" dirty="0">
+                <a:solidFill>
+                  <a:srgbClr val="1C2430"/>
+                </a:solidFill>
+                <a:latin typeface="Vazir" panose="020B0603030804020204" pitchFamily="34" charset="-78"/>
+                <a:cs typeface="Vazir" panose="020B0603030804020204" pitchFamily="34" charset="-78"/>
+              </a:rPr>
+              <a:t>.</a:t>
+            </a:r>
+            <a:endParaRPr sz="1300" b="0" dirty="0">
+              <a:solidFill>
+                <a:srgbClr val="1C2430"/>
+              </a:solidFill>
+              <a:latin typeface="Vazir" panose="020B0603030804020204" pitchFamily="34" charset="-78"/>
+              <a:cs typeface="Vazir" panose="020B0603030804020204" pitchFamily="34" charset="-78"/>
+            </a:endParaRPr>
           </a:p>
         </p:txBody>
       </p:sp>
@@ -15141,6 +18330,136 @@
           <a:p>
             <a:pPr algn="r" rtl="1"/>
             <a:r>
+              <a:rPr sz="1300" b="0" dirty="0" err="1">
+                <a:solidFill>
+                  <a:srgbClr val="1C2430"/>
+                </a:solidFill>
+                <a:latin typeface="Vazir" panose="020B0603030804020204" pitchFamily="34" charset="-78"/>
+                <a:cs typeface="Vazir" panose="020B0603030804020204" pitchFamily="34" charset="-78"/>
+              </a:rPr>
+              <a:t>تشخیص</a:t>
+            </a:r>
+            <a:r>
+              <a:rPr sz="1300" b="0" dirty="0">
+                <a:solidFill>
+                  <a:srgbClr val="1C2430"/>
+                </a:solidFill>
+                <a:latin typeface="Vazir" panose="020B0603030804020204" pitchFamily="34" charset="-78"/>
+                <a:cs typeface="Vazir" panose="020B0603030804020204" pitchFamily="34" charset="-78"/>
+              </a:rPr>
+              <a:t>، </a:t>
+            </a:r>
+            <a:r>
+              <a:rPr sz="1300" b="0" dirty="0" err="1">
+                <a:solidFill>
+                  <a:srgbClr val="1C2430"/>
+                </a:solidFill>
+                <a:latin typeface="Vazir" panose="020B0603030804020204" pitchFamily="34" charset="-78"/>
+                <a:cs typeface="Vazir" panose="020B0603030804020204" pitchFamily="34" charset="-78"/>
+              </a:rPr>
+              <a:t>ردیابی</a:t>
+            </a:r>
+            <a:r>
+              <a:rPr sz="1300" b="0" dirty="0">
+                <a:solidFill>
+                  <a:srgbClr val="1C2430"/>
+                </a:solidFill>
+                <a:latin typeface="Vazir" panose="020B0603030804020204" pitchFamily="34" charset="-78"/>
+                <a:cs typeface="Vazir" panose="020B0603030804020204" pitchFamily="34" charset="-78"/>
+              </a:rPr>
+              <a:t>، </a:t>
+            </a:r>
+            <a:r>
+              <a:rPr sz="1300" b="0" dirty="0" err="1">
+                <a:solidFill>
+                  <a:srgbClr val="1C2430"/>
+                </a:solidFill>
+                <a:latin typeface="Vazir" panose="020B0603030804020204" pitchFamily="34" charset="-78"/>
+                <a:cs typeface="Vazir" panose="020B0603030804020204" pitchFamily="34" charset="-78"/>
+              </a:rPr>
+              <a:t>چهره</a:t>
+            </a:r>
+            <a:r>
+              <a:rPr sz="1300" b="0" dirty="0">
+                <a:solidFill>
+                  <a:srgbClr val="1C2430"/>
+                </a:solidFill>
+                <a:latin typeface="Vazir" panose="020B0603030804020204" pitchFamily="34" charset="-78"/>
+                <a:cs typeface="Vazir" panose="020B0603030804020204" pitchFamily="34" charset="-78"/>
+              </a:rPr>
+              <a:t>، </a:t>
+            </a:r>
+            <a:r>
+              <a:rPr sz="1300" b="0" dirty="0" err="1">
+                <a:solidFill>
+                  <a:srgbClr val="1C2430"/>
+                </a:solidFill>
+                <a:latin typeface="Vazir" panose="020B0603030804020204" pitchFamily="34" charset="-78"/>
+                <a:cs typeface="Vazir" panose="020B0603030804020204" pitchFamily="34" charset="-78"/>
+              </a:rPr>
+              <a:t>وب</a:t>
+            </a:r>
+            <a:r>
+              <a:rPr sz="1300" b="0" dirty="0">
+                <a:solidFill>
+                  <a:srgbClr val="1C2430"/>
+                </a:solidFill>
+                <a:latin typeface="Vazir" panose="020B0603030804020204" pitchFamily="34" charset="-78"/>
+                <a:cs typeface="Vazir" panose="020B0603030804020204" pitchFamily="34" charset="-78"/>
+              </a:rPr>
+              <a:t>، </a:t>
+            </a:r>
+            <a:r>
+              <a:rPr sz="1300" b="0" dirty="0" err="1">
+                <a:solidFill>
+                  <a:srgbClr val="1C2430"/>
+                </a:solidFill>
+                <a:latin typeface="Vazir" panose="020B0603030804020204" pitchFamily="34" charset="-78"/>
+                <a:cs typeface="Vazir" panose="020B0603030804020204" pitchFamily="34" charset="-78"/>
+              </a:rPr>
+              <a:t>آموزش</a:t>
+            </a:r>
+            <a:r>
+              <a:rPr sz="1300" b="0" dirty="0">
+                <a:solidFill>
+                  <a:srgbClr val="1C2430"/>
+                </a:solidFill>
+                <a:latin typeface="Vazir" panose="020B0603030804020204" pitchFamily="34" charset="-78"/>
+                <a:cs typeface="Vazir" panose="020B0603030804020204" pitchFamily="34" charset="-78"/>
+              </a:rPr>
+              <a:t> و </a:t>
+            </a:r>
+            <a:r>
+              <a:rPr sz="1300" b="0" dirty="0" err="1">
+                <a:solidFill>
+                  <a:srgbClr val="1C2430"/>
+                </a:solidFill>
+                <a:latin typeface="Vazir" panose="020B0603030804020204" pitchFamily="34" charset="-78"/>
+                <a:cs typeface="Vazir" panose="020B0603030804020204" pitchFamily="34" charset="-78"/>
+              </a:rPr>
+              <a:t>مستندسازی</a:t>
+            </a:r>
+            <a:r>
+              <a:rPr sz="1300" b="0" dirty="0">
+                <a:solidFill>
+                  <a:srgbClr val="1C2430"/>
+                </a:solidFill>
+                <a:latin typeface="Vazir" panose="020B0603030804020204" pitchFamily="34" charset="-78"/>
+                <a:cs typeface="Vazir" panose="020B0603030804020204" pitchFamily="34" charset="-78"/>
+              </a:rPr>
+              <a:t> – </a:t>
+            </a:r>
+            <a:r>
+              <a:rPr lang="fa-IR" sz="1300" b="0">
+                <a:solidFill>
+                  <a:srgbClr val="1C2430"/>
+                </a:solidFill>
+                <a:latin typeface="Vazir" panose="020B0603030804020204" pitchFamily="34" charset="-78"/>
+                <a:cs typeface="Vazir" panose="020B0603030804020204" pitchFamily="34" charset="-78"/>
+              </a:rPr>
+              <a:t> </a:t>
+            </a:r>
+            <a:r>
               <a:rPr sz="1300" b="0">
                 <a:solidFill>
                   <a:srgbClr val="1C2430"/>
@@ -15148,7 +18467,57 @@
                 <a:latin typeface="Vazir" panose="020B0603030804020204" pitchFamily="34" charset="-78"/>
                 <a:cs typeface="Vazir" panose="020B0603030804020204" pitchFamily="34" charset="-78"/>
               </a:rPr>
-              <a:t>تشخیص، ردیابی، چهره، وب، آموزش و مستندسازی – همگی محقق شدند.</a:t>
+              <a:t>همگی</a:t>
+            </a:r>
+            <a:r>
+              <a:rPr sz="1300" b="0" dirty="0">
+                <a:solidFill>
+                  <a:srgbClr val="1C2430"/>
+                </a:solidFill>
+                <a:latin typeface="Vazir" panose="020B0603030804020204" pitchFamily="34" charset="-78"/>
+                <a:cs typeface="Vazir" panose="020B0603030804020204" pitchFamily="34" charset="-78"/>
+              </a:rPr>
+              <a:t> </a:t>
+            </a:r>
+            <a:r>
+              <a:rPr sz="1300" b="0" dirty="0" err="1">
+                <a:solidFill>
+                  <a:srgbClr val="1C2430"/>
+                </a:solidFill>
+                <a:latin typeface="Vazir" panose="020B0603030804020204" pitchFamily="34" charset="-78"/>
+                <a:cs typeface="Vazir" panose="020B0603030804020204" pitchFamily="34" charset="-78"/>
+              </a:rPr>
+              <a:t>محقق</a:t>
+            </a:r>
+            <a:r>
+              <a:rPr sz="1300" b="0" dirty="0">
+                <a:solidFill>
+                  <a:srgbClr val="1C2430"/>
+                </a:solidFill>
+                <a:latin typeface="Vazir" panose="020B0603030804020204" pitchFamily="34" charset="-78"/>
+                <a:cs typeface="Vazir" panose="020B0603030804020204" pitchFamily="34" charset="-78"/>
+              </a:rPr>
+              <a:t> </a:t>
+            </a:r>
+            <a:r>
+              <a:rPr sz="1300" b="0" dirty="0" err="1">
+                <a:solidFill>
+                  <a:srgbClr val="1C2430"/>
+                </a:solidFill>
+                <a:latin typeface="Vazir" panose="020B0603030804020204" pitchFamily="34" charset="-78"/>
+                <a:cs typeface="Vazir" panose="020B0603030804020204" pitchFamily="34" charset="-78"/>
+              </a:rPr>
+              <a:t>شدند</a:t>
+            </a:r>
+            <a:r>
+              <a:rPr sz="1300" b="0" dirty="0">
+                <a:solidFill>
+                  <a:srgbClr val="1C2430"/>
+                </a:solidFill>
+                <a:latin typeface="Vazir" panose="020B0603030804020204" pitchFamily="34" charset="-78"/>
+                <a:cs typeface="Vazir" panose="020B0603030804020204" pitchFamily="34" charset="-78"/>
+              </a:rPr>
+              <a:t>.</a:t>
             </a:r>
           </a:p>
         </p:txBody>

</xml_diff>

<commit_message>
Update face match threshold in configuration and documentation
- Reduced face match threshold in .env.example, app/config.py, and face-recognition.md from 0.4 to 0.22 for improved accuracy in face recognition.
- Updated README.md and training-reference.md to reflect the new default threshold value and its implications for matching accuracy.
- Removed outdated entries in training-reference.md for clarity.
</commit_message>
<xml_diff>
--- a/docs/thesis/Defense_Presentation_YOLO11.pptx
+++ b/docs/thesis/Defense_Presentation_YOLO11.pptx
@@ -18450,7 +18450,7 @@
               <a:t> – </a:t>
             </a:r>
             <a:r>
-              <a:rPr lang="fa-IR" sz="1300" b="0">
+              <a:rPr lang="fa-IR" sz="1300" b="0" dirty="0">
                 <a:solidFill>
                   <a:srgbClr val="1C2430"/>
                 </a:solidFill>
@@ -18460,7 +18460,7 @@
               <a:t> </a:t>
             </a:r>
             <a:r>
-              <a:rPr sz="1300" b="0">
+              <a:rPr sz="1300" b="0" dirty="0" err="1">
                 <a:solidFill>
                   <a:srgbClr val="1C2430"/>
                 </a:solidFill>

</xml_diff>

<commit_message>
Update Defense Presentation with latest findings and improvements
</commit_message>
<xml_diff>
--- a/docs/thesis/Defense_Presentation_YOLO11.pptx
+++ b/docs/thesis/Defense_Presentation_YOLO11.pptx
@@ -19989,15 +19989,62 @@
           <a:p>
             <a:pPr algn="r" rtl="1"/>
             <a:r>
-              <a:rPr sz="1700" b="1">
+              <a:rPr sz="1700" b="1" dirty="0" err="1">
                 <a:solidFill>
                   <a:srgbClr val="0B1F3A"/>
                 </a:solidFill>
                 <a:latin typeface="Vazir" panose="020B0603030804020204" pitchFamily="34" charset="-78"/>
                 <a:cs typeface="Vazir" panose="020B0603030804020204" pitchFamily="34" charset="-78"/>
               </a:rPr>
-              <a:t>تعادل دقت–سرعت</a:t>
-            </a:r>
+              <a:t>تعادل</a:t>
+            </a:r>
+            <a:r>
+              <a:rPr sz="1700" b="1" dirty="0">
+                <a:solidFill>
+                  <a:srgbClr val="0B1F3A"/>
+                </a:solidFill>
+                <a:latin typeface="Vazir" panose="020B0603030804020204" pitchFamily="34" charset="-78"/>
+                <a:cs typeface="Vazir" panose="020B0603030804020204" pitchFamily="34" charset="-78"/>
+              </a:rPr>
+              <a:t> </a:t>
+            </a:r>
+            <a:r>
+              <a:rPr sz="1700" b="1" dirty="0" err="1">
+                <a:solidFill>
+                  <a:srgbClr val="0B1F3A"/>
+                </a:solidFill>
+                <a:latin typeface="Vazir" panose="020B0603030804020204" pitchFamily="34" charset="-78"/>
+                <a:cs typeface="Vazir" panose="020B0603030804020204" pitchFamily="34" charset="-78"/>
+              </a:rPr>
+              <a:t>دقت</a:t>
+            </a:r>
+            <a:r>
+              <a:rPr sz="1700" b="1" dirty="0">
+                <a:solidFill>
+                  <a:srgbClr val="0B1F3A"/>
+                </a:solidFill>
+                <a:latin typeface="Vazir" panose="020B0603030804020204" pitchFamily="34" charset="-78"/>
+                <a:cs typeface="Vazir" panose="020B0603030804020204" pitchFamily="34" charset="-78"/>
+              </a:rPr>
+              <a:t>–</a:t>
+            </a:r>
+            <a:r>
+              <a:rPr sz="1700" b="1" dirty="0" err="1">
+                <a:solidFill>
+                  <a:srgbClr val="0B1F3A"/>
+                </a:solidFill>
+                <a:latin typeface="Vazir" panose="020B0603030804020204" pitchFamily="34" charset="-78"/>
+                <a:cs typeface="Vazir" panose="020B0603030804020204" pitchFamily="34" charset="-78"/>
+              </a:rPr>
+              <a:t>سرعت</a:t>
+            </a:r>
+            <a:endParaRPr sz="1700" b="1" dirty="0">
+              <a:solidFill>
+                <a:srgbClr val="0B1F3A"/>
+              </a:solidFill>
+              <a:latin typeface="Vazir" panose="020B0603030804020204" pitchFamily="34" charset="-78"/>
+              <a:cs typeface="Vazir" panose="020B0603030804020204" pitchFamily="34" charset="-78"/>
+            </a:endParaRPr>
           </a:p>
         </p:txBody>
       </p:sp>
@@ -23133,15 +23180,42 @@
           <a:p>
             <a:pPr algn="r" rtl="1"/>
             <a:r>
-              <a:rPr sz="2200" b="1">
+              <a:rPr lang="fa-IR" sz="2200" b="1" dirty="0">
                 <a:solidFill>
                   <a:srgbClr val="FFFFFF"/>
                 </a:solidFill>
                 <a:latin typeface="Vazir" panose="020B0603030804020204" pitchFamily="34" charset="-78"/>
                 <a:cs typeface="Vazir" panose="020B0603030804020204" pitchFamily="34" charset="-78"/>
               </a:rPr>
-              <a:t>چرا YOLO11 + مرور روش‌ها</a:t>
-            </a:r>
+              <a:t>چرا</a:t>
+            </a:r>
+            <a:r>
+              <a:rPr lang="en-US" sz="2200" b="1" dirty="0">
+                <a:solidFill>
+                  <a:srgbClr val="FFFFFF"/>
+                </a:solidFill>
+                <a:latin typeface="Vazir" panose="020B0603030804020204" pitchFamily="34" charset="-78"/>
+                <a:cs typeface="Vazir" panose="020B0603030804020204" pitchFamily="34" charset="-78"/>
+              </a:rPr>
+              <a:t> Yolo11</a:t>
+            </a:r>
+            <a:r>
+              <a:rPr lang="fa-IR" sz="2200" b="1">
+                <a:solidFill>
+                  <a:srgbClr val="FFFFFF"/>
+                </a:solidFill>
+                <a:latin typeface="Vazir" panose="020B0603030804020204" pitchFamily="34" charset="-78"/>
+                <a:cs typeface="Vazir" panose="020B0603030804020204" pitchFamily="34" charset="-78"/>
+              </a:rPr>
+              <a:t> + مرور روش ها</a:t>
+            </a:r>
+            <a:endParaRPr lang="fa-IR" sz="2200" b="1" dirty="0">
+              <a:solidFill>
+                <a:srgbClr val="FFFFFF"/>
+              </a:solidFill>
+              <a:latin typeface="Vazir" panose="020B0603030804020204" pitchFamily="34" charset="-78"/>
+              <a:cs typeface="Vazir" panose="020B0603030804020204" pitchFamily="34" charset="-78"/>
+            </a:endParaRPr>
           </a:p>
         </p:txBody>
       </p:sp>

</xml_diff>

<commit_message>
Update Defense Presentation with new content and enhancements
</commit_message>
<xml_diff>
--- a/docs/thesis/Defense_Presentation_YOLO11.pptx
+++ b/docs/thesis/Defense_Presentation_YOLO11.pptx
@@ -23200,7 +23200,7 @@
               <a:t> Yolo11</a:t>
             </a:r>
             <a:r>
-              <a:rPr lang="fa-IR" sz="2200" b="1">
+              <a:rPr lang="fa-IR" sz="2200" b="1" dirty="0">
                 <a:solidFill>
                   <a:srgbClr val="FFFFFF"/>
                 </a:solidFill>
@@ -23209,13 +23209,6 @@
               </a:rPr>
               <a:t> + مرور روش ها</a:t>
             </a:r>
-            <a:endParaRPr lang="fa-IR" sz="2200" b="1" dirty="0">
-              <a:solidFill>
-                <a:srgbClr val="FFFFFF"/>
-              </a:solidFill>
-              <a:latin typeface="Vazir" panose="020B0603030804020204" pitchFamily="34" charset="-78"/>
-              <a:cs typeface="Vazir" panose="020B0603030804020204" pitchFamily="34" charset="-78"/>
-            </a:endParaRPr>
           </a:p>
         </p:txBody>
       </p:sp>
@@ -24340,7 +24333,7 @@
         <p:spPr>
           <a:xfrm>
             <a:off x="548640" y="1600200"/>
-            <a:ext cx="3383280" cy="1741502"/>
+            <a:ext cx="3383280" cy="1161857"/>
           </a:xfrm>
           <a:prstGeom prst="rect">
             <a:avLst/>
@@ -24352,30 +24345,6 @@
             <a:spAutoFit/>
           </a:bodyPr>
           <a:lstStyle/>
-          <a:p>
-            <a:pPr rtl="1">
-              <a:spcAft>
-                <a:spcPts val="700"/>
-              </a:spcAft>
-            </a:pPr>
-            <a:r>
-              <a:rPr sz="1300" b="0" dirty="0">
-                <a:solidFill>
-                  <a:srgbClr val="1C2430"/>
-                </a:solidFill>
-                <a:latin typeface="Vazir" panose="020B0603030804020204" pitchFamily="34" charset="-78"/>
-                <a:cs typeface="Vazir" panose="020B0603030804020204" pitchFamily="34" charset="-78"/>
-              </a:rPr>
-              <a:t>Embedding</a:t>
-            </a:r>
-            <a:endParaRPr lang="fa-IR" sz="1300" b="0" dirty="0">
-              <a:solidFill>
-                <a:srgbClr val="1C2430"/>
-              </a:solidFill>
-              <a:latin typeface="Vazir" panose="020B0603030804020204" pitchFamily="34" charset="-78"/>
-              <a:cs typeface="Vazir" panose="020B0603030804020204" pitchFamily="34" charset="-78"/>
-            </a:endParaRPr>
-          </a:p>
           <a:p>
             <a:pPr algn="r" rtl="1">
               <a:spcAft>
@@ -24383,6 +24352,16 @@
               </a:spcAft>
             </a:pPr>
             <a:r>
+              <a:rPr sz="1300" b="0" dirty="0">
+                <a:solidFill>
+                  <a:srgbClr val="1C2430"/>
+                </a:solidFill>
+                <a:latin typeface="Vazir" panose="020B0603030804020204" pitchFamily="34" charset="-78"/>
+                <a:cs typeface="Vazir" panose="020B0603030804020204" pitchFamily="34" charset="-78"/>
+              </a:rPr>
+              <a:t>Embedding</a:t>
+            </a:r>
+            <a:r>
               <a:rPr lang="fa-IR" sz="1300" b="0" dirty="0" err="1">
                 <a:solidFill>
                   <a:srgbClr val="1C2430"/>
@@ -24412,30 +24391,6 @@
               </a:rPr>
               <a:t>Facenet512</a:t>
             </a:r>
-          </a:p>
-          <a:p>
-            <a:pPr rtl="1">
-              <a:spcAft>
-                <a:spcPts val="700"/>
-              </a:spcAft>
-            </a:pPr>
-            <a:r>
-              <a:rPr sz="1300" b="0" dirty="0" err="1">
-                <a:solidFill>
-                  <a:srgbClr val="1C2430"/>
-                </a:solidFill>
-                <a:latin typeface="Vazir" panose="020B0603030804020204" pitchFamily="34" charset="-78"/>
-                <a:cs typeface="Vazir" panose="020B0603030804020204" pitchFamily="34" charset="-78"/>
-              </a:rPr>
-              <a:t>DeepFace</a:t>
-            </a:r>
-            <a:endParaRPr lang="fa-IR" sz="1300" b="0" dirty="0">
-              <a:solidFill>
-                <a:srgbClr val="1C2430"/>
-              </a:solidFill>
-              <a:latin typeface="Vazir" panose="020B0603030804020204" pitchFamily="34" charset="-78"/>
-              <a:cs typeface="Vazir" panose="020B0603030804020204" pitchFamily="34" charset="-78"/>
-            </a:endParaRPr>
           </a:p>
           <a:p>
             <a:pPr algn="r" rtl="1">
@@ -24443,6 +24398,26 @@
                 <a:spcPts val="700"/>
               </a:spcAft>
             </a:pPr>
+            <a:r>
+              <a:rPr sz="1300" b="0" dirty="0" err="1">
+                <a:solidFill>
+                  <a:srgbClr val="1C2430"/>
+                </a:solidFill>
+                <a:latin typeface="Vazir" panose="020B0603030804020204" pitchFamily="34" charset="-78"/>
+                <a:cs typeface="Vazir" panose="020B0603030804020204" pitchFamily="34" charset="-78"/>
+              </a:rPr>
+              <a:t>DeepFace</a:t>
+            </a:r>
+            <a:r>
+              <a:rPr lang="fa-IR" sz="1300" b="0" dirty="0">
+                <a:solidFill>
+                  <a:srgbClr val="1C2430"/>
+                </a:solidFill>
+                <a:latin typeface="Vazir" panose="020B0603030804020204" pitchFamily="34" charset="-78"/>
+                <a:cs typeface="Vazir" panose="020B0603030804020204" pitchFamily="34" charset="-78"/>
+              </a:rPr>
+              <a:t> </a:t>
+            </a:r>
             <a:r>
               <a:rPr sz="1300" b="0" dirty="0">
                 <a:solidFill>
@@ -26665,15 +26640,72 @@
           <a:p>
             <a:pPr algn="r" rtl="1"/>
             <a:r>
-              <a:rPr sz="1500" b="1">
+              <a:rPr sz="1500" b="1" dirty="0" err="1">
                 <a:solidFill>
                   <a:srgbClr val="0B1F3A"/>
                 </a:solidFill>
                 <a:latin typeface="Vazir" panose="020B0603030804020204" pitchFamily="34" charset="-78"/>
                 <a:cs typeface="Vazir" panose="020B0603030804020204" pitchFamily="34" charset="-78"/>
               </a:rPr>
-              <a:t>لایه تشخیص / ردیابی</a:t>
-            </a:r>
+              <a:t>لایه</a:t>
+            </a:r>
+            <a:r>
+              <a:rPr sz="1500" b="1" dirty="0">
+                <a:solidFill>
+                  <a:srgbClr val="0B1F3A"/>
+                </a:solidFill>
+                <a:latin typeface="Vazir" panose="020B0603030804020204" pitchFamily="34" charset="-78"/>
+                <a:cs typeface="Vazir" panose="020B0603030804020204" pitchFamily="34" charset="-78"/>
+              </a:rPr>
+              <a:t> </a:t>
+            </a:r>
+            <a:r>
+              <a:rPr sz="1500" b="1" dirty="0" err="1">
+                <a:solidFill>
+                  <a:srgbClr val="0B1F3A"/>
+                </a:solidFill>
+                <a:latin typeface="Vazir" panose="020B0603030804020204" pitchFamily="34" charset="-78"/>
+                <a:cs typeface="Vazir" panose="020B0603030804020204" pitchFamily="34" charset="-78"/>
+              </a:rPr>
+              <a:t>تشخیص</a:t>
+            </a:r>
+            <a:r>
+              <a:rPr sz="1500" b="1" dirty="0">
+                <a:solidFill>
+                  <a:srgbClr val="0B1F3A"/>
+                </a:solidFill>
+                <a:latin typeface="Vazir" panose="020B0603030804020204" pitchFamily="34" charset="-78"/>
+                <a:cs typeface="Vazir" panose="020B0603030804020204" pitchFamily="34" charset="-78"/>
+              </a:rPr>
+              <a:t>/ </a:t>
+            </a:r>
+            <a:r>
+              <a:rPr lang="fa-IR" sz="1500" b="1" dirty="0">
+                <a:solidFill>
+                  <a:srgbClr val="0B1F3A"/>
+                </a:solidFill>
+                <a:latin typeface="Vazir" panose="020B0603030804020204" pitchFamily="34" charset="-78"/>
+                <a:cs typeface="Vazir" panose="020B0603030804020204" pitchFamily="34" charset="-78"/>
+              </a:rPr>
+              <a:t> </a:t>
+            </a:r>
+            <a:r>
+              <a:rPr sz="1500" b="1" dirty="0" err="1">
+                <a:solidFill>
+                  <a:srgbClr val="0B1F3A"/>
+                </a:solidFill>
+                <a:latin typeface="Vazir" panose="020B0603030804020204" pitchFamily="34" charset="-78"/>
+                <a:cs typeface="Vazir" panose="020B0603030804020204" pitchFamily="34" charset="-78"/>
+              </a:rPr>
+              <a:t>ردیابی</a:t>
+            </a:r>
+            <a:endParaRPr sz="1500" b="1" dirty="0">
+              <a:solidFill>
+                <a:srgbClr val="0B1F3A"/>
+              </a:solidFill>
+              <a:latin typeface="Vazir" panose="020B0603030804020204" pitchFamily="34" charset="-78"/>
+              <a:cs typeface="Vazir" panose="020B0603030804020204" pitchFamily="34" charset="-78"/>
+            </a:endParaRPr>
           </a:p>
         </p:txBody>
       </p:sp>
@@ -27438,6 +27470,56 @@
           <a:p>
             <a:pPr algn="r" rtl="1"/>
             <a:r>
+              <a:rPr sz="1500" b="1" dirty="0" err="1">
+                <a:solidFill>
+                  <a:srgbClr val="0B1F3A"/>
+                </a:solidFill>
+                <a:latin typeface="Vazir" panose="020B0603030804020204" pitchFamily="34" charset="-78"/>
+                <a:cs typeface="Vazir" panose="020B0603030804020204" pitchFamily="34" charset="-78"/>
+              </a:rPr>
+              <a:t>رابط</a:t>
+            </a:r>
+            <a:r>
+              <a:rPr sz="1500" b="1" dirty="0">
+                <a:solidFill>
+                  <a:srgbClr val="0B1F3A"/>
+                </a:solidFill>
+                <a:latin typeface="Vazir" panose="020B0603030804020204" pitchFamily="34" charset="-78"/>
+                <a:cs typeface="Vazir" panose="020B0603030804020204" pitchFamily="34" charset="-78"/>
+              </a:rPr>
+              <a:t> </a:t>
+            </a:r>
+            <a:r>
+              <a:rPr sz="1500" b="1" dirty="0" err="1">
+                <a:solidFill>
+                  <a:srgbClr val="0B1F3A"/>
+                </a:solidFill>
+                <a:latin typeface="Vazir" panose="020B0603030804020204" pitchFamily="34" charset="-78"/>
+                <a:cs typeface="Vazir" panose="020B0603030804020204" pitchFamily="34" charset="-78"/>
+              </a:rPr>
+              <a:t>وب</a:t>
+            </a:r>
+            <a:r>
+              <a:rPr sz="1500" b="1" dirty="0">
+                <a:solidFill>
+                  <a:srgbClr val="0B1F3A"/>
+                </a:solidFill>
+                <a:latin typeface="Vazir" panose="020B0603030804020204" pitchFamily="34" charset="-78"/>
+                <a:cs typeface="Vazir" panose="020B0603030804020204" pitchFamily="34" charset="-78"/>
+              </a:rPr>
+              <a:t>+ </a:t>
+            </a:r>
+            <a:r>
+              <a:rPr lang="fa-IR" sz="1500" b="1">
+                <a:solidFill>
+                  <a:srgbClr val="0B1F3A"/>
+                </a:solidFill>
+                <a:latin typeface="Vazir" panose="020B0603030804020204" pitchFamily="34" charset="-78"/>
+                <a:cs typeface="Vazir" panose="020B0603030804020204" pitchFamily="34" charset="-78"/>
+              </a:rPr>
+              <a:t> </a:t>
+            </a:r>
+            <a:r>
               <a:rPr sz="1500" b="1">
                 <a:solidFill>
                   <a:srgbClr val="0B1F3A"/>
@@ -27445,8 +27527,35 @@
                 <a:latin typeface="Vazir" panose="020B0603030804020204" pitchFamily="34" charset="-78"/>
                 <a:cs typeface="Vazir" panose="020B0603030804020204" pitchFamily="34" charset="-78"/>
               </a:rPr>
-              <a:t>رابط وب + مدل پایه</a:t>
-            </a:r>
+              <a:t>مدل</a:t>
+            </a:r>
+            <a:r>
+              <a:rPr sz="1500" b="1" dirty="0">
+                <a:solidFill>
+                  <a:srgbClr val="0B1F3A"/>
+                </a:solidFill>
+                <a:latin typeface="Vazir" panose="020B0603030804020204" pitchFamily="34" charset="-78"/>
+                <a:cs typeface="Vazir" panose="020B0603030804020204" pitchFamily="34" charset="-78"/>
+              </a:rPr>
+              <a:t> </a:t>
+            </a:r>
+            <a:r>
+              <a:rPr sz="1500" b="1" dirty="0" err="1">
+                <a:solidFill>
+                  <a:srgbClr val="0B1F3A"/>
+                </a:solidFill>
+                <a:latin typeface="Vazir" panose="020B0603030804020204" pitchFamily="34" charset="-78"/>
+                <a:cs typeface="Vazir" panose="020B0603030804020204" pitchFamily="34" charset="-78"/>
+              </a:rPr>
+              <a:t>پایه</a:t>
+            </a:r>
+            <a:endParaRPr sz="1500" b="1" dirty="0">
+              <a:solidFill>
+                <a:srgbClr val="0B1F3A"/>
+              </a:solidFill>
+              <a:latin typeface="Vazir" panose="020B0603030804020204" pitchFamily="34" charset="-78"/>
+              <a:cs typeface="Vazir" panose="020B0603030804020204" pitchFamily="34" charset="-78"/>
+            </a:endParaRPr>
           </a:p>
         </p:txBody>
       </p:sp>

</xml_diff>